<commit_message>
docs: pitch deck v4 with square corners, personas and business model
Co-Authored-By: Claude Fable 5.1 <noreply@anthropic.com>
</commit_message>
<xml_diff>
--- a/pitch/ROCHADE_Pitch.pptx
+++ b/pitch/ROCHADE_Pitch.pptx
@@ -116,7 +116,7 @@
   <p:extLst>
     <p:ext uri="{521415D9-36F7-43E2-AB2F-B90AF26B5E84}">
       <p14:sectionLst xmlns:p14="http://schemas.microsoft.com/office/powerpoint/2010/main">
-        <p14:section name="Pitch" id="{097eca3b-366a-f7f3-4773-9e53589ec8d4}">
+        <p14:section name="Pitch" id="{872131a1-06cb-533c-b4db-540381dcd525}">
           <p14:sldIdLst>
             <p14:sldId id="256"/>
             <p14:sldId id="257"/>
@@ -971,7 +971,7 @@
           <a:p>
             <a:r>
               <a:rPr lang="en-US" dirty="0"/>
-              <a:t>[0:15–0:40] Das ist kein Einzelfall. 2018 bis 2022 wurden in der Schweiz 10'900 Mehrfamilienhäuser komplett leergekündigt, knapp 30'000 Menschen pro Jahr. 1'270 Häuser allein in der Stadt Zürich, Basel 380, Genf mit seinen strengen Regeln rund 100. Jedes vierte geleerte Haus in Zürich gehörte einer Genossenschaft, also genau denen, die niemanden rauswerfen wollen. Und die Angst ist da: 84 Prozent der Zürcher Mietenden sorgen sich deswegen, bei den über 55-Jährigen 91 Prozent. Die Umfrage hat der Mieterverband bezahlt, die Zahl der ZKB nicht.</a:t>
+              <a:t>[0:15–0:40] Das ist kein Einzelfall. 2018 bis 2022 wurden in der Schweiz 10'900 Mehrfamilienhäuser komplett leergekündigt, knapp 30'000 Menschen pro Jahr. 1'270 Häuser allein in der Stadt Zürich, Basel 380, Genf mit seinen strengen Regeln rund 100. Jedes vierte geleerte Haus in Zürich gehörte einer Genossenschaft, also genau denen, die niemanden rauswerfen wollen. Und die Angst ist da: 84 Prozent der Zürcher Mietenden sorgen sich deswegen, bei den über 55-Jährigen 91 Prozent. Die Umfrage hat der Mieterverband bezahlt, die Zahlen der ZKB nicht.</a:t>
             </a:r>
             <a:endParaRPr lang="en-US" dirty="0"/>
           </a:p>
@@ -1059,7 +1059,7 @@
           <a:p>
             <a:r>
               <a:rPr lang="en-US" dirty="0"/>
-              <a:t>[0:40–1:00] Wer raus muss, findet bei 0,11 Prozent Leerstand nichts, zahlt im Neubau rund 30 Prozent mehr, und jede dritte Person muss die Gemeinde verlassen. Die Fachstelle Zürich im Alter schätzt, dass jede zehnte Altersheim-Anmeldung eine Kündigung oder Sanierung als Grund hat. Und für Eigentümer ist es ein Risiko: Bei den Sugus-Häusern haben sich rund 100 Haushalte gewehrt, Schlichtungsbehörde und Mietgericht haben die Kündigungen für ungültig erklärt. Ein Jahr Stillstand, Schlagzeilen, Anwälte.</a:t>
+              <a:t>[0:40–1:05] Drei Menschen. Rosa Meier bekommt den Brief, findet bei 0,11 Prozent Leerstand nichts, zahlt im Neubau 30 Prozent mehr; jede dritte Gekündigte muss die Gemeinde verlassen. Sandra Keller soll 49 Mietparteien durch drei Etappen schieben, in Excel, mit vierfachem Aufwand, und wenn der Bau sich verschiebt, fängt sie von vorne an. Und Reto Huber im Vorstand weiss seit den Sugus-Häusern, was eine Leerkündigung kostet: Schlichtungsbehörde, Schlagzeilen, ein Jahr Stillstand. Zürich verlangt von ihm neu den Nachweis, dass es nicht anders geht. Er ist unser Kunde.</a:t>
             </a:r>
             <a:endParaRPr lang="en-US" dirty="0"/>
           </a:p>
@@ -1147,7 +1147,7 @@
           <a:p>
             <a:r>
               <a:rPr lang="en-US" dirty="0"/>
-              <a:t>[1:00–1:25] Es geht anders: die Rochade. Frau Meier zieht für fünf Monate in eine freie Wohnung in der Siedlung, ihre eigene wird saniert, dann kommt sie zurück. Ihr Mietvertrag bleibt die ganze Zeit bestehen. Die Uni Zürich hat zwölf Eigentümer und Genossenschaften befragt: Rochaden sind die mit Abstand effektivste Massnahme, aber «enorm aufwändig». Die Genossenschaft bgnzwo macht es gerade in Höngg mit 49 Mietparteien und hat den vierfachen Aufwand, weil alles von Hand geplant wird. Darum machen es viele nicht.</a:t>
+              <a:t>[1:05–1:25] Es geht anders: die Rochade. Frau Meier zieht für fünf Monate in eine freie Wohnung in der Siedlung, ihre eigene wird saniert, dann kommt sie zurück. Ihr Mietvertrag bleibt die ganze Zeit bestehen. Die Uni Zürich hat zwölf Eigentümer und Genossenschaften befragt: Rochaden sind die mit Abstand effektivste Massnahme, aber «enorm aufwändig». Flächen finden, zuteilen, zwei Übergaben pro Haushalt, und jede Bauverschiebung wirft den Plan um. Darum machen es viele nicht, und kündigen.</a:t>
             </a:r>
             <a:endParaRPr lang="en-US" dirty="0"/>
           </a:p>
@@ -1411,7 +1411,7 @@
           <a:p>
             <a:r>
               <a:rPr lang="en-US" dirty="0"/>
-              <a:t>[2:20–2:50] Darum bauen wir ROCHADE. Die Verwaltung sieht die ganze Siedlung: Haus A wird saniert, die acht Haushalte sitzen in freien Wohnungen von Haus B, Haus C und zwei externen. Die Bewohnenden sehen auf dem Handy nur, was sie betrifft: Auszug, Wohnung, Rückkehr. Ändert die Verwaltung einen Termin, ist er in unter einer Sekunde auf dem Handy. Das ist die Information, die das Zürcher Gesetz verlangt und die Mietenden brauchen, um freiwillig Ja zu sagen.</a:t>
+              <a:t>[2:20–2:50] Darum bauen wir ROCHADE. Die Verwaltung sieht die ganze Siedlung: Haus A wird saniert, die acht Haushalte sitzen in freien Wohnungen von Haus B, Haus C und zwei externen. Vier Regeln werden nie gebrochen: Zimmerzahl, Hindernisfreiheit, Zeitfenster, keine Doppelbelegung. Verzögert sich Etappe 1 um zwei Monate, sagt ROCHADE: 11 Konflikte. Für Hr. Aydin fehlt ab Juni 2027 eine 2,5-Zimmer-Wohnung. Etappe 2 ab November 2027 löst alles, ein Klick; in Excel wäre das ein Wochenende. Die Bewohnenden sehen auf dem Handy nur, was sie betrifft: Auszug, Wohnung, Rückkehr, live.</a:t>
             </a:r>
             <a:endParaRPr lang="en-US" dirty="0"/>
           </a:p>
@@ -1499,7 +1499,7 @@
           <a:p>
             <a:r>
               <a:rPr lang="en-US" dirty="0"/>
-              <a:t>[2:50–3:10] Vier Regeln, die nie gebrochen werden: Zimmerzahl, Hindernisfreiheit, Zeitfenster, keine Doppelbelegung. Verzögert sich Etappe 1 um zwei Monate, sagt ROCHADE: 11 Konflikte. Für Hr. Aydin fehlt ab Juni 2027 eine 2,5-Zimmer-Wohnung. Und: Etappe 2 ab November 2027 löst alles. Ein Klick. In Excel wäre das ein Wochenende.</a:t>
+              <a:t>[2:50–3:15] Wie verdienen wir Geld? Die Eigentümerschaft zahlt, pro Sanierungsprojekt: ein Promille der Sanierungssumme, mindestens 5'000 Franken. Bei 10 Millionen sind das 10'000 Franken, inklusive Bewohner-App und Live-Updates. Das Nachweis-Dossier für das Baugesuch ist drin, in Zürich ab 20 Mietverhältnissen Pflicht, das ist unser Türöffner. Später ein Abo für Pensionskassen und grosse Genossenschaften mit mehreren Sanierungen im Jahr. Für den Kunden rechnet es sich sofort: Eine Leerkündigung von 24 Wohnungen kostet sechs Monate Mietzinsausfall, rund 216'000 Franken, die Rochade hält die Mieten am Laufen. Unsere Kosten pro Projekt liegen bei rund 2'000 Franken, die Fixkosten im ersten Jahr bei 120'000. Mit zwölf Projekten sind wir kostendeckend, danach rund 80 Prozent Marge. Alles Annahmen, die wir in den Pilotgesprächen prüfen.</a:t>
             </a:r>
             <a:endParaRPr lang="en-US" dirty="0"/>
           </a:p>
@@ -1587,7 +1587,7 @@
           <a:p>
             <a:r>
               <a:rPr lang="en-US" dirty="0"/>
-              <a:t>[3:10–3:40] Bezahlt wird pro Sanierungsprojekt von der Eigentümerschaft: ein Promille der Sanierungssumme, mindestens 5'000 Franken. Bei 10 Millionen sind das 10'000 Franken, eine Woche Bauverzögerung kostet mehr. Mit zwölf Projekten im Jahr sind wir kostendeckend; das sind Annahmen für die Pilotgespräche. Der Markt: 58'100 gemeinnützige Wohnungen allein in Zürich, über eine Million sanierungsbedürftige Gebäude in der Schweiz. Konkurrenz: Garaio, Abacus und Rimo kennen Verträge, emonitor und Flatfox die Vermietung. Die Rochade plant niemand, ausser Excel von Hand. Wir starten 2027 mit zwei Pilot-Genossenschaften, gratis gegen echte Daten, dann über die Verbände. Unser Hebel ist die Zürcher Prüfpflicht.</a:t>
+              <a:t>[3:15–3:40] Der Markt: Über 2'000 Häuser werden in der Schweiz jedes Jahr komplett leergekündigt, über eine Million Gebäude sind sanierungsbedürftig. Wir starten in Zürich, bei den Genossenschaften: 58'100 Wohnungen, sie dürfen nicht kündigen und sanieren ohnehin in Etappen. 2027 zwei Pilot-Genossenschaften, gratis gegen echte Daten, dann über die Verbände; unser Hebel ist die Zürcher Prüfpflicht. Konkurrenz: Garaio, Abacus und Rimo kennen Verträge, emonitor und Flatfox die Vermietung. Die Rochade plant niemand, ausser Excel, von Hand.</a:t>
             </a:r>
             <a:endParaRPr lang="en-US" dirty="0"/>
           </a:p>
@@ -2838,10 +2838,8 @@
             <a:off x="457200" y="2743200"/>
             <a:ext cx="2651760" cy="868680"/>
           </a:xfrm>
-          <a:prstGeom prst="roundRect">
-            <a:avLst>
-              <a:gd name="adj" fmla="val 14737"/>
-            </a:avLst>
+          <a:prstGeom prst="rect">
+            <a:avLst/>
           </a:prstGeom>
           <a:solidFill>
             <a:srgbClr val="2F525C"/>
@@ -2943,10 +2941,8 @@
             <a:off x="3246120" y="2743200"/>
             <a:ext cx="2651760" cy="868680"/>
           </a:xfrm>
-          <a:prstGeom prst="roundRect">
-            <a:avLst>
-              <a:gd name="adj" fmla="val 14737"/>
-            </a:avLst>
+          <a:prstGeom prst="rect">
+            <a:avLst/>
           </a:prstGeom>
           <a:solidFill>
             <a:srgbClr val="2F525C"/>
@@ -3048,10 +3044,8 @@
             <a:off x="6035040" y="2743200"/>
             <a:ext cx="2651760" cy="868680"/>
           </a:xfrm>
-          <a:prstGeom prst="roundRect">
-            <a:avLst>
-              <a:gd name="adj" fmla="val 14737"/>
-            </a:avLst>
+          <a:prstGeom prst="rect">
+            <a:avLst/>
           </a:prstGeom>
           <a:solidFill>
             <a:srgbClr val="2F525C"/>
@@ -3324,10 +3318,8 @@
             <a:off x="457200" y="1280160"/>
             <a:ext cx="3383280" cy="3291840"/>
           </a:xfrm>
-          <a:prstGeom prst="roundRect">
-            <a:avLst>
-              <a:gd name="adj" fmla="val 3889"/>
-            </a:avLst>
+          <a:prstGeom prst="rect">
+            <a:avLst/>
           </a:prstGeom>
           <a:solidFill>
             <a:srgbClr val="24414A"/>
@@ -3640,10 +3632,8 @@
             <a:off x="4023360" y="4160520"/>
             <a:ext cx="4663440" cy="457200"/>
           </a:xfrm>
-          <a:prstGeom prst="roundRect">
-            <a:avLst>
-              <a:gd name="adj" fmla="val 28000"/>
-            </a:avLst>
+          <a:prstGeom prst="rect">
+            <a:avLst/>
           </a:prstGeom>
           <a:solidFill>
             <a:srgbClr val="FDEBDD"/>
@@ -3836,7 +3826,7 @@
                   <a:schemeClr val="tx1"/>
                 </a:solidFill>
               </a:rPr>
-              <a:t>Wer raus muss, findet nichts, zahlt mehr, verliert das Quartier.</a:t>
+              <a:t>Drei Menschen, drei Probleme. Einer davon zahlt.</a:t>
             </a:r>
             <a:endParaRPr lang="en-US" sz="3000" dirty="0"/>
           </a:p>
@@ -3851,12 +3841,10 @@
         <p:spPr>
           <a:xfrm>
             <a:off x="457200" y="1280160"/>
-            <a:ext cx="2651760" cy="2240280"/>
-          </a:xfrm>
-          <a:prstGeom prst="roundRect">
-            <a:avLst>
-              <a:gd name="adj" fmla="val 5714"/>
-            </a:avLst>
+            <a:ext cx="2651760" cy="3291840"/>
+          </a:xfrm>
+          <a:prstGeom prst="rect">
+            <a:avLst/>
           </a:prstGeom>
           <a:solidFill>
             <a:srgbClr val="FFFFFF"/>
@@ -3871,14 +3859,39 @@
       </p:sp>
       <p:sp>
         <p:nvSpPr>
-          <p:cNvPr id="4" name="Text 2"/>
-          <p:cNvSpPr txBox="1"/>
-          <p:nvPr/>
-        </p:nvSpPr>
-        <p:spPr>
-          <a:xfrm>
-            <a:off x="685800" y="1426464"/>
-            <a:ext cx="2194560" cy="857250"/>
+          <p:cNvPr id="4" name="Shape 2"/>
+          <p:cNvSpPr/>
+          <p:nvPr/>
+        </p:nvSpPr>
+        <p:spPr>
+          <a:xfrm>
+            <a:off x="640080" y="1463040"/>
+            <a:ext cx="457200" cy="457200"/>
+          </a:xfrm>
+          <a:prstGeom prst="rect">
+            <a:avLst/>
+          </a:prstGeom>
+          <a:solidFill>
+            <a:srgbClr val="24414A"/>
+          </a:solidFill>
+          <a:ln w="12700">
+            <a:solidFill>
+              <a:srgbClr val="24414A"/>
+            </a:solidFill>
+            <a:prstDash val="solid"/>
+          </a:ln>
+        </p:spPr>
+      </p:sp>
+      <p:sp>
+        <p:nvSpPr>
+          <p:cNvPr id="5" name="Text 3"/>
+          <p:cNvSpPr txBox="1"/>
+          <p:nvPr/>
+        </p:nvSpPr>
+        <p:spPr>
+          <a:xfrm>
+            <a:off x="640080" y="1463040"/>
+            <a:ext cx="457200" cy="457200"/>
           </a:xfrm>
           <a:prstGeom prst="rect">
             <a:avLst/>
@@ -3890,11 +3903,50 @@
           <a:bodyPr wrap="square" lIns="0" tIns="0" rIns="0" bIns="0" rtlCol="0" anchor="ctr"/>
           <a:lstStyle/>
           <a:p>
+            <a:pPr algn="ctr" indent="0" marL="0">
+              <a:buNone/>
+            </a:pPr>
+            <a:r>
+              <a:rPr lang="en-US" sz="1400" b="1" dirty="0">
+                <a:solidFill>
+                  <a:srgbClr val="FFFFFF"/>
+                </a:solidFill>
+                <a:latin typeface="Arial" pitchFamily="34" charset="0"/>
+                <a:ea typeface="Arial" pitchFamily="34" charset="-122"/>
+                <a:cs typeface="Arial" pitchFamily="34" charset="-120"/>
+              </a:rPr>
+              <a:t>RM</a:t>
+            </a:r>
+            <a:endParaRPr lang="en-US" sz="1400" dirty="0"/>
+          </a:p>
+        </p:txBody>
+      </p:sp>
+      <p:sp>
+        <p:nvSpPr>
+          <p:cNvPr id="6" name="Text 4"/>
+          <p:cNvSpPr txBox="1"/>
+          <p:nvPr/>
+        </p:nvSpPr>
+        <p:spPr>
+          <a:xfrm>
+            <a:off x="1234440" y="1444752"/>
+            <a:ext cx="1737360" cy="256032"/>
+          </a:xfrm>
+          <a:prstGeom prst="rect">
+            <a:avLst/>
+          </a:prstGeom>
+          <a:noFill/>
+          <a:ln/>
+        </p:spPr>
+        <p:txBody>
+          <a:bodyPr wrap="square" lIns="0" tIns="0" rIns="0" bIns="0" rtlCol="0" anchor="ctr"/>
+          <a:lstStyle/>
+          <a:p>
             <a:pPr indent="0" marL="0">
               <a:buNone/>
             </a:pPr>
             <a:r>
-              <a:rPr lang="en-US" sz="5400" b="1" dirty="0">
+              <a:rPr lang="en-US" sz="1300" b="1" dirty="0">
                 <a:solidFill>
                   <a:srgbClr val="1C2326"/>
                 </a:solidFill>
@@ -3902,22 +3954,22 @@
                 <a:ea typeface="Arial" pitchFamily="34" charset="-122"/>
                 <a:cs typeface="Arial" pitchFamily="34" charset="-120"/>
               </a:rPr>
-              <a:t>0,11 %</a:t>
-            </a:r>
-            <a:endParaRPr lang="en-US" sz="5400" dirty="0"/>
-          </a:p>
-        </p:txBody>
-      </p:sp>
-      <p:sp>
-        <p:nvSpPr>
-          <p:cNvPr id="5" name="Text 3"/>
-          <p:cNvSpPr txBox="1"/>
-          <p:nvPr/>
-        </p:nvSpPr>
-        <p:spPr>
-          <a:xfrm>
-            <a:off x="685800" y="2320290"/>
-            <a:ext cx="2194560" cy="816102"/>
+              <a:t>Rosa Meier, 78</a:t>
+            </a:r>
+            <a:endParaRPr lang="en-US" sz="1300" dirty="0"/>
+          </a:p>
+        </p:txBody>
+      </p:sp>
+      <p:sp>
+        <p:nvSpPr>
+          <p:cNvPr id="7" name="Text 5"/>
+          <p:cNvSpPr txBox="1"/>
+          <p:nvPr/>
+        </p:nvSpPr>
+        <p:spPr>
+          <a:xfrm>
+            <a:off x="1234440" y="1700784"/>
+            <a:ext cx="1737360" cy="365760"/>
           </a:xfrm>
           <a:prstGeom prst="rect">
             <a:avLst/>
@@ -3933,7 +3985,46 @@
               <a:buNone/>
             </a:pPr>
             <a:r>
-              <a:rPr lang="en-US" sz="1400" dirty="0">
+              <a:rPr lang="en-US" sz="850" dirty="0">
+                <a:solidFill>
+                  <a:srgbClr val="5B6468"/>
+                </a:solidFill>
+                <a:latin typeface="Arial" pitchFamily="34" charset="0"/>
+                <a:ea typeface="Arial" pitchFamily="34" charset="-122"/>
+                <a:cs typeface="Arial" pitchFamily="34" charset="-120"/>
+              </a:rPr>
+              <a:t>Bewohnerin seit 1994, Höngg</a:t>
+            </a:r>
+            <a:endParaRPr lang="en-US" sz="850" dirty="0"/>
+          </a:p>
+        </p:txBody>
+      </p:sp>
+      <p:sp>
+        <p:nvSpPr>
+          <p:cNvPr id="8" name="Text 6"/>
+          <p:cNvSpPr txBox="1"/>
+          <p:nvPr/>
+        </p:nvSpPr>
+        <p:spPr>
+          <a:xfrm>
+            <a:off x="640080" y="2148840"/>
+            <a:ext cx="2286000" cy="1417320"/>
+          </a:xfrm>
+          <a:prstGeom prst="rect">
+            <a:avLst/>
+          </a:prstGeom>
+          <a:noFill/>
+          <a:ln/>
+        </p:spPr>
+        <p:txBody>
+          <a:bodyPr wrap="square" lIns="0" tIns="0" rIns="0" bIns="0" rtlCol="0" anchor="t"/>
+          <a:lstStyle/>
+          <a:p>
+            <a:pPr indent="0" marL="0">
+              <a:buNone/>
+            </a:pPr>
+            <a:r>
+              <a:rPr lang="en-US" sz="1000" dirty="0">
                 <a:solidFill>
                   <a:srgbClr val="1C2326"/>
                 </a:solidFill>
@@ -3941,7 +4032,135 @@
                 <a:ea typeface="Arial" pitchFamily="34" charset="-122"/>
                 <a:cs typeface="Arial" pitchFamily="34" charset="-120"/>
               </a:rPr>
-              <a:t>Leerstand in der Stadt Zürich: 252 freie Wohnungen.</a:t>
+              <a:t>Der Brief: Sanierung, alle raus. Bei 0,11 % Leerstand findet sie nichts, im Neubau kostet es 30 % mehr. Jede dritte Gekündigte muss die Gemeinde verlassen.</a:t>
+            </a:r>
+            <a:endParaRPr lang="en-US" sz="1000" dirty="0"/>
+          </a:p>
+        </p:txBody>
+      </p:sp>
+      <p:sp>
+        <p:nvSpPr>
+          <p:cNvPr id="9" name="Text 7"/>
+          <p:cNvSpPr txBox="1"/>
+          <p:nvPr/>
+        </p:nvSpPr>
+        <p:spPr>
+          <a:xfrm>
+            <a:off x="640080" y="3657600"/>
+            <a:ext cx="2286000" cy="548640"/>
+          </a:xfrm>
+          <a:prstGeom prst="rect">
+            <a:avLst/>
+          </a:prstGeom>
+          <a:noFill/>
+          <a:ln/>
+        </p:spPr>
+        <p:txBody>
+          <a:bodyPr wrap="square" lIns="0" tIns="0" rIns="0" bIns="0" rtlCol="0" anchor="t"/>
+          <a:lstStyle/>
+          <a:p>
+            <a:pPr indent="0" marL="0">
+              <a:buNone/>
+            </a:pPr>
+            <a:r>
+              <a:rPr lang="en-US" sz="1000" b="1" dirty="0">
+                <a:solidFill>
+                  <a:srgbClr val="24414A"/>
+                </a:solidFill>
+                <a:latin typeface="Arial" pitchFamily="34" charset="0"/>
+                <a:ea typeface="Arial" pitchFamily="34" charset="-122"/>
+                <a:cs typeface="Arial" pitchFamily="34" charset="-120"/>
+              </a:rPr>
+              <a:t>Will: bleiben. Und wissen, wann sie zurück kann.</a:t>
+            </a:r>
+            <a:endParaRPr lang="en-US" sz="1000" dirty="0"/>
+          </a:p>
+        </p:txBody>
+      </p:sp>
+      <p:sp>
+        <p:nvSpPr>
+          <p:cNvPr id="10" name="Shape 8"/>
+          <p:cNvSpPr/>
+          <p:nvPr/>
+        </p:nvSpPr>
+        <p:spPr>
+          <a:xfrm>
+            <a:off x="3246120" y="1280160"/>
+            <a:ext cx="2651760" cy="3291840"/>
+          </a:xfrm>
+          <a:prstGeom prst="rect">
+            <a:avLst/>
+          </a:prstGeom>
+          <a:solidFill>
+            <a:srgbClr val="FFFFFF"/>
+          </a:solidFill>
+          <a:ln w="9525">
+            <a:solidFill>
+              <a:srgbClr val="E3DDD4"/>
+            </a:solidFill>
+            <a:prstDash val="solid"/>
+          </a:ln>
+        </p:spPr>
+      </p:sp>
+      <p:sp>
+        <p:nvSpPr>
+          <p:cNvPr id="11" name="Shape 9"/>
+          <p:cNvSpPr/>
+          <p:nvPr/>
+        </p:nvSpPr>
+        <p:spPr>
+          <a:xfrm>
+            <a:off x="3429000" y="1463040"/>
+            <a:ext cx="457200" cy="457200"/>
+          </a:xfrm>
+          <a:prstGeom prst="rect">
+            <a:avLst/>
+          </a:prstGeom>
+          <a:solidFill>
+            <a:srgbClr val="24414A"/>
+          </a:solidFill>
+          <a:ln w="12700">
+            <a:solidFill>
+              <a:srgbClr val="24414A"/>
+            </a:solidFill>
+            <a:prstDash val="solid"/>
+          </a:ln>
+        </p:spPr>
+      </p:sp>
+      <p:sp>
+        <p:nvSpPr>
+          <p:cNvPr id="12" name="Text 10"/>
+          <p:cNvSpPr txBox="1"/>
+          <p:nvPr/>
+        </p:nvSpPr>
+        <p:spPr>
+          <a:xfrm>
+            <a:off x="3429000" y="1463040"/>
+            <a:ext cx="457200" cy="457200"/>
+          </a:xfrm>
+          <a:prstGeom prst="rect">
+            <a:avLst/>
+          </a:prstGeom>
+          <a:noFill/>
+          <a:ln/>
+        </p:spPr>
+        <p:txBody>
+          <a:bodyPr wrap="square" lIns="0" tIns="0" rIns="0" bIns="0" rtlCol="0" anchor="ctr"/>
+          <a:lstStyle/>
+          <a:p>
+            <a:pPr algn="ctr" indent="0" marL="0">
+              <a:buNone/>
+            </a:pPr>
+            <a:r>
+              <a:rPr lang="en-US" sz="1400" b="1" dirty="0">
+                <a:solidFill>
+                  <a:srgbClr val="FFFFFF"/>
+                </a:solidFill>
+                <a:latin typeface="Arial" pitchFamily="34" charset="0"/>
+                <a:ea typeface="Arial" pitchFamily="34" charset="-122"/>
+                <a:cs typeface="Arial" pitchFamily="34" charset="-120"/>
+              </a:rPr>
+              <a:t>SK</a:t>
             </a:r>
             <a:endParaRPr lang="en-US" sz="1400" dirty="0"/>
           </a:p>
@@ -3949,14 +4168,14 @@
       </p:sp>
       <p:sp>
         <p:nvSpPr>
-          <p:cNvPr id="6" name="Text 4"/>
-          <p:cNvSpPr txBox="1"/>
-          <p:nvPr/>
-        </p:nvSpPr>
-        <p:spPr>
-          <a:xfrm>
-            <a:off x="685800" y="3191256"/>
-            <a:ext cx="2194560" cy="201168"/>
+          <p:cNvPr id="13" name="Text 11"/>
+          <p:cNvSpPr txBox="1"/>
+          <p:nvPr/>
+        </p:nvSpPr>
+        <p:spPr>
+          <a:xfrm>
+            <a:off x="4023360" y="1444752"/>
+            <a:ext cx="1737360" cy="256032"/>
           </a:xfrm>
           <a:prstGeom prst="rect">
             <a:avLst/>
@@ -3972,7 +4191,46 @@
               <a:buNone/>
             </a:pPr>
             <a:r>
-              <a:rPr lang="en-US" sz="800" dirty="0">
+              <a:rPr lang="en-US" sz="1300" b="1" dirty="0">
+                <a:solidFill>
+                  <a:srgbClr val="1C2326"/>
+                </a:solidFill>
+                <a:latin typeface="Arial" pitchFamily="34" charset="0"/>
+                <a:ea typeface="Arial" pitchFamily="34" charset="-122"/>
+                <a:cs typeface="Arial" pitchFamily="34" charset="-120"/>
+              </a:rPr>
+              <a:t>Sandra Keller, 44</a:t>
+            </a:r>
+            <a:endParaRPr lang="en-US" sz="1300" dirty="0"/>
+          </a:p>
+        </p:txBody>
+      </p:sp>
+      <p:sp>
+        <p:nvSpPr>
+          <p:cNvPr id="14" name="Text 12"/>
+          <p:cNvSpPr txBox="1"/>
+          <p:nvPr/>
+        </p:nvSpPr>
+        <p:spPr>
+          <a:xfrm>
+            <a:off x="4023360" y="1700784"/>
+            <a:ext cx="1737360" cy="365760"/>
+          </a:xfrm>
+          <a:prstGeom prst="rect">
+            <a:avLst/>
+          </a:prstGeom>
+          <a:noFill/>
+          <a:ln/>
+        </p:spPr>
+        <p:txBody>
+          <a:bodyPr wrap="square" lIns="0" tIns="0" rIns="0" bIns="0" rtlCol="0" anchor="t"/>
+          <a:lstStyle/>
+          <a:p>
+            <a:pPr indent="0" marL="0">
+              <a:buNone/>
+            </a:pPr>
+            <a:r>
+              <a:rPr lang="en-US" sz="850" dirty="0">
                 <a:solidFill>
                   <a:srgbClr val="5B6468"/>
                 </a:solidFill>
@@ -3980,27 +4238,103 @@
                 <a:ea typeface="Arial" pitchFamily="34" charset="-122"/>
                 <a:cs typeface="Arial" pitchFamily="34" charset="-120"/>
               </a:rPr>
-              <a:t>Statistik Stadt Zürich, 1. Juni 2026</a:t>
-            </a:r>
-            <a:endParaRPr lang="en-US" sz="800" dirty="0"/>
-          </a:p>
-        </p:txBody>
-      </p:sp>
-      <p:sp>
-        <p:nvSpPr>
-          <p:cNvPr id="7" name="Shape 5"/>
+              <a:t>Bewirtschafterin, Genossenschaft mit 1'200 Wohnungen</a:t>
+            </a:r>
+            <a:endParaRPr lang="en-US" sz="850" dirty="0"/>
+          </a:p>
+        </p:txBody>
+      </p:sp>
+      <p:sp>
+        <p:nvSpPr>
+          <p:cNvPr id="15" name="Text 13"/>
+          <p:cNvSpPr txBox="1"/>
+          <p:nvPr/>
+        </p:nvSpPr>
+        <p:spPr>
+          <a:xfrm>
+            <a:off x="3429000" y="2148840"/>
+            <a:ext cx="2286000" cy="1417320"/>
+          </a:xfrm>
+          <a:prstGeom prst="rect">
+            <a:avLst/>
+          </a:prstGeom>
+          <a:noFill/>
+          <a:ln/>
+        </p:spPr>
+        <p:txBody>
+          <a:bodyPr wrap="square" lIns="0" tIns="0" rIns="0" bIns="0" rtlCol="0" anchor="t"/>
+          <a:lstStyle/>
+          <a:p>
+            <a:pPr indent="0" marL="0">
+              <a:buNone/>
+            </a:pPr>
+            <a:r>
+              <a:rPr lang="en-US" sz="1000" dirty="0">
+                <a:solidFill>
+                  <a:srgbClr val="1C2326"/>
+                </a:solidFill>
+                <a:latin typeface="Arial" pitchFamily="34" charset="0"/>
+                <a:ea typeface="Arial" pitchFamily="34" charset="-122"/>
+                <a:cs typeface="Arial" pitchFamily="34" charset="-120"/>
+              </a:rPr>
+              <a:t>49 Mietparteien, drei Etappen, elf freie Wohnungen. Alles in Excel und E-Mails, vierfacher Aufwand. Verschiebt sich der Bau, fängt sie von vorne an.</a:t>
+            </a:r>
+            <a:endParaRPr lang="en-US" sz="1000" dirty="0"/>
+          </a:p>
+        </p:txBody>
+      </p:sp>
+      <p:sp>
+        <p:nvSpPr>
+          <p:cNvPr id="16" name="Text 14"/>
+          <p:cNvSpPr txBox="1"/>
+          <p:nvPr/>
+        </p:nvSpPr>
+        <p:spPr>
+          <a:xfrm>
+            <a:off x="3429000" y="3657600"/>
+            <a:ext cx="2286000" cy="548640"/>
+          </a:xfrm>
+          <a:prstGeom prst="rect">
+            <a:avLst/>
+          </a:prstGeom>
+          <a:noFill/>
+          <a:ln/>
+        </p:spPr>
+        <p:txBody>
+          <a:bodyPr wrap="square" lIns="0" tIns="0" rIns="0" bIns="0" rtlCol="0" anchor="t"/>
+          <a:lstStyle/>
+          <a:p>
+            <a:pPr indent="0" marL="0">
+              <a:buNone/>
+            </a:pPr>
+            <a:r>
+              <a:rPr lang="en-US" sz="1000" b="1" dirty="0">
+                <a:solidFill>
+                  <a:srgbClr val="24414A"/>
+                </a:solidFill>
+                <a:latin typeface="Arial" pitchFamily="34" charset="0"/>
+                <a:ea typeface="Arial" pitchFamily="34" charset="-122"/>
+                <a:cs typeface="Arial" pitchFamily="34" charset="-120"/>
+              </a:rPr>
+              <a:t>Will: einen Plan, der bei Änderungen hält.</a:t>
+            </a:r>
+            <a:endParaRPr lang="en-US" sz="1000" dirty="0"/>
+          </a:p>
+        </p:txBody>
+      </p:sp>
+      <p:sp>
+        <p:nvSpPr>
+          <p:cNvPr id="17" name="Shape 15"/>
           <p:cNvSpPr/>
           <p:nvPr/>
         </p:nvSpPr>
         <p:spPr>
           <a:xfrm>
-            <a:off x="3246120" y="1280160"/>
-            <a:ext cx="2651760" cy="2240280"/>
-          </a:xfrm>
-          <a:prstGeom prst="roundRect">
-            <a:avLst>
-              <a:gd name="adj" fmla="val 5714"/>
-            </a:avLst>
+            <a:off x="6035040" y="1280160"/>
+            <a:ext cx="2651760" cy="3291840"/>
+          </a:xfrm>
+          <a:prstGeom prst="rect">
+            <a:avLst/>
           </a:prstGeom>
           <a:solidFill>
             <a:srgbClr val="FDEBDD"/>
@@ -4015,143 +4349,24 @@
       </p:sp>
       <p:sp>
         <p:nvSpPr>
-          <p:cNvPr id="8" name="Text 6"/>
-          <p:cNvSpPr txBox="1"/>
-          <p:nvPr/>
-        </p:nvSpPr>
-        <p:spPr>
-          <a:xfrm>
-            <a:off x="3474720" y="1426464"/>
-            <a:ext cx="2194560" cy="857250"/>
-          </a:xfrm>
-          <a:prstGeom prst="rect">
-            <a:avLst/>
-          </a:prstGeom>
-          <a:noFill/>
-          <a:ln/>
-        </p:spPr>
-        <p:txBody>
-          <a:bodyPr wrap="square" lIns="0" tIns="0" rIns="0" bIns="0" rtlCol="0" anchor="ctr"/>
-          <a:lstStyle/>
-          <a:p>
-            <a:pPr indent="0" marL="0">
-              <a:buNone/>
-            </a:pPr>
-            <a:r>
-              <a:rPr lang="en-US" sz="5400" b="1" dirty="0">
-                <a:solidFill>
-                  <a:srgbClr val="B8460E"/>
-                </a:solidFill>
-                <a:latin typeface="Arial" pitchFamily="34" charset="0"/>
-                <a:ea typeface="Arial" pitchFamily="34" charset="-122"/>
-                <a:cs typeface="Arial" pitchFamily="34" charset="-120"/>
-              </a:rPr>
-              <a:t>+30 %</a:t>
-            </a:r>
-            <a:endParaRPr lang="en-US" sz="5400" dirty="0"/>
-          </a:p>
-        </p:txBody>
-      </p:sp>
-      <p:sp>
-        <p:nvSpPr>
-          <p:cNvPr id="9" name="Text 7"/>
-          <p:cNvSpPr txBox="1"/>
-          <p:nvPr/>
-        </p:nvSpPr>
-        <p:spPr>
-          <a:xfrm>
-            <a:off x="3474720" y="2320290"/>
-            <a:ext cx="2194560" cy="816102"/>
-          </a:xfrm>
-          <a:prstGeom prst="rect">
-            <a:avLst/>
-          </a:prstGeom>
-          <a:noFill/>
-          <a:ln/>
-        </p:spPr>
-        <p:txBody>
-          <a:bodyPr wrap="square" lIns="0" tIns="0" rIns="0" bIns="0" rtlCol="0" anchor="t"/>
-          <a:lstStyle/>
-          <a:p>
-            <a:pPr indent="0" marL="0">
-              <a:buNone/>
-            </a:pPr>
-            <a:r>
-              <a:rPr lang="en-US" sz="1400" dirty="0">
-                <a:solidFill>
-                  <a:srgbClr val="1C2326"/>
-                </a:solidFill>
-                <a:latin typeface="Arial" pitchFamily="34" charset="0"/>
-                <a:ea typeface="Arial" pitchFamily="34" charset="-122"/>
-                <a:cs typeface="Arial" pitchFamily="34" charset="-120"/>
-              </a:rPr>
-              <a:t>Miete im Neubau gegenüber langjährigen Mietenden.</a:t>
-            </a:r>
-            <a:endParaRPr lang="en-US" sz="1400" dirty="0"/>
-          </a:p>
-        </p:txBody>
-      </p:sp>
-      <p:sp>
-        <p:nvSpPr>
-          <p:cNvPr id="10" name="Text 8"/>
-          <p:cNvSpPr txBox="1"/>
-          <p:nvPr/>
-        </p:nvSpPr>
-        <p:spPr>
-          <a:xfrm>
-            <a:off x="3474720" y="3191256"/>
-            <a:ext cx="2194560" cy="201168"/>
-          </a:xfrm>
-          <a:prstGeom prst="rect">
-            <a:avLst/>
-          </a:prstGeom>
-          <a:noFill/>
-          <a:ln/>
-        </p:spPr>
-        <p:txBody>
-          <a:bodyPr wrap="square" lIns="0" tIns="0" rIns="0" bIns="0" rtlCol="0" anchor="ctr"/>
-          <a:lstStyle/>
-          <a:p>
-            <a:pPr indent="0" marL="0">
-              <a:buNone/>
-            </a:pPr>
-            <a:r>
-              <a:rPr lang="en-US" sz="800" dirty="0">
-                <a:solidFill>
-                  <a:srgbClr val="5B6468"/>
-                </a:solidFill>
-                <a:latin typeface="Arial" pitchFamily="34" charset="0"/>
-                <a:ea typeface="Arial" pitchFamily="34" charset="-122"/>
-                <a:cs typeface="Arial" pitchFamily="34" charset="-120"/>
-              </a:rPr>
-              <a:t>Statistik Stadt Zürich, via 20 Minuten</a:t>
-            </a:r>
-            <a:endParaRPr lang="en-US" sz="800" dirty="0"/>
-          </a:p>
-        </p:txBody>
-      </p:sp>
-      <p:sp>
-        <p:nvSpPr>
-          <p:cNvPr id="11" name="Shape 9"/>
+          <p:cNvPr id="18" name="Shape 16"/>
           <p:cNvSpPr/>
           <p:nvPr/>
         </p:nvSpPr>
         <p:spPr>
           <a:xfrm>
-            <a:off x="6035040" y="1280160"/>
-            <a:ext cx="2651760" cy="2240280"/>
-          </a:xfrm>
-          <a:prstGeom prst="roundRect">
-            <a:avLst>
-              <a:gd name="adj" fmla="val 5714"/>
-            </a:avLst>
+            <a:off x="6217920" y="1463040"/>
+            <a:ext cx="457200" cy="457200"/>
+          </a:xfrm>
+          <a:prstGeom prst="rect">
+            <a:avLst/>
           </a:prstGeom>
           <a:solidFill>
-            <a:srgbClr val="FFFFFF"/>
+            <a:srgbClr val="B8460E"/>
           </a:solidFill>
-          <a:ln w="9525">
+          <a:ln w="12700">
             <a:solidFill>
-              <a:srgbClr val="E3DDD4"/>
+              <a:srgbClr val="B8460E"/>
             </a:solidFill>
             <a:prstDash val="solid"/>
           </a:ln>
@@ -4159,14 +4374,14 @@
       </p:sp>
       <p:sp>
         <p:nvSpPr>
-          <p:cNvPr id="12" name="Text 10"/>
-          <p:cNvSpPr txBox="1"/>
-          <p:nvPr/>
-        </p:nvSpPr>
-        <p:spPr>
-          <a:xfrm>
-            <a:off x="6263640" y="1426464"/>
-            <a:ext cx="2194560" cy="730250"/>
+          <p:cNvPr id="19" name="Text 17"/>
+          <p:cNvSpPr txBox="1"/>
+          <p:nvPr/>
+        </p:nvSpPr>
+        <p:spPr>
+          <a:xfrm>
+            <a:off x="6217920" y="1463040"/>
+            <a:ext cx="457200" cy="457200"/>
           </a:xfrm>
           <a:prstGeom prst="rect">
             <a:avLst/>
@@ -4178,11 +4393,50 @@
           <a:bodyPr wrap="square" lIns="0" tIns="0" rIns="0" bIns="0" rtlCol="0" anchor="ctr"/>
           <a:lstStyle/>
           <a:p>
+            <a:pPr algn="ctr" indent="0" marL="0">
+              <a:buNone/>
+            </a:pPr>
+            <a:r>
+              <a:rPr lang="en-US" sz="1400" b="1" dirty="0">
+                <a:solidFill>
+                  <a:srgbClr val="FFFFFF"/>
+                </a:solidFill>
+                <a:latin typeface="Arial" pitchFamily="34" charset="0"/>
+                <a:ea typeface="Arial" pitchFamily="34" charset="-122"/>
+                <a:cs typeface="Arial" pitchFamily="34" charset="-120"/>
+              </a:rPr>
+              <a:t>RH</a:t>
+            </a:r>
+            <a:endParaRPr lang="en-US" sz="1400" dirty="0"/>
+          </a:p>
+        </p:txBody>
+      </p:sp>
+      <p:sp>
+        <p:nvSpPr>
+          <p:cNvPr id="20" name="Text 18"/>
+          <p:cNvSpPr txBox="1"/>
+          <p:nvPr/>
+        </p:nvSpPr>
+        <p:spPr>
+          <a:xfrm>
+            <a:off x="6812280" y="1444752"/>
+            <a:ext cx="1737360" cy="256032"/>
+          </a:xfrm>
+          <a:prstGeom prst="rect">
+            <a:avLst/>
+          </a:prstGeom>
+          <a:noFill/>
+          <a:ln/>
+        </p:spPr>
+        <p:txBody>
+          <a:bodyPr wrap="square" lIns="0" tIns="0" rIns="0" bIns="0" rtlCol="0" anchor="ctr"/>
+          <a:lstStyle/>
+          <a:p>
             <a:pPr indent="0" marL="0">
               <a:buNone/>
             </a:pPr>
             <a:r>
-              <a:rPr lang="en-US" sz="4600" b="1" dirty="0">
+              <a:rPr lang="en-US" sz="1300" b="1" dirty="0">
                 <a:solidFill>
                   <a:srgbClr val="1C2326"/>
                 </a:solidFill>
@@ -4190,22 +4444,22 @@
                 <a:ea typeface="Arial" pitchFamily="34" charset="-122"/>
                 <a:cs typeface="Arial" pitchFamily="34" charset="-120"/>
               </a:rPr>
-              <a:t>1 von 3</a:t>
-            </a:r>
-            <a:endParaRPr lang="en-US" sz="4600" dirty="0"/>
-          </a:p>
-        </p:txBody>
-      </p:sp>
-      <p:sp>
-        <p:nvSpPr>
-          <p:cNvPr id="13" name="Text 11"/>
-          <p:cNvSpPr txBox="1"/>
-          <p:nvPr/>
-        </p:nvSpPr>
-        <p:spPr>
-          <a:xfrm>
-            <a:off x="6263640" y="2193290"/>
-            <a:ext cx="2194560" cy="943102"/>
+              <a:t>Reto Huber, 58</a:t>
+            </a:r>
+            <a:endParaRPr lang="en-US" sz="1300" dirty="0"/>
+          </a:p>
+        </p:txBody>
+      </p:sp>
+      <p:sp>
+        <p:nvSpPr>
+          <p:cNvPr id="21" name="Text 19"/>
+          <p:cNvSpPr txBox="1"/>
+          <p:nvPr/>
+        </p:nvSpPr>
+        <p:spPr>
+          <a:xfrm>
+            <a:off x="6812280" y="1700784"/>
+            <a:ext cx="1737360" cy="365760"/>
           </a:xfrm>
           <a:prstGeom prst="rect">
             <a:avLst/>
@@ -4221,7 +4475,46 @@
               <a:buNone/>
             </a:pPr>
             <a:r>
-              <a:rPr lang="en-US" sz="1400" dirty="0">
+              <a:rPr lang="en-US" sz="850" dirty="0">
+                <a:solidFill>
+                  <a:srgbClr val="5B6468"/>
+                </a:solidFill>
+                <a:latin typeface="Arial" pitchFamily="34" charset="0"/>
+                <a:ea typeface="Arial" pitchFamily="34" charset="-122"/>
+                <a:cs typeface="Arial" pitchFamily="34" charset="-120"/>
+              </a:rPr>
+              <a:t>Vorstand, entscheidet und zahlt</a:t>
+            </a:r>
+            <a:endParaRPr lang="en-US" sz="850" dirty="0"/>
+          </a:p>
+        </p:txBody>
+      </p:sp>
+      <p:sp>
+        <p:nvSpPr>
+          <p:cNvPr id="22" name="Text 20"/>
+          <p:cNvSpPr txBox="1"/>
+          <p:nvPr/>
+        </p:nvSpPr>
+        <p:spPr>
+          <a:xfrm>
+            <a:off x="6217920" y="2148840"/>
+            <a:ext cx="2286000" cy="1417320"/>
+          </a:xfrm>
+          <a:prstGeom prst="rect">
+            <a:avLst/>
+          </a:prstGeom>
+          <a:noFill/>
+          <a:ln/>
+        </p:spPr>
+        <p:txBody>
+          <a:bodyPr wrap="square" lIns="0" tIns="0" rIns="0" bIns="0" rtlCol="0" anchor="t"/>
+          <a:lstStyle/>
+          <a:p>
+            <a:pPr indent="0" marL="0">
+              <a:buNone/>
+            </a:pPr>
+            <a:r>
+              <a:rPr lang="en-US" sz="1000" dirty="0">
                 <a:solidFill>
                   <a:srgbClr val="1C2326"/>
                 </a:solidFill>
@@ -4229,73 +4522,71 @@
                 <a:ea typeface="Arial" pitchFamily="34" charset="-122"/>
                 <a:cs typeface="Arial" pitchFamily="34" charset="-120"/>
               </a:rPr>
-              <a:t>muss die Gemeinde verlassen. Nur zwei Drittel finden vor Ort eine neue Wohnung.</a:t>
-            </a:r>
-            <a:endParaRPr lang="en-US" sz="1400" dirty="0"/>
-          </a:p>
-        </p:txBody>
-      </p:sp>
-      <p:sp>
-        <p:nvSpPr>
-          <p:cNvPr id="14" name="Text 12"/>
-          <p:cNvSpPr txBox="1"/>
-          <p:nvPr/>
-        </p:nvSpPr>
-        <p:spPr>
-          <a:xfrm>
-            <a:off x="6263640" y="3191256"/>
-            <a:ext cx="2194560" cy="201168"/>
-          </a:xfrm>
-          <a:prstGeom prst="rect">
-            <a:avLst/>
-          </a:prstGeom>
-          <a:noFill/>
-          <a:ln/>
-        </p:spPr>
-        <p:txBody>
-          <a:bodyPr wrap="square" lIns="0" tIns="0" rIns="0" bIns="0" rtlCol="0" anchor="ctr"/>
+              <a:t>Leerkündigung heisst Schlichtungsbehörde, Schlagzeilen, ein Jahr Stillstand (Sugus-Häuser). Zürich verlangt neu den Nachweis, dass bewohnt oder etappiert geprüft wurde.</a:t>
+            </a:r>
+            <a:endParaRPr lang="en-US" sz="1000" dirty="0"/>
+          </a:p>
+        </p:txBody>
+      </p:sp>
+      <p:sp>
+        <p:nvSpPr>
+          <p:cNvPr id="23" name="Text 21"/>
+          <p:cNvSpPr txBox="1"/>
+          <p:nvPr/>
+        </p:nvSpPr>
+        <p:spPr>
+          <a:xfrm>
+            <a:off x="6217920" y="3657600"/>
+            <a:ext cx="2286000" cy="548640"/>
+          </a:xfrm>
+          <a:prstGeom prst="rect">
+            <a:avLst/>
+          </a:prstGeom>
+          <a:noFill/>
+          <a:ln/>
+        </p:spPr>
+        <p:txBody>
+          <a:bodyPr wrap="square" lIns="0" tIns="0" rIns="0" bIns="0" rtlCol="0" anchor="t"/>
           <a:lstStyle/>
           <a:p>
             <a:pPr indent="0" marL="0">
               <a:buNone/>
             </a:pPr>
             <a:r>
-              <a:rPr lang="en-US" sz="800" dirty="0">
-                <a:solidFill>
-                  <a:srgbClr val="5B6468"/>
-                </a:solidFill>
-                <a:latin typeface="Arial" pitchFamily="34" charset="0"/>
-                <a:ea typeface="Arial" pitchFamily="34" charset="-122"/>
-                <a:cs typeface="Arial" pitchFamily="34" charset="-120"/>
-              </a:rPr>
-              <a:t>Zürcher Kantonalbank, 2024</a:t>
-            </a:r>
-            <a:endParaRPr lang="en-US" sz="800" dirty="0"/>
-          </a:p>
-        </p:txBody>
-      </p:sp>
-      <p:sp>
-        <p:nvSpPr>
-          <p:cNvPr id="15" name="Shape 13"/>
+              <a:rPr lang="en-US" sz="1000" b="1" dirty="0">
+                <a:solidFill>
+                  <a:srgbClr val="B8460E"/>
+                </a:solidFill>
+                <a:latin typeface="Arial" pitchFamily="34" charset="0"/>
+                <a:ea typeface="Arial" pitchFamily="34" charset="-122"/>
+                <a:cs typeface="Arial" pitchFamily="34" charset="-120"/>
+              </a:rPr>
+              <a:t>Will: Sanierung im Termin, rechtssicher, ohne Rauswurf.</a:t>
+            </a:r>
+            <a:endParaRPr lang="en-US" sz="1000" dirty="0"/>
+          </a:p>
+        </p:txBody>
+      </p:sp>
+      <p:sp>
+        <p:nvSpPr>
+          <p:cNvPr id="24" name="Shape 22"/>
           <p:cNvSpPr/>
           <p:nvPr/>
         </p:nvSpPr>
         <p:spPr>
           <a:xfrm>
-            <a:off x="457200" y="3657600"/>
-            <a:ext cx="8229600" cy="914400"/>
-          </a:xfrm>
-          <a:prstGeom prst="roundRect">
-            <a:avLst>
-              <a:gd name="adj" fmla="val 14000"/>
-            </a:avLst>
+            <a:off x="6217920" y="4224528"/>
+            <a:ext cx="914400" cy="237744"/>
+          </a:xfrm>
+          <a:prstGeom prst="rect">
+            <a:avLst/>
           </a:prstGeom>
           <a:solidFill>
-            <a:srgbClr val="E2ECEE"/>
+            <a:srgbClr val="B8460E"/>
           </a:solidFill>
           <a:ln w="12700">
             <a:solidFill>
-              <a:srgbClr val="E2ECEE"/>
+              <a:srgbClr val="B8460E"/>
             </a:solidFill>
             <a:prstDash val="solid"/>
           </a:ln>
@@ -4303,14 +4594,14 @@
       </p:sp>
       <p:sp>
         <p:nvSpPr>
-          <p:cNvPr id="16" name="Text 14"/>
-          <p:cNvSpPr txBox="1"/>
-          <p:nvPr/>
-        </p:nvSpPr>
-        <p:spPr>
-          <a:xfrm>
-            <a:off x="731520" y="3767328"/>
-            <a:ext cx="2926080" cy="320040"/>
+          <p:cNvPr id="25" name="Text 23"/>
+          <p:cNvSpPr txBox="1"/>
+          <p:nvPr/>
+        </p:nvSpPr>
+        <p:spPr>
+          <a:xfrm>
+            <a:off x="6217920" y="4224528"/>
+            <a:ext cx="914400" cy="237744"/>
           </a:xfrm>
           <a:prstGeom prst="rect">
             <a:avLst/>
@@ -4322,50 +4613,50 @@
           <a:bodyPr wrap="square" lIns="0" tIns="0" rIns="0" bIns="0" rtlCol="0" anchor="ctr"/>
           <a:lstStyle/>
           <a:p>
+            <a:pPr algn="ctr" indent="0" marL="0">
+              <a:buNone/>
+            </a:pPr>
+            <a:r>
+              <a:rPr lang="en-US" sz="900" b="1" dirty="0">
+                <a:solidFill>
+                  <a:srgbClr val="FFFFFF"/>
+                </a:solidFill>
+                <a:latin typeface="Arial" pitchFamily="34" charset="0"/>
+                <a:ea typeface="Arial" pitchFamily="34" charset="-122"/>
+                <a:cs typeface="Arial" pitchFamily="34" charset="-120"/>
+              </a:rPr>
+              <a:t>zahlt</a:t>
+            </a:r>
+            <a:endParaRPr lang="en-US" sz="900" dirty="0"/>
+          </a:p>
+        </p:txBody>
+      </p:sp>
+      <p:sp>
+        <p:nvSpPr>
+          <p:cNvPr id="26" name="Text 24"/>
+          <p:cNvSpPr txBox="1"/>
+          <p:nvPr/>
+        </p:nvSpPr>
+        <p:spPr>
+          <a:xfrm>
+            <a:off x="457200" y="4599432"/>
+            <a:ext cx="8229600" cy="201168"/>
+          </a:xfrm>
+          <a:prstGeom prst="rect">
+            <a:avLst/>
+          </a:prstGeom>
+          <a:noFill/>
+          <a:ln/>
+        </p:spPr>
+        <p:txBody>
+          <a:bodyPr wrap="square" lIns="0" tIns="0" rIns="0" bIns="0" rtlCol="0" anchor="ctr"/>
+          <a:lstStyle/>
+          <a:p>
             <a:pPr indent="0" marL="0">
               <a:buNone/>
             </a:pPr>
             <a:r>
-              <a:rPr lang="en-US" sz="1500" b="1" dirty="0">
-                <a:solidFill>
-                  <a:srgbClr val="1C2326"/>
-                </a:solidFill>
-                <a:latin typeface="Arial" pitchFamily="34" charset="0"/>
-                <a:ea typeface="Arial" pitchFamily="34" charset="-122"/>
-                <a:cs typeface="Arial" pitchFamily="34" charset="-120"/>
-              </a:rPr>
-              <a:t>Sugus-Häuser, Zürich Kreis 5</a:t>
-            </a:r>
-            <a:endParaRPr lang="en-US" sz="1500" dirty="0"/>
-          </a:p>
-        </p:txBody>
-      </p:sp>
-      <p:sp>
-        <p:nvSpPr>
-          <p:cNvPr id="17" name="Text 15"/>
-          <p:cNvSpPr txBox="1"/>
-          <p:nvPr/>
-        </p:nvSpPr>
-        <p:spPr>
-          <a:xfrm>
-            <a:off x="731520" y="4087368"/>
-            <a:ext cx="2926080" cy="274320"/>
-          </a:xfrm>
-          <a:prstGeom prst="rect">
-            <a:avLst/>
-          </a:prstGeom>
-          <a:noFill/>
-          <a:ln/>
-        </p:spPr>
-        <p:txBody>
-          <a:bodyPr wrap="square" lIns="0" tIns="0" rIns="0" bIns="0" rtlCol="0" anchor="ctr"/>
-          <a:lstStyle/>
-          <a:p>
-            <a:pPr indent="0" marL="0">
-              <a:buNone/>
-            </a:pPr>
-            <a:r>
-              <a:rPr lang="en-US" sz="1000" dirty="0">
+              <a:rPr lang="en-US" sz="750" dirty="0">
                 <a:solidFill>
                   <a:srgbClr val="5B6468"/>
                 </a:solidFill>
@@ -4373,48 +4664,9 @@
                 <a:ea typeface="Arial" pitchFamily="34" charset="-122"/>
                 <a:cs typeface="Arial" pitchFamily="34" charset="-120"/>
               </a:rPr>
-              <a:t>Kündigung kurz vor Weihnachten 2024</a:t>
-            </a:r>
-            <a:endParaRPr lang="en-US" sz="1000" dirty="0"/>
-          </a:p>
-        </p:txBody>
-      </p:sp>
-      <p:sp>
-        <p:nvSpPr>
-          <p:cNvPr id="18" name="Text 16"/>
-          <p:cNvSpPr txBox="1"/>
-          <p:nvPr/>
-        </p:nvSpPr>
-        <p:spPr>
-          <a:xfrm>
-            <a:off x="3657600" y="3730752"/>
-            <a:ext cx="4846320" cy="777240"/>
-          </a:xfrm>
-          <a:prstGeom prst="rect">
-            <a:avLst/>
-          </a:prstGeom>
-          <a:noFill/>
-          <a:ln/>
-        </p:spPr>
-        <p:txBody>
-          <a:bodyPr wrap="square" lIns="0" tIns="0" rIns="0" bIns="0" rtlCol="0" anchor="ctr"/>
-          <a:lstStyle/>
-          <a:p>
-            <a:pPr indent="0" marL="0">
-              <a:buNone/>
-            </a:pPr>
-            <a:r>
-              <a:rPr lang="en-US" sz="1100" dirty="0">
-                <a:solidFill>
-                  <a:srgbClr val="1C2326"/>
-                </a:solidFill>
-                <a:latin typeface="Arial" pitchFamily="34" charset="0"/>
-                <a:ea typeface="Arial" pitchFamily="34" charset="-122"/>
-                <a:cs typeface="Arial" pitchFamily="34" charset="-120"/>
-              </a:rPr>
-              <a:t>Rund 100 Haushalte leergekündigt. Monatelanger Widerstand, Schlichtungsbehörde und Mietgericht erklären die Kündigungen für ungültig. Leerkündigung ist auch für Eigentümer ein Risiko.</a:t>
-            </a:r>
-            <a:endParaRPr lang="en-US" sz="1100" dirty="0"/>
+              <a:t>Personas, Namen fiktiv. Zahlen: Stadt Zürich 2026, Statistik Stadt Zürich via 20 Minuten, ZKB 2024, bgnzwo 2026, SRF/NZZ zu den Sugus-Häusern.</a:t>
+            </a:r>
+            <a:endParaRPr lang="en-US" sz="750" dirty="0"/>
           </a:p>
         </p:txBody>
       </p:sp>
@@ -4537,10 +4789,8 @@
             <a:off x="457200" y="1280160"/>
             <a:ext cx="4846320" cy="3291840"/>
           </a:xfrm>
-          <a:prstGeom prst="roundRect">
-            <a:avLst>
-              <a:gd name="adj" fmla="val 3889"/>
-            </a:avLst>
+          <a:prstGeom prst="rect">
+            <a:avLst/>
           </a:prstGeom>
           <a:solidFill>
             <a:srgbClr val="FFFFFF"/>
@@ -4564,10 +4814,8 @@
             <a:off x="731520" y="1828800"/>
             <a:ext cx="1280160" cy="502920"/>
           </a:xfrm>
-          <a:prstGeom prst="roundRect">
-            <a:avLst>
-              <a:gd name="adj" fmla="val 14545"/>
-            </a:avLst>
+          <a:prstGeom prst="rect">
+            <a:avLst/>
           </a:prstGeom>
           <a:solidFill>
             <a:srgbClr val="1C2326"/>
@@ -4708,10 +4956,8 @@
             <a:off x="2240280" y="1828800"/>
             <a:ext cx="1280160" cy="502920"/>
           </a:xfrm>
-          <a:prstGeom prst="roundRect">
-            <a:avLst>
-              <a:gd name="adj" fmla="val 14545"/>
-            </a:avLst>
+          <a:prstGeom prst="rect">
+            <a:avLst/>
           </a:prstGeom>
           <a:solidFill>
             <a:srgbClr val="24414A"/>
@@ -4852,10 +5098,8 @@
             <a:off x="3749040" y="1828800"/>
             <a:ext cx="1280160" cy="502920"/>
           </a:xfrm>
-          <a:prstGeom prst="roundRect">
-            <a:avLst>
-              <a:gd name="adj" fmla="val 14545"/>
-            </a:avLst>
+          <a:prstGeom prst="rect">
+            <a:avLst/>
           </a:prstGeom>
           <a:solidFill>
             <a:srgbClr val="1C2326"/>
@@ -4957,10 +5201,8 @@
             <a:off x="731520" y="2926080"/>
             <a:ext cx="1280160" cy="502920"/>
           </a:xfrm>
-          <a:prstGeom prst="roundRect">
-            <a:avLst>
-              <a:gd name="adj" fmla="val 14545"/>
-            </a:avLst>
+          <a:prstGeom prst="rect">
+            <a:avLst/>
           </a:prstGeom>
           <a:solidFill>
             <a:srgbClr val="FDEBDD"/>
@@ -5062,10 +5304,8 @@
             <a:off x="2240280" y="2926080"/>
             <a:ext cx="1280160" cy="502920"/>
           </a:xfrm>
-          <a:prstGeom prst="roundRect">
-            <a:avLst>
-              <a:gd name="adj" fmla="val 14545"/>
-            </a:avLst>
+          <a:prstGeom prst="rect">
+            <a:avLst/>
           </a:prstGeom>
           <a:solidFill>
             <a:srgbClr val="FAF8F5"/>
@@ -5167,10 +5407,8 @@
             <a:off x="3749040" y="2926080"/>
             <a:ext cx="1280160" cy="502920"/>
           </a:xfrm>
-          <a:prstGeom prst="roundRect">
-            <a:avLst>
-              <a:gd name="adj" fmla="val 14545"/>
-            </a:avLst>
+          <a:prstGeom prst="rect">
+            <a:avLst/>
           </a:prstGeom>
           <a:solidFill>
             <a:srgbClr val="276B43"/>
@@ -5311,10 +5549,8 @@
             <a:off x="5486400" y="1280160"/>
             <a:ext cx="3200400" cy="1554480"/>
           </a:xfrm>
-          <a:prstGeom prst="roundRect">
-            <a:avLst>
-              <a:gd name="adj" fmla="val 8235"/>
-            </a:avLst>
+          <a:prstGeom prst="rect">
+            <a:avLst/>
           </a:prstGeom>
           <a:solidFill>
             <a:srgbClr val="24414A"/>
@@ -5416,10 +5652,8 @@
             <a:off x="5486400" y="3017520"/>
             <a:ext cx="3200400" cy="1554480"/>
           </a:xfrm>
-          <a:prstGeom prst="roundRect">
-            <a:avLst>
-              <a:gd name="adj" fmla="val 8235"/>
-            </a:avLst>
+          <a:prstGeom prst="rect">
+            <a:avLst/>
           </a:prstGeom>
           <a:solidFill>
             <a:srgbClr val="FFFFFF"/>
@@ -5441,7 +5675,7 @@
         <p:spPr>
           <a:xfrm>
             <a:off x="5715000" y="3108960"/>
-            <a:ext cx="2743200" cy="640080"/>
+            <a:ext cx="2743200" cy="548640"/>
           </a:xfrm>
           <a:prstGeom prst="rect">
             <a:avLst/>
@@ -5457,7 +5691,7 @@
               <a:buNone/>
             </a:pPr>
             <a:r>
-              <a:rPr lang="en-US" sz="3600" b="1" dirty="0">
+              <a:rPr lang="en-US" sz="2400" b="1" dirty="0">
                 <a:solidFill>
                   <a:srgbClr val="F26A1B"/>
                 </a:solidFill>
@@ -5465,9 +5699,9 @@
                 <a:ea typeface="Arial" pitchFamily="34" charset="-122"/>
                 <a:cs typeface="Arial" pitchFamily="34" charset="-120"/>
               </a:rPr>
-              <a:t>49 · 4×</a:t>
-            </a:r>
-            <a:endParaRPr lang="en-US" sz="3600" dirty="0"/>
+              <a:t>«enorm aufwändig»</a:t>
+            </a:r>
+            <a:endParaRPr lang="en-US" sz="2400" dirty="0"/>
           </a:p>
         </p:txBody>
       </p:sp>
@@ -5479,8 +5713,8 @@
         </p:nvSpPr>
         <p:spPr>
           <a:xfrm>
-            <a:off x="5715000" y="3749040"/>
-            <a:ext cx="2743200" cy="548640"/>
+            <a:off x="5715000" y="3703320"/>
+            <a:ext cx="2743200" cy="594360"/>
           </a:xfrm>
           <a:prstGeom prst="rect">
             <a:avLst/>
@@ -5504,7 +5738,7 @@
                 <a:ea typeface="Arial" pitchFamily="34" charset="-122"/>
                 <a:cs typeface="Arial" pitchFamily="34" charset="-120"/>
               </a:rPr>
-              <a:t>Mietparteien, vierfacher Aufwand in der Bewirtschaftung. Geplant mit Tabellen, E-Mails und Erfahrung.</a:t>
+              <a:t>sagen dieselben Befragten. Flächen finden, zuteilen, zwei Übergaben pro Haushalt, jede Verschiebung von Hand. Darum machen es viele nicht.</a:t>
             </a:r>
             <a:endParaRPr lang="en-US" sz="1000" dirty="0"/>
           </a:p>
@@ -5543,7 +5777,7 @@
                 <a:ea typeface="Arial" pitchFamily="34" charset="-122"/>
                 <a:cs typeface="Arial" pitchFamily="34" charset="-120"/>
               </a:rPr>
-              <a:t>bgnzwo, Siedlung Hönggerberg, 2026</a:t>
+              <a:t>Keller, CUREM Universität Zürich, 2025</a:t>
             </a:r>
             <a:endParaRPr lang="en-US" sz="800" dirty="0"/>
           </a:p>
@@ -5668,10 +5902,8 @@
             <a:off x="457200" y="1280160"/>
             <a:ext cx="2651760" cy="2286000"/>
           </a:xfrm>
-          <a:prstGeom prst="roundRect">
-            <a:avLst>
-              <a:gd name="adj" fmla="val 5600"/>
-            </a:avLst>
+          <a:prstGeom prst="rect">
+            <a:avLst/>
           </a:prstGeom>
           <a:solidFill>
             <a:srgbClr val="FFFFFF"/>
@@ -5812,10 +6044,8 @@
             <a:off x="3246120" y="1280160"/>
             <a:ext cx="2651760" cy="2286000"/>
           </a:xfrm>
-          <a:prstGeom prst="roundRect">
-            <a:avLst>
-              <a:gd name="adj" fmla="val 5600"/>
-            </a:avLst>
+          <a:prstGeom prst="rect">
+            <a:avLst/>
           </a:prstGeom>
           <a:solidFill>
             <a:srgbClr val="FDEBDD"/>
@@ -5956,10 +6186,8 @@
             <a:off x="6035040" y="1280160"/>
             <a:ext cx="2651760" cy="2286000"/>
           </a:xfrm>
-          <a:prstGeom prst="roundRect">
-            <a:avLst>
-              <a:gd name="adj" fmla="val 5600"/>
-            </a:avLst>
+          <a:prstGeom prst="rect">
+            <a:avLst/>
           </a:prstGeom>
           <a:solidFill>
             <a:srgbClr val="E2ECEE"/>
@@ -6100,10 +6328,8 @@
             <a:off x="457200" y="3703320"/>
             <a:ext cx="1988820" cy="914400"/>
           </a:xfrm>
-          <a:prstGeom prst="roundRect">
-            <a:avLst>
-              <a:gd name="adj" fmla="val 14000"/>
-            </a:avLst>
+          <a:prstGeom prst="rect">
+            <a:avLst/>
           </a:prstGeom>
           <a:solidFill>
             <a:srgbClr val="FFFFFF"/>
@@ -6127,7 +6353,7 @@
             <a:off x="594360" y="3831336"/>
             <a:ext cx="128016" cy="128016"/>
           </a:xfrm>
-          <a:prstGeom prst="ellipse">
+          <a:prstGeom prst="rect">
             <a:avLst/>
           </a:prstGeom>
           <a:solidFill>
@@ -6230,10 +6456,8 @@
             <a:off x="2537460" y="3703320"/>
             <a:ext cx="1988820" cy="914400"/>
           </a:xfrm>
-          <a:prstGeom prst="roundRect">
-            <a:avLst>
-              <a:gd name="adj" fmla="val 14000"/>
-            </a:avLst>
+          <a:prstGeom prst="rect">
+            <a:avLst/>
           </a:prstGeom>
           <a:solidFill>
             <a:srgbClr val="FFFFFF"/>
@@ -6257,7 +6481,7 @@
             <a:off x="2674620" y="3831336"/>
             <a:ext cx="128016" cy="128016"/>
           </a:xfrm>
-          <a:prstGeom prst="ellipse">
+          <a:prstGeom prst="rect">
             <a:avLst/>
           </a:prstGeom>
           <a:solidFill>
@@ -6360,10 +6584,8 @@
             <a:off x="4617720" y="3703320"/>
             <a:ext cx="1988820" cy="914400"/>
           </a:xfrm>
-          <a:prstGeom prst="roundRect">
-            <a:avLst>
-              <a:gd name="adj" fmla="val 14000"/>
-            </a:avLst>
+          <a:prstGeom prst="rect">
+            <a:avLst/>
           </a:prstGeom>
           <a:solidFill>
             <a:srgbClr val="FFFFFF"/>
@@ -6387,7 +6609,7 @@
             <a:off x="4754880" y="3831336"/>
             <a:ext cx="128016" cy="128016"/>
           </a:xfrm>
-          <a:prstGeom prst="ellipse">
+          <a:prstGeom prst="rect">
             <a:avLst/>
           </a:prstGeom>
           <a:solidFill>
@@ -6490,10 +6712,8 @@
             <a:off x="6697980" y="3703320"/>
             <a:ext cx="1988820" cy="914400"/>
           </a:xfrm>
-          <a:prstGeom prst="roundRect">
-            <a:avLst>
-              <a:gd name="adj" fmla="val 14000"/>
-            </a:avLst>
+          <a:prstGeom prst="rect">
+            <a:avLst/>
           </a:prstGeom>
           <a:solidFill>
             <a:srgbClr val="FFFFFF"/>
@@ -6517,7 +6737,7 @@
             <a:off x="6835140" y="3831336"/>
             <a:ext cx="128016" cy="128016"/>
           </a:xfrm>
-          <a:prstGeom prst="ellipse">
+          <a:prstGeom prst="rect">
             <a:avLst/>
           </a:prstGeom>
           <a:solidFill>
@@ -6728,10 +6948,8 @@
             <a:off x="457200" y="1280160"/>
             <a:ext cx="4023360" cy="530352"/>
           </a:xfrm>
-          <a:prstGeom prst="roundRect">
-            <a:avLst>
-              <a:gd name="adj" fmla="val 24138"/>
-            </a:avLst>
+          <a:prstGeom prst="rect">
+            <a:avLst/>
           </a:prstGeom>
           <a:solidFill>
             <a:srgbClr val="FFFFFF"/>
@@ -6752,8 +6970,8 @@
         </p:nvSpPr>
         <p:spPr>
           <a:xfrm>
-            <a:off x="457200" y="1389888"/>
-            <a:ext cx="54864" cy="310896"/>
+            <a:off x="457200" y="1280160"/>
+            <a:ext cx="64008" cy="530352"/>
           </a:xfrm>
           <a:prstGeom prst="rect">
             <a:avLst/>
@@ -6777,7 +6995,7 @@
         </p:nvSpPr>
         <p:spPr>
           <a:xfrm>
-            <a:off x="640080" y="1280160"/>
+            <a:off x="658368" y="1280160"/>
             <a:ext cx="1234440" cy="530352"/>
           </a:xfrm>
           <a:prstGeom prst="rect">
@@ -6816,8 +7034,8 @@
         </p:nvSpPr>
         <p:spPr>
           <a:xfrm>
-            <a:off x="1874520" y="1280160"/>
-            <a:ext cx="2514600" cy="530352"/>
+            <a:off x="1892808" y="1280160"/>
+            <a:ext cx="2496312" cy="530352"/>
           </a:xfrm>
           <a:prstGeom prst="rect">
             <a:avLst/>
@@ -6858,10 +7076,8 @@
             <a:off x="457200" y="1883664"/>
             <a:ext cx="4023360" cy="530352"/>
           </a:xfrm>
-          <a:prstGeom prst="roundRect">
-            <a:avLst>
-              <a:gd name="adj" fmla="val 24138"/>
-            </a:avLst>
+          <a:prstGeom prst="rect">
+            <a:avLst/>
           </a:prstGeom>
           <a:solidFill>
             <a:srgbClr val="FFFFFF"/>
@@ -6882,8 +7098,8 @@
         </p:nvSpPr>
         <p:spPr>
           <a:xfrm>
-            <a:off x="457200" y="1993392"/>
-            <a:ext cx="54864" cy="310896"/>
+            <a:off x="457200" y="1883664"/>
+            <a:ext cx="64008" cy="530352"/>
           </a:xfrm>
           <a:prstGeom prst="rect">
             <a:avLst/>
@@ -6907,7 +7123,7 @@
         </p:nvSpPr>
         <p:spPr>
           <a:xfrm>
-            <a:off x="640080" y="1883664"/>
+            <a:off x="658368" y="1883664"/>
             <a:ext cx="1234440" cy="530352"/>
           </a:xfrm>
           <a:prstGeom prst="rect">
@@ -6946,8 +7162,8 @@
         </p:nvSpPr>
         <p:spPr>
           <a:xfrm>
-            <a:off x="1874520" y="1883664"/>
-            <a:ext cx="2514600" cy="530352"/>
+            <a:off x="1892808" y="1883664"/>
+            <a:ext cx="2496312" cy="530352"/>
           </a:xfrm>
           <a:prstGeom prst="rect">
             <a:avLst/>
@@ -6988,10 +7204,8 @@
             <a:off x="457200" y="2487168"/>
             <a:ext cx="4023360" cy="530352"/>
           </a:xfrm>
-          <a:prstGeom prst="roundRect">
-            <a:avLst>
-              <a:gd name="adj" fmla="val 24138"/>
-            </a:avLst>
+          <a:prstGeom prst="rect">
+            <a:avLst/>
           </a:prstGeom>
           <a:solidFill>
             <a:srgbClr val="FFFFFF"/>
@@ -7012,8 +7226,8 @@
         </p:nvSpPr>
         <p:spPr>
           <a:xfrm>
-            <a:off x="457200" y="2596896"/>
-            <a:ext cx="54864" cy="310896"/>
+            <a:off x="457200" y="2487168"/>
+            <a:ext cx="64008" cy="530352"/>
           </a:xfrm>
           <a:prstGeom prst="rect">
             <a:avLst/>
@@ -7037,7 +7251,7 @@
         </p:nvSpPr>
         <p:spPr>
           <a:xfrm>
-            <a:off x="640080" y="2487168"/>
+            <a:off x="658368" y="2487168"/>
             <a:ext cx="1234440" cy="530352"/>
           </a:xfrm>
           <a:prstGeom prst="rect">
@@ -7076,8 +7290,8 @@
         </p:nvSpPr>
         <p:spPr>
           <a:xfrm>
-            <a:off x="1874520" y="2487168"/>
-            <a:ext cx="2514600" cy="530352"/>
+            <a:off x="1892808" y="2487168"/>
+            <a:ext cx="2496312" cy="530352"/>
           </a:xfrm>
           <a:prstGeom prst="rect">
             <a:avLst/>
@@ -7118,10 +7332,8 @@
             <a:off x="457200" y="3090672"/>
             <a:ext cx="4023360" cy="530352"/>
           </a:xfrm>
-          <a:prstGeom prst="roundRect">
-            <a:avLst>
-              <a:gd name="adj" fmla="val 24138"/>
-            </a:avLst>
+          <a:prstGeom prst="rect">
+            <a:avLst/>
           </a:prstGeom>
           <a:solidFill>
             <a:srgbClr val="FFFFFF"/>
@@ -7142,8 +7354,8 @@
         </p:nvSpPr>
         <p:spPr>
           <a:xfrm>
-            <a:off x="457200" y="3200400"/>
-            <a:ext cx="54864" cy="310896"/>
+            <a:off x="457200" y="3090672"/>
+            <a:ext cx="64008" cy="530352"/>
           </a:xfrm>
           <a:prstGeom prst="rect">
             <a:avLst/>
@@ -7167,7 +7379,7 @@
         </p:nvSpPr>
         <p:spPr>
           <a:xfrm>
-            <a:off x="640080" y="3090672"/>
+            <a:off x="658368" y="3090672"/>
             <a:ext cx="1234440" cy="530352"/>
           </a:xfrm>
           <a:prstGeom prst="rect">
@@ -7206,8 +7418,8 @@
         </p:nvSpPr>
         <p:spPr>
           <a:xfrm>
-            <a:off x="1874520" y="3090672"/>
-            <a:ext cx="2514600" cy="530352"/>
+            <a:off x="1892808" y="3090672"/>
+            <a:ext cx="2496312" cy="530352"/>
           </a:xfrm>
           <a:prstGeom prst="rect">
             <a:avLst/>
@@ -7248,10 +7460,8 @@
             <a:off x="457200" y="3694176"/>
             <a:ext cx="4023360" cy="530352"/>
           </a:xfrm>
-          <a:prstGeom prst="roundRect">
-            <a:avLst>
-              <a:gd name="adj" fmla="val 24138"/>
-            </a:avLst>
+          <a:prstGeom prst="rect">
+            <a:avLst/>
           </a:prstGeom>
           <a:solidFill>
             <a:srgbClr val="FFFFFF"/>
@@ -7272,8 +7482,8 @@
         </p:nvSpPr>
         <p:spPr>
           <a:xfrm>
-            <a:off x="457200" y="3803904"/>
-            <a:ext cx="54864" cy="310896"/>
+            <a:off x="457200" y="3694176"/>
+            <a:ext cx="64008" cy="530352"/>
           </a:xfrm>
           <a:prstGeom prst="rect">
             <a:avLst/>
@@ -7297,7 +7507,7 @@
         </p:nvSpPr>
         <p:spPr>
           <a:xfrm>
-            <a:off x="640080" y="3694176"/>
+            <a:off x="658368" y="3694176"/>
             <a:ext cx="1234440" cy="530352"/>
           </a:xfrm>
           <a:prstGeom prst="rect">
@@ -7336,8 +7546,8 @@
         </p:nvSpPr>
         <p:spPr>
           <a:xfrm>
-            <a:off x="1874520" y="3694176"/>
-            <a:ext cx="2514600" cy="530352"/>
+            <a:off x="1892808" y="3694176"/>
+            <a:ext cx="2496312" cy="530352"/>
           </a:xfrm>
           <a:prstGeom prst="rect">
             <a:avLst/>
@@ -7378,10 +7588,8 @@
             <a:off x="4663440" y="1280160"/>
             <a:ext cx="4023360" cy="3291840"/>
           </a:xfrm>
-          <a:prstGeom prst="roundRect">
-            <a:avLst>
-              <a:gd name="adj" fmla="val 3889"/>
-            </a:avLst>
+          <a:prstGeom prst="rect">
+            <a:avLst/>
           </a:prstGeom>
           <a:solidFill>
             <a:srgbClr val="24414A"/>
@@ -7444,10 +7652,8 @@
             <a:off x="4892040" y="1755648"/>
             <a:ext cx="310896" cy="310896"/>
           </a:xfrm>
-          <a:prstGeom prst="roundRect">
-            <a:avLst>
-              <a:gd name="adj" fmla="val 23529"/>
-            </a:avLst>
+          <a:prstGeom prst="rect">
+            <a:avLst/>
           </a:prstGeom>
           <a:solidFill>
             <a:srgbClr val="F26A1B"/>
@@ -7588,10 +7794,8 @@
             <a:off x="4892040" y="2450592"/>
             <a:ext cx="310896" cy="310896"/>
           </a:xfrm>
-          <a:prstGeom prst="roundRect">
-            <a:avLst>
-              <a:gd name="adj" fmla="val 23529"/>
-            </a:avLst>
+          <a:prstGeom prst="rect">
+            <a:avLst/>
           </a:prstGeom>
           <a:solidFill>
             <a:srgbClr val="F26A1B"/>
@@ -7732,10 +7936,8 @@
             <a:off x="4892040" y="3145536"/>
             <a:ext cx="310896" cy="310896"/>
           </a:xfrm>
-          <a:prstGeom prst="roundRect">
-            <a:avLst>
-              <a:gd name="adj" fmla="val 23529"/>
-            </a:avLst>
+          <a:prstGeom prst="rect">
+            <a:avLst/>
           </a:prstGeom>
           <a:solidFill>
             <a:srgbClr val="F26A1B"/>
@@ -7876,10 +8078,8 @@
             <a:off x="4892040" y="3840480"/>
             <a:ext cx="310896" cy="310896"/>
           </a:xfrm>
-          <a:prstGeom prst="roundRect">
-            <a:avLst>
-              <a:gd name="adj" fmla="val 23529"/>
-            </a:avLst>
+          <a:prstGeom prst="rect">
+            <a:avLst/>
           </a:prstGeom>
           <a:solidFill>
             <a:srgbClr val="F26A1B"/>
@@ -8111,7 +8311,7 @@
                   <a:schemeClr val="tx1"/>
                 </a:solidFill>
               </a:rPr>
-              <a:t>ROCHADE plant die Rochade. Für Verwaltung und Bewohnende.</a:t>
+              <a:t>ROCHADE plant die Rochade. Vier Regeln, jeder Konflikt mit Vorschlag.</a:t>
             </a:r>
             <a:endParaRPr lang="en-US" sz="3000" dirty="0"/>
           </a:p>
@@ -8126,12 +8326,10 @@
         <p:spPr>
           <a:xfrm>
             <a:off x="457200" y="1280160"/>
-            <a:ext cx="5760720" cy="2880360"/>
-          </a:xfrm>
-          <a:prstGeom prst="roundRect">
-            <a:avLst>
-              <a:gd name="adj" fmla="val 4444"/>
-            </a:avLst>
+            <a:ext cx="5760720" cy="2788920"/>
+          </a:xfrm>
+          <a:prstGeom prst="rect">
+            <a:avLst/>
           </a:prstGeom>
           <a:solidFill>
             <a:srgbClr val="FFFFFF"/>
@@ -8146,7 +8344,7 @@
       </p:sp>
       <p:pic>
         <p:nvPicPr>
-          <p:cNvPr id="4" name="Image 0" descr="/private/tmp/claude-501/-Users-francescorocca--claude-spares-spare-pTP7p5/c9c54887-e9ac-44ae-bd9c-ebf5f8016333/scratchpad/deck/img/stage-crop.png">    </p:cNvPr>
+          <p:cNvPr id="4" name="Image 0" descr="/private/tmp/claude-501/-Users-francescorocca--claude-spares-spare-pTP7p5/c9c54887-e9ac-44ae-bd9c-ebf5f8016333/scratchpad/deck/img/stage-square-crop.png">    </p:cNvPr>
           <p:cNvPicPr>
             <a:picLocks noChangeAspect="1"/>
           </p:cNvPicPr>
@@ -8160,7 +8358,7 @@
         <p:spPr>
           <a:xfrm>
             <a:off x="566928" y="1371600"/>
-            <a:ext cx="5541264" cy="2697480"/>
+            <a:ext cx="5541264" cy="2606040"/>
           </a:xfrm>
           <a:prstGeom prst="rect">
             <a:avLst/>
@@ -8169,14 +8367,426 @@
       </p:pic>
       <p:sp>
         <p:nvSpPr>
-          <p:cNvPr id="5" name="Text 2"/>
-          <p:cNvSpPr txBox="1"/>
-          <p:nvPr/>
-        </p:nvSpPr>
-        <p:spPr>
-          <a:xfrm>
-            <a:off x="457200" y="4224528"/>
-            <a:ext cx="5760720" cy="411480"/>
+          <p:cNvPr id="5" name="Shape 2"/>
+          <p:cNvSpPr/>
+          <p:nvPr/>
+        </p:nvSpPr>
+        <p:spPr>
+          <a:xfrm>
+            <a:off x="457200" y="4160520"/>
+            <a:ext cx="274320" cy="274320"/>
+          </a:xfrm>
+          <a:prstGeom prst="rect">
+            <a:avLst/>
+          </a:prstGeom>
+          <a:solidFill>
+            <a:srgbClr val="1C2326"/>
+          </a:solidFill>
+          <a:ln w="12700">
+            <a:solidFill>
+              <a:srgbClr val="1C2326"/>
+            </a:solidFill>
+            <a:prstDash val="solid"/>
+          </a:ln>
+        </p:spPr>
+      </p:sp>
+      <p:sp>
+        <p:nvSpPr>
+          <p:cNvPr id="6" name="Text 3"/>
+          <p:cNvSpPr txBox="1"/>
+          <p:nvPr/>
+        </p:nvSpPr>
+        <p:spPr>
+          <a:xfrm>
+            <a:off x="457200" y="4160520"/>
+            <a:ext cx="274320" cy="274320"/>
+          </a:xfrm>
+          <a:prstGeom prst="rect">
+            <a:avLst/>
+          </a:prstGeom>
+          <a:noFill/>
+          <a:ln/>
+        </p:spPr>
+        <p:txBody>
+          <a:bodyPr wrap="square" lIns="0" tIns="0" rIns="0" bIns="0" rtlCol="0" anchor="ctr"/>
+          <a:lstStyle/>
+          <a:p>
+            <a:pPr algn="ctr" indent="0" marL="0">
+              <a:buNone/>
+            </a:pPr>
+            <a:r>
+              <a:rPr lang="en-US" sz="1000" b="1" dirty="0">
+                <a:solidFill>
+                  <a:srgbClr val="FFFFFF"/>
+                </a:solidFill>
+                <a:latin typeface="Arial" pitchFamily="34" charset="0"/>
+                <a:ea typeface="Arial" pitchFamily="34" charset="-122"/>
+                <a:cs typeface="Arial" pitchFamily="34" charset="-120"/>
+              </a:rPr>
+              <a:t>1</a:t>
+            </a:r>
+            <a:endParaRPr lang="en-US" sz="1000" dirty="0"/>
+          </a:p>
+        </p:txBody>
+      </p:sp>
+      <p:sp>
+        <p:nvSpPr>
+          <p:cNvPr id="7" name="Text 4"/>
+          <p:cNvSpPr txBox="1"/>
+          <p:nvPr/>
+        </p:nvSpPr>
+        <p:spPr>
+          <a:xfrm>
+            <a:off x="786384" y="4160520"/>
+            <a:ext cx="1115568" cy="274320"/>
+          </a:xfrm>
+          <a:prstGeom prst="rect">
+            <a:avLst/>
+          </a:prstGeom>
+          <a:noFill/>
+          <a:ln/>
+        </p:spPr>
+        <p:txBody>
+          <a:bodyPr wrap="square" lIns="0" tIns="0" rIns="0" bIns="0" rtlCol="0" anchor="ctr"/>
+          <a:lstStyle/>
+          <a:p>
+            <a:pPr indent="0" marL="0">
+              <a:buNone/>
+            </a:pPr>
+            <a:r>
+              <a:rPr lang="en-US" sz="950" b="1" dirty="0">
+                <a:solidFill>
+                  <a:srgbClr val="1C2326"/>
+                </a:solidFill>
+                <a:latin typeface="Arial" pitchFamily="34" charset="0"/>
+                <a:ea typeface="Arial" pitchFamily="34" charset="-122"/>
+                <a:cs typeface="Arial" pitchFamily="34" charset="-120"/>
+              </a:rPr>
+              <a:t>Zimmerzahl</a:t>
+            </a:r>
+            <a:endParaRPr lang="en-US" sz="950" dirty="0"/>
+          </a:p>
+        </p:txBody>
+      </p:sp>
+      <p:sp>
+        <p:nvSpPr>
+          <p:cNvPr id="8" name="Shape 5"/>
+          <p:cNvSpPr/>
+          <p:nvPr/>
+        </p:nvSpPr>
+        <p:spPr>
+          <a:xfrm>
+            <a:off x="1920240" y="4160520"/>
+            <a:ext cx="274320" cy="274320"/>
+          </a:xfrm>
+          <a:prstGeom prst="rect">
+            <a:avLst/>
+          </a:prstGeom>
+          <a:solidFill>
+            <a:srgbClr val="1C2326"/>
+          </a:solidFill>
+          <a:ln w="12700">
+            <a:solidFill>
+              <a:srgbClr val="1C2326"/>
+            </a:solidFill>
+            <a:prstDash val="solid"/>
+          </a:ln>
+        </p:spPr>
+      </p:sp>
+      <p:sp>
+        <p:nvSpPr>
+          <p:cNvPr id="9" name="Text 6"/>
+          <p:cNvSpPr txBox="1"/>
+          <p:nvPr/>
+        </p:nvSpPr>
+        <p:spPr>
+          <a:xfrm>
+            <a:off x="1920240" y="4160520"/>
+            <a:ext cx="274320" cy="274320"/>
+          </a:xfrm>
+          <a:prstGeom prst="rect">
+            <a:avLst/>
+          </a:prstGeom>
+          <a:noFill/>
+          <a:ln/>
+        </p:spPr>
+        <p:txBody>
+          <a:bodyPr wrap="square" lIns="0" tIns="0" rIns="0" bIns="0" rtlCol="0" anchor="ctr"/>
+          <a:lstStyle/>
+          <a:p>
+            <a:pPr algn="ctr" indent="0" marL="0">
+              <a:buNone/>
+            </a:pPr>
+            <a:r>
+              <a:rPr lang="en-US" sz="1000" b="1" dirty="0">
+                <a:solidFill>
+                  <a:srgbClr val="FFFFFF"/>
+                </a:solidFill>
+                <a:latin typeface="Arial" pitchFamily="34" charset="0"/>
+                <a:ea typeface="Arial" pitchFamily="34" charset="-122"/>
+                <a:cs typeface="Arial" pitchFamily="34" charset="-120"/>
+              </a:rPr>
+              <a:t>2</a:t>
+            </a:r>
+            <a:endParaRPr lang="en-US" sz="1000" dirty="0"/>
+          </a:p>
+        </p:txBody>
+      </p:sp>
+      <p:sp>
+        <p:nvSpPr>
+          <p:cNvPr id="10" name="Text 7"/>
+          <p:cNvSpPr txBox="1"/>
+          <p:nvPr/>
+        </p:nvSpPr>
+        <p:spPr>
+          <a:xfrm>
+            <a:off x="2249424" y="4160520"/>
+            <a:ext cx="1115568" cy="274320"/>
+          </a:xfrm>
+          <a:prstGeom prst="rect">
+            <a:avLst/>
+          </a:prstGeom>
+          <a:noFill/>
+          <a:ln/>
+        </p:spPr>
+        <p:txBody>
+          <a:bodyPr wrap="square" lIns="0" tIns="0" rIns="0" bIns="0" rtlCol="0" anchor="ctr"/>
+          <a:lstStyle/>
+          <a:p>
+            <a:pPr indent="0" marL="0">
+              <a:buNone/>
+            </a:pPr>
+            <a:r>
+              <a:rPr lang="en-US" sz="950" b="1" dirty="0">
+                <a:solidFill>
+                  <a:srgbClr val="1C2326"/>
+                </a:solidFill>
+                <a:latin typeface="Arial" pitchFamily="34" charset="0"/>
+                <a:ea typeface="Arial" pitchFamily="34" charset="-122"/>
+                <a:cs typeface="Arial" pitchFamily="34" charset="-120"/>
+              </a:rPr>
+              <a:t>Hindernisfrei</a:t>
+            </a:r>
+            <a:endParaRPr lang="en-US" sz="950" dirty="0"/>
+          </a:p>
+        </p:txBody>
+      </p:sp>
+      <p:sp>
+        <p:nvSpPr>
+          <p:cNvPr id="11" name="Shape 8"/>
+          <p:cNvSpPr/>
+          <p:nvPr/>
+        </p:nvSpPr>
+        <p:spPr>
+          <a:xfrm>
+            <a:off x="3383280" y="4160520"/>
+            <a:ext cx="274320" cy="274320"/>
+          </a:xfrm>
+          <a:prstGeom prst="rect">
+            <a:avLst/>
+          </a:prstGeom>
+          <a:solidFill>
+            <a:srgbClr val="1C2326"/>
+          </a:solidFill>
+          <a:ln w="12700">
+            <a:solidFill>
+              <a:srgbClr val="1C2326"/>
+            </a:solidFill>
+            <a:prstDash val="solid"/>
+          </a:ln>
+        </p:spPr>
+      </p:sp>
+      <p:sp>
+        <p:nvSpPr>
+          <p:cNvPr id="12" name="Text 9"/>
+          <p:cNvSpPr txBox="1"/>
+          <p:nvPr/>
+        </p:nvSpPr>
+        <p:spPr>
+          <a:xfrm>
+            <a:off x="3383280" y="4160520"/>
+            <a:ext cx="274320" cy="274320"/>
+          </a:xfrm>
+          <a:prstGeom prst="rect">
+            <a:avLst/>
+          </a:prstGeom>
+          <a:noFill/>
+          <a:ln/>
+        </p:spPr>
+        <p:txBody>
+          <a:bodyPr wrap="square" lIns="0" tIns="0" rIns="0" bIns="0" rtlCol="0" anchor="ctr"/>
+          <a:lstStyle/>
+          <a:p>
+            <a:pPr algn="ctr" indent="0" marL="0">
+              <a:buNone/>
+            </a:pPr>
+            <a:r>
+              <a:rPr lang="en-US" sz="1000" b="1" dirty="0">
+                <a:solidFill>
+                  <a:srgbClr val="FFFFFF"/>
+                </a:solidFill>
+                <a:latin typeface="Arial" pitchFamily="34" charset="0"/>
+                <a:ea typeface="Arial" pitchFamily="34" charset="-122"/>
+                <a:cs typeface="Arial" pitchFamily="34" charset="-120"/>
+              </a:rPr>
+              <a:t>3</a:t>
+            </a:r>
+            <a:endParaRPr lang="en-US" sz="1000" dirty="0"/>
+          </a:p>
+        </p:txBody>
+      </p:sp>
+      <p:sp>
+        <p:nvSpPr>
+          <p:cNvPr id="13" name="Text 10"/>
+          <p:cNvSpPr txBox="1"/>
+          <p:nvPr/>
+        </p:nvSpPr>
+        <p:spPr>
+          <a:xfrm>
+            <a:off x="3712464" y="4160520"/>
+            <a:ext cx="1115568" cy="274320"/>
+          </a:xfrm>
+          <a:prstGeom prst="rect">
+            <a:avLst/>
+          </a:prstGeom>
+          <a:noFill/>
+          <a:ln/>
+        </p:spPr>
+        <p:txBody>
+          <a:bodyPr wrap="square" lIns="0" tIns="0" rIns="0" bIns="0" rtlCol="0" anchor="ctr"/>
+          <a:lstStyle/>
+          <a:p>
+            <a:pPr indent="0" marL="0">
+              <a:buNone/>
+            </a:pPr>
+            <a:r>
+              <a:rPr lang="en-US" sz="950" b="1" dirty="0">
+                <a:solidFill>
+                  <a:srgbClr val="1C2326"/>
+                </a:solidFill>
+                <a:latin typeface="Arial" pitchFamily="34" charset="0"/>
+                <a:ea typeface="Arial" pitchFamily="34" charset="-122"/>
+                <a:cs typeface="Arial" pitchFamily="34" charset="-120"/>
+              </a:rPr>
+              <a:t>Zeitfenster</a:t>
+            </a:r>
+            <a:endParaRPr lang="en-US" sz="950" dirty="0"/>
+          </a:p>
+        </p:txBody>
+      </p:sp>
+      <p:sp>
+        <p:nvSpPr>
+          <p:cNvPr id="14" name="Shape 11"/>
+          <p:cNvSpPr/>
+          <p:nvPr/>
+        </p:nvSpPr>
+        <p:spPr>
+          <a:xfrm>
+            <a:off x="4846320" y="4160520"/>
+            <a:ext cx="274320" cy="274320"/>
+          </a:xfrm>
+          <a:prstGeom prst="rect">
+            <a:avLst/>
+          </a:prstGeom>
+          <a:solidFill>
+            <a:srgbClr val="1C2326"/>
+          </a:solidFill>
+          <a:ln w="12700">
+            <a:solidFill>
+              <a:srgbClr val="1C2326"/>
+            </a:solidFill>
+            <a:prstDash val="solid"/>
+          </a:ln>
+        </p:spPr>
+      </p:sp>
+      <p:sp>
+        <p:nvSpPr>
+          <p:cNvPr id="15" name="Text 12"/>
+          <p:cNvSpPr txBox="1"/>
+          <p:nvPr/>
+        </p:nvSpPr>
+        <p:spPr>
+          <a:xfrm>
+            <a:off x="4846320" y="4160520"/>
+            <a:ext cx="274320" cy="274320"/>
+          </a:xfrm>
+          <a:prstGeom prst="rect">
+            <a:avLst/>
+          </a:prstGeom>
+          <a:noFill/>
+          <a:ln/>
+        </p:spPr>
+        <p:txBody>
+          <a:bodyPr wrap="square" lIns="0" tIns="0" rIns="0" bIns="0" rtlCol="0" anchor="ctr"/>
+          <a:lstStyle/>
+          <a:p>
+            <a:pPr algn="ctr" indent="0" marL="0">
+              <a:buNone/>
+            </a:pPr>
+            <a:r>
+              <a:rPr lang="en-US" sz="1000" b="1" dirty="0">
+                <a:solidFill>
+                  <a:srgbClr val="FFFFFF"/>
+                </a:solidFill>
+                <a:latin typeface="Arial" pitchFamily="34" charset="0"/>
+                <a:ea typeface="Arial" pitchFamily="34" charset="-122"/>
+                <a:cs typeface="Arial" pitchFamily="34" charset="-120"/>
+              </a:rPr>
+              <a:t>4</a:t>
+            </a:r>
+            <a:endParaRPr lang="en-US" sz="1000" dirty="0"/>
+          </a:p>
+        </p:txBody>
+      </p:sp>
+      <p:sp>
+        <p:nvSpPr>
+          <p:cNvPr id="16" name="Text 13"/>
+          <p:cNvSpPr txBox="1"/>
+          <p:nvPr/>
+        </p:nvSpPr>
+        <p:spPr>
+          <a:xfrm>
+            <a:off x="5175504" y="4160520"/>
+            <a:ext cx="1115568" cy="274320"/>
+          </a:xfrm>
+          <a:prstGeom prst="rect">
+            <a:avLst/>
+          </a:prstGeom>
+          <a:noFill/>
+          <a:ln/>
+        </p:spPr>
+        <p:txBody>
+          <a:bodyPr wrap="square" lIns="0" tIns="0" rIns="0" bIns="0" rtlCol="0" anchor="ctr"/>
+          <a:lstStyle/>
+          <a:p>
+            <a:pPr indent="0" marL="0">
+              <a:buNone/>
+            </a:pPr>
+            <a:r>
+              <a:rPr lang="en-US" sz="950" b="1" dirty="0">
+                <a:solidFill>
+                  <a:srgbClr val="1C2326"/>
+                </a:solidFill>
+                <a:latin typeface="Arial" pitchFamily="34" charset="0"/>
+                <a:ea typeface="Arial" pitchFamily="34" charset="-122"/>
+                <a:cs typeface="Arial" pitchFamily="34" charset="-120"/>
+              </a:rPr>
+              <a:t>Keine Doppelbelegung</a:t>
+            </a:r>
+            <a:endParaRPr lang="en-US" sz="950" dirty="0"/>
+          </a:p>
+        </p:txBody>
+      </p:sp>
+      <p:sp>
+        <p:nvSpPr>
+          <p:cNvPr id="17" name="Text 14"/>
+          <p:cNvSpPr txBox="1"/>
+          <p:nvPr/>
+        </p:nvSpPr>
+        <p:spPr>
+          <a:xfrm>
+            <a:off x="457200" y="4480560"/>
+            <a:ext cx="5760720" cy="292608"/>
           </a:xfrm>
           <a:prstGeom prst="rect">
             <a:avLst/>
@@ -8192,7 +8802,7 @@
               <a:buNone/>
             </a:pPr>
             <a:r>
-              <a:rPr lang="en-US" sz="1200" dirty="0">
+              <a:rPr lang="en-US" sz="900" dirty="0">
                 <a:solidFill>
                   <a:srgbClr val="5B6468"/>
                 </a:solidFill>
@@ -8200,15 +8810,15 @@
                 <a:ea typeface="Arial" pitchFamily="34" charset="-122"/>
                 <a:cs typeface="Arial" pitchFamily="34" charset="-120"/>
               </a:rPr>
-              <a:t>Verwaltung: die ganze Siedlung, jeder Haushalt, jede freie Wohnung. Ein Klick legt den Plan neu.</a:t>
-            </a:r>
-            <a:endParaRPr lang="en-US" sz="1200" dirty="0"/>
-          </a:p>
-        </p:txBody>
-      </p:sp>
-      <p:sp>
-        <p:nvSpPr>
-          <p:cNvPr id="6" name="Shape 3"/>
+              <a:t>Nie gebrochen. Verzögert sich Etappe 1 um zwei Monate: 11 Konflikte mit Namen und Grund, Vorschlag Etappe 2 ab November 2027. Ein Klick.</a:t>
+            </a:r>
+            <a:endParaRPr lang="en-US" sz="900" dirty="0"/>
+          </a:p>
+        </p:txBody>
+      </p:sp>
+      <p:sp>
+        <p:nvSpPr>
+          <p:cNvPr id="18" name="Shape 15"/>
           <p:cNvSpPr/>
           <p:nvPr/>
         </p:nvSpPr>
@@ -8242,7 +8852,7 @@
       </p:sp>
       <p:pic>
         <p:nvPicPr>
-          <p:cNvPr id="7" name="Image 1" descr="/private/tmp/claude-501/-Users-francescorocca--claude-spares-spare-pTP7p5/c9c54887-e9ac-44ae-bd9c-ebf5f8016333/scratchpad/deck/img/app-siedlung-round.png">    </p:cNvPr>
+          <p:cNvPr id="19" name="Image 1" descr="/private/tmp/claude-501/-Users-francescorocca--claude-spares-spare-pTP7p5/c9c54887-e9ac-44ae-bd9c-ebf5f8016333/scratchpad/deck/img/app-siedlung-round.png">    </p:cNvPr>
           <p:cNvPicPr>
             <a:picLocks noChangeAspect="1"/>
           </p:cNvPicPr>
@@ -8268,7 +8878,7 @@
       </p:pic>
       <p:sp>
         <p:nvSpPr>
-          <p:cNvPr id="8" name="Shape 4"/>
+          <p:cNvPr id="20" name="Shape 16"/>
           <p:cNvSpPr/>
           <p:nvPr/>
         </p:nvSpPr>
@@ -8302,7 +8912,7 @@
       </p:sp>
       <p:pic>
         <p:nvPicPr>
-          <p:cNvPr id="9" name="Image 2" descr="/private/tmp/claude-501/-Users-francescorocca--claude-spares-spare-pTP7p5/c9c54887-e9ac-44ae-bd9c-ebf5f8016333/scratchpad/deck/img/app-mein-umzug-round.png">    </p:cNvPr>
+          <p:cNvPr id="21" name="Image 2" descr="/private/tmp/claude-501/-Users-francescorocca--claude-spares-spare-pTP7p5/c9c54887-e9ac-44ae-bd9c-ebf5f8016333/scratchpad/deck/img/app-mein-umzug-round.png">    </p:cNvPr>
           <p:cNvPicPr>
             <a:picLocks noChangeAspect="1"/>
           </p:cNvPicPr>
@@ -8326,7 +8936,7 @@
       </p:pic>
       <p:sp>
         <p:nvSpPr>
-          <p:cNvPr id="10" name="Text 5"/>
+          <p:cNvPr id="22" name="Text 17"/>
           <p:cNvSpPr txBox="1"/>
           <p:nvPr/>
         </p:nvSpPr>
@@ -8465,7 +9075,7 @@
                   <a:schemeClr val="tx1"/>
                 </a:solidFill>
               </a:rPr>
-              <a:t>Vier Regeln. Jeder Konflikt mit Namen, Grund und Vorschlag.</a:t>
+              <a:t>Wie wir Geld verdienen: pro Sanierungsprojekt, von der Eigentümerschaft.</a:t>
             </a:r>
             <a:endParaRPr lang="en-US" sz="3000" dirty="0"/>
           </a:p>
@@ -8479,13 +9089,526 @@
         </p:nvSpPr>
         <p:spPr>
           <a:xfrm>
-            <a:off x="457200" y="1325880"/>
-            <a:ext cx="384048" cy="384048"/>
-          </a:xfrm>
-          <a:prstGeom prst="roundRect">
-            <a:avLst>
-              <a:gd name="adj" fmla="val 19048"/>
-            </a:avLst>
+            <a:off x="457200" y="1280160"/>
+            <a:ext cx="1783080" cy="2240280"/>
+          </a:xfrm>
+          <a:prstGeom prst="rect">
+            <a:avLst/>
+          </a:prstGeom>
+          <a:solidFill>
+            <a:srgbClr val="FDEBDD"/>
+          </a:solidFill>
+          <a:ln w="12700">
+            <a:solidFill>
+              <a:srgbClr val="FDEBDD"/>
+            </a:solidFill>
+            <a:prstDash val="solid"/>
+          </a:ln>
+        </p:spPr>
+      </p:sp>
+      <p:sp>
+        <p:nvSpPr>
+          <p:cNvPr id="4" name="Shape 2"/>
+          <p:cNvSpPr/>
+          <p:nvPr/>
+        </p:nvSpPr>
+        <p:spPr>
+          <a:xfrm>
+            <a:off x="594360" y="1389888"/>
+            <a:ext cx="274320" cy="274320"/>
+          </a:xfrm>
+          <a:prstGeom prst="rect">
+            <a:avLst/>
+          </a:prstGeom>
+          <a:solidFill>
+            <a:srgbClr val="B8460E"/>
+          </a:solidFill>
+          <a:ln w="12700">
+            <a:solidFill>
+              <a:srgbClr val="B8460E"/>
+            </a:solidFill>
+            <a:prstDash val="solid"/>
+          </a:ln>
+        </p:spPr>
+      </p:sp>
+      <p:sp>
+        <p:nvSpPr>
+          <p:cNvPr id="5" name="Text 3"/>
+          <p:cNvSpPr txBox="1"/>
+          <p:nvPr/>
+        </p:nvSpPr>
+        <p:spPr>
+          <a:xfrm>
+            <a:off x="594360" y="1389888"/>
+            <a:ext cx="274320" cy="274320"/>
+          </a:xfrm>
+          <a:prstGeom prst="rect">
+            <a:avLst/>
+          </a:prstGeom>
+          <a:noFill/>
+          <a:ln/>
+        </p:spPr>
+        <p:txBody>
+          <a:bodyPr wrap="square" lIns="0" tIns="0" rIns="0" bIns="0" rtlCol="0" anchor="ctr"/>
+          <a:lstStyle/>
+          <a:p>
+            <a:pPr algn="ctr" indent="0" marL="0">
+              <a:buNone/>
+            </a:pPr>
+            <a:r>
+              <a:rPr lang="en-US" sz="1000" b="1" dirty="0">
+                <a:solidFill>
+                  <a:srgbClr val="FFFFFF"/>
+                </a:solidFill>
+                <a:latin typeface="Arial" pitchFamily="34" charset="0"/>
+                <a:ea typeface="Arial" pitchFamily="34" charset="-122"/>
+                <a:cs typeface="Arial" pitchFamily="34" charset="-120"/>
+              </a:rPr>
+              <a:t>1</a:t>
+            </a:r>
+            <a:endParaRPr lang="en-US" sz="1000" dirty="0"/>
+          </a:p>
+        </p:txBody>
+      </p:sp>
+      <p:sp>
+        <p:nvSpPr>
+          <p:cNvPr id="6" name="Text 4"/>
+          <p:cNvSpPr txBox="1"/>
+          <p:nvPr/>
+        </p:nvSpPr>
+        <p:spPr>
+          <a:xfrm>
+            <a:off x="960120" y="1389888"/>
+            <a:ext cx="1188720" cy="274320"/>
+          </a:xfrm>
+          <a:prstGeom prst="rect">
+            <a:avLst/>
+          </a:prstGeom>
+          <a:noFill/>
+          <a:ln/>
+        </p:spPr>
+        <p:txBody>
+          <a:bodyPr wrap="square" lIns="0" tIns="0" rIns="0" bIns="0" rtlCol="0" anchor="ctr"/>
+          <a:lstStyle/>
+          <a:p>
+            <a:pPr indent="0" marL="0">
+              <a:buNone/>
+            </a:pPr>
+            <a:r>
+              <a:rPr lang="en-US" sz="1100" b="1" dirty="0">
+                <a:solidFill>
+                  <a:srgbClr val="1C2326"/>
+                </a:solidFill>
+                <a:latin typeface="Arial" pitchFamily="34" charset="0"/>
+                <a:ea typeface="Arial" pitchFamily="34" charset="-122"/>
+                <a:cs typeface="Arial" pitchFamily="34" charset="-120"/>
+              </a:rPr>
+              <a:t>Projektlizenz</a:t>
+            </a:r>
+            <a:endParaRPr lang="en-US" sz="1100" dirty="0"/>
+          </a:p>
+        </p:txBody>
+      </p:sp>
+      <p:sp>
+        <p:nvSpPr>
+          <p:cNvPr id="7" name="Text 5"/>
+          <p:cNvSpPr txBox="1"/>
+          <p:nvPr/>
+        </p:nvSpPr>
+        <p:spPr>
+          <a:xfrm>
+            <a:off x="594360" y="1783080"/>
+            <a:ext cx="1554480" cy="502920"/>
+          </a:xfrm>
+          <a:prstGeom prst="rect">
+            <a:avLst/>
+          </a:prstGeom>
+          <a:noFill/>
+          <a:ln/>
+        </p:spPr>
+        <p:txBody>
+          <a:bodyPr wrap="square" lIns="0" tIns="0" rIns="0" bIns="0" rtlCol="0" anchor="t"/>
+          <a:lstStyle/>
+          <a:p>
+            <a:pPr indent="0" marL="0">
+              <a:buNone/>
+            </a:pPr>
+            <a:r>
+              <a:rPr lang="en-US" sz="1300" b="1" dirty="0">
+                <a:solidFill>
+                  <a:srgbClr val="B8460E"/>
+                </a:solidFill>
+                <a:latin typeface="Arial" pitchFamily="34" charset="0"/>
+                <a:ea typeface="Arial" pitchFamily="34" charset="-122"/>
+                <a:cs typeface="Arial" pitchFamily="34" charset="-120"/>
+              </a:rPr>
+              <a:t>1 ‰ der Sanierungssumme</a:t>
+            </a:r>
+            <a:endParaRPr lang="en-US" sz="1300" dirty="0"/>
+          </a:p>
+        </p:txBody>
+      </p:sp>
+      <p:sp>
+        <p:nvSpPr>
+          <p:cNvPr id="8" name="Text 6"/>
+          <p:cNvSpPr txBox="1"/>
+          <p:nvPr/>
+        </p:nvSpPr>
+        <p:spPr>
+          <a:xfrm>
+            <a:off x="594360" y="2304288"/>
+            <a:ext cx="1554480" cy="960120"/>
+          </a:xfrm>
+          <a:prstGeom prst="rect">
+            <a:avLst/>
+          </a:prstGeom>
+          <a:noFill/>
+          <a:ln/>
+        </p:spPr>
+        <p:txBody>
+          <a:bodyPr wrap="square" lIns="0" tIns="0" rIns="0" bIns="0" rtlCol="0" anchor="t"/>
+          <a:lstStyle/>
+          <a:p>
+            <a:pPr indent="0" marL="0">
+              <a:buNone/>
+            </a:pPr>
+            <a:r>
+              <a:rPr lang="en-US" sz="850" dirty="0">
+                <a:solidFill>
+                  <a:srgbClr val="1C2326"/>
+                </a:solidFill>
+                <a:latin typeface="Arial" pitchFamily="34" charset="0"/>
+                <a:ea typeface="Arial" pitchFamily="34" charset="-122"/>
+                <a:cs typeface="Arial" pitchFamily="34" charset="-120"/>
+              </a:rPr>
+              <a:t>mindestens CHF 5'000. Enthält Planung, Bewohner-App und Live-Updates. 10 Mio. → CHF 10'000.</a:t>
+            </a:r>
+            <a:endParaRPr lang="en-US" sz="850" dirty="0"/>
+          </a:p>
+        </p:txBody>
+      </p:sp>
+      <p:sp>
+        <p:nvSpPr>
+          <p:cNvPr id="9" name="Text 7"/>
+          <p:cNvSpPr txBox="1"/>
+          <p:nvPr/>
+        </p:nvSpPr>
+        <p:spPr>
+          <a:xfrm>
+            <a:off x="594360" y="3273552"/>
+            <a:ext cx="1554480" cy="182880"/>
+          </a:xfrm>
+          <a:prstGeom prst="rect">
+            <a:avLst/>
+          </a:prstGeom>
+          <a:noFill/>
+          <a:ln/>
+        </p:spPr>
+        <p:txBody>
+          <a:bodyPr wrap="square" lIns="0" tIns="0" rIns="0" bIns="0" rtlCol="0" anchor="ctr"/>
+          <a:lstStyle/>
+          <a:p>
+            <a:pPr indent="0" marL="0">
+              <a:buNone/>
+            </a:pPr>
+            <a:r>
+              <a:rPr lang="en-US" sz="750" dirty="0">
+                <a:solidFill>
+                  <a:srgbClr val="5B6468"/>
+                </a:solidFill>
+                <a:latin typeface="Arial" pitchFamily="34" charset="0"/>
+                <a:ea typeface="Arial" pitchFamily="34" charset="-122"/>
+                <a:cs typeface="Arial" pitchFamily="34" charset="-120"/>
+              </a:rPr>
+              <a:t>heute</a:t>
+            </a:r>
+            <a:endParaRPr lang="en-US" sz="750" dirty="0"/>
+          </a:p>
+        </p:txBody>
+      </p:sp>
+      <p:sp>
+        <p:nvSpPr>
+          <p:cNvPr id="10" name="Shape 8"/>
+          <p:cNvSpPr/>
+          <p:nvPr/>
+        </p:nvSpPr>
+        <p:spPr>
+          <a:xfrm>
+            <a:off x="2331720" y="1280160"/>
+            <a:ext cx="1783080" cy="2240280"/>
+          </a:xfrm>
+          <a:prstGeom prst="rect">
+            <a:avLst/>
+          </a:prstGeom>
+          <a:solidFill>
+            <a:srgbClr val="E2ECEE"/>
+          </a:solidFill>
+          <a:ln w="12700">
+            <a:solidFill>
+              <a:srgbClr val="E2ECEE"/>
+            </a:solidFill>
+            <a:prstDash val="solid"/>
+          </a:ln>
+        </p:spPr>
+      </p:sp>
+      <p:sp>
+        <p:nvSpPr>
+          <p:cNvPr id="11" name="Shape 9"/>
+          <p:cNvSpPr/>
+          <p:nvPr/>
+        </p:nvSpPr>
+        <p:spPr>
+          <a:xfrm>
+            <a:off x="2468880" y="1389888"/>
+            <a:ext cx="274320" cy="274320"/>
+          </a:xfrm>
+          <a:prstGeom prst="rect">
+            <a:avLst/>
+          </a:prstGeom>
+          <a:solidFill>
+            <a:srgbClr val="24414A"/>
+          </a:solidFill>
+          <a:ln w="12700">
+            <a:solidFill>
+              <a:srgbClr val="24414A"/>
+            </a:solidFill>
+            <a:prstDash val="solid"/>
+          </a:ln>
+        </p:spPr>
+      </p:sp>
+      <p:sp>
+        <p:nvSpPr>
+          <p:cNvPr id="12" name="Text 10"/>
+          <p:cNvSpPr txBox="1"/>
+          <p:nvPr/>
+        </p:nvSpPr>
+        <p:spPr>
+          <a:xfrm>
+            <a:off x="2468880" y="1389888"/>
+            <a:ext cx="274320" cy="274320"/>
+          </a:xfrm>
+          <a:prstGeom prst="rect">
+            <a:avLst/>
+          </a:prstGeom>
+          <a:noFill/>
+          <a:ln/>
+        </p:spPr>
+        <p:txBody>
+          <a:bodyPr wrap="square" lIns="0" tIns="0" rIns="0" bIns="0" rtlCol="0" anchor="ctr"/>
+          <a:lstStyle/>
+          <a:p>
+            <a:pPr algn="ctr" indent="0" marL="0">
+              <a:buNone/>
+            </a:pPr>
+            <a:r>
+              <a:rPr lang="en-US" sz="1000" b="1" dirty="0">
+                <a:solidFill>
+                  <a:srgbClr val="FFFFFF"/>
+                </a:solidFill>
+                <a:latin typeface="Arial" pitchFamily="34" charset="0"/>
+                <a:ea typeface="Arial" pitchFamily="34" charset="-122"/>
+                <a:cs typeface="Arial" pitchFamily="34" charset="-120"/>
+              </a:rPr>
+              <a:t>2</a:t>
+            </a:r>
+            <a:endParaRPr lang="en-US" sz="1000" dirty="0"/>
+          </a:p>
+        </p:txBody>
+      </p:sp>
+      <p:sp>
+        <p:nvSpPr>
+          <p:cNvPr id="13" name="Text 11"/>
+          <p:cNvSpPr txBox="1"/>
+          <p:nvPr/>
+        </p:nvSpPr>
+        <p:spPr>
+          <a:xfrm>
+            <a:off x="2834640" y="1389888"/>
+            <a:ext cx="1188720" cy="274320"/>
+          </a:xfrm>
+          <a:prstGeom prst="rect">
+            <a:avLst/>
+          </a:prstGeom>
+          <a:noFill/>
+          <a:ln/>
+        </p:spPr>
+        <p:txBody>
+          <a:bodyPr wrap="square" lIns="0" tIns="0" rIns="0" bIns="0" rtlCol="0" anchor="ctr"/>
+          <a:lstStyle/>
+          <a:p>
+            <a:pPr indent="0" marL="0">
+              <a:buNone/>
+            </a:pPr>
+            <a:r>
+              <a:rPr lang="en-US" sz="1100" b="1" dirty="0">
+                <a:solidFill>
+                  <a:srgbClr val="1C2326"/>
+                </a:solidFill>
+                <a:latin typeface="Arial" pitchFamily="34" charset="0"/>
+                <a:ea typeface="Arial" pitchFamily="34" charset="-122"/>
+                <a:cs typeface="Arial" pitchFamily="34" charset="-120"/>
+              </a:rPr>
+              <a:t>Nachweis-Dossier</a:t>
+            </a:r>
+            <a:endParaRPr lang="en-US" sz="1100" dirty="0"/>
+          </a:p>
+        </p:txBody>
+      </p:sp>
+      <p:sp>
+        <p:nvSpPr>
+          <p:cNvPr id="14" name="Text 12"/>
+          <p:cNvSpPr txBox="1"/>
+          <p:nvPr/>
+        </p:nvSpPr>
+        <p:spPr>
+          <a:xfrm>
+            <a:off x="2468880" y="1783080"/>
+            <a:ext cx="1554480" cy="502920"/>
+          </a:xfrm>
+          <a:prstGeom prst="rect">
+            <a:avLst/>
+          </a:prstGeom>
+          <a:noFill/>
+          <a:ln/>
+        </p:spPr>
+        <p:txBody>
+          <a:bodyPr wrap="square" lIns="0" tIns="0" rIns="0" bIns="0" rtlCol="0" anchor="t"/>
+          <a:lstStyle/>
+          <a:p>
+            <a:pPr indent="0" marL="0">
+              <a:buNone/>
+            </a:pPr>
+            <a:r>
+              <a:rPr lang="en-US" sz="1300" b="1" dirty="0">
+                <a:solidFill>
+                  <a:srgbClr val="24414A"/>
+                </a:solidFill>
+                <a:latin typeface="Arial" pitchFamily="34" charset="0"/>
+                <a:ea typeface="Arial" pitchFamily="34" charset="-122"/>
+                <a:cs typeface="Arial" pitchFamily="34" charset="-120"/>
+              </a:rPr>
+              <a:t>im Preis enthalten</a:t>
+            </a:r>
+            <a:endParaRPr lang="en-US" sz="1300" dirty="0"/>
+          </a:p>
+        </p:txBody>
+      </p:sp>
+      <p:sp>
+        <p:nvSpPr>
+          <p:cNvPr id="15" name="Text 13"/>
+          <p:cNvSpPr txBox="1"/>
+          <p:nvPr/>
+        </p:nvSpPr>
+        <p:spPr>
+          <a:xfrm>
+            <a:off x="2468880" y="2304288"/>
+            <a:ext cx="1554480" cy="960120"/>
+          </a:xfrm>
+          <a:prstGeom prst="rect">
+            <a:avLst/>
+          </a:prstGeom>
+          <a:noFill/>
+          <a:ln/>
+        </p:spPr>
+        <p:txBody>
+          <a:bodyPr wrap="square" lIns="0" tIns="0" rIns="0" bIns="0" rtlCol="0" anchor="t"/>
+          <a:lstStyle/>
+          <a:p>
+            <a:pPr indent="0" marL="0">
+              <a:buNone/>
+            </a:pPr>
+            <a:r>
+              <a:rPr lang="en-US" sz="850" dirty="0">
+                <a:solidFill>
+                  <a:srgbClr val="1C2326"/>
+                </a:solidFill>
+                <a:latin typeface="Arial" pitchFamily="34" charset="0"/>
+                <a:ea typeface="Arial" pitchFamily="34" charset="-122"/>
+                <a:cs typeface="Arial" pitchFamily="34" charset="-120"/>
+              </a:rPr>
+              <a:t>Export für das Baugesuch: bewohnt oder etappiert geprüft. In Zürich ab 20 Mietverhältnissen Pflicht, unser Türöffner.</a:t>
+            </a:r>
+            <a:endParaRPr lang="en-US" sz="850" dirty="0"/>
+          </a:p>
+        </p:txBody>
+      </p:sp>
+      <p:sp>
+        <p:nvSpPr>
+          <p:cNvPr id="16" name="Text 14"/>
+          <p:cNvSpPr txBox="1"/>
+          <p:nvPr/>
+        </p:nvSpPr>
+        <p:spPr>
+          <a:xfrm>
+            <a:off x="2468880" y="3273552"/>
+            <a:ext cx="1554480" cy="182880"/>
+          </a:xfrm>
+          <a:prstGeom prst="rect">
+            <a:avLst/>
+          </a:prstGeom>
+          <a:noFill/>
+          <a:ln/>
+        </p:spPr>
+        <p:txBody>
+          <a:bodyPr wrap="square" lIns="0" tIns="0" rIns="0" bIns="0" rtlCol="0" anchor="ctr"/>
+          <a:lstStyle/>
+          <a:p>
+            <a:pPr indent="0" marL="0">
+              <a:buNone/>
+            </a:pPr>
+            <a:r>
+              <a:rPr lang="en-US" sz="750" dirty="0">
+                <a:solidFill>
+                  <a:srgbClr val="5B6468"/>
+                </a:solidFill>
+                <a:latin typeface="Arial" pitchFamily="34" charset="0"/>
+                <a:ea typeface="Arial" pitchFamily="34" charset="-122"/>
+                <a:cs typeface="Arial" pitchFamily="34" charset="-120"/>
+              </a:rPr>
+              <a:t>heute</a:t>
+            </a:r>
+            <a:endParaRPr lang="en-US" sz="750" dirty="0"/>
+          </a:p>
+        </p:txBody>
+      </p:sp>
+      <p:sp>
+        <p:nvSpPr>
+          <p:cNvPr id="17" name="Shape 15"/>
+          <p:cNvSpPr/>
+          <p:nvPr/>
+        </p:nvSpPr>
+        <p:spPr>
+          <a:xfrm>
+            <a:off x="4206240" y="1280160"/>
+            <a:ext cx="1783080" cy="2240280"/>
+          </a:xfrm>
+          <a:prstGeom prst="rect">
+            <a:avLst/>
+          </a:prstGeom>
+          <a:solidFill>
+            <a:srgbClr val="F1EDE6"/>
+          </a:solidFill>
+          <a:ln w="12700">
+            <a:solidFill>
+              <a:srgbClr val="F1EDE6"/>
+            </a:solidFill>
+            <a:prstDash val="solid"/>
+          </a:ln>
+        </p:spPr>
+      </p:sp>
+      <p:sp>
+        <p:nvSpPr>
+          <p:cNvPr id="18" name="Shape 16"/>
+          <p:cNvSpPr/>
+          <p:nvPr/>
+        </p:nvSpPr>
+        <p:spPr>
+          <a:xfrm>
+            <a:off x="4343400" y="1389888"/>
+            <a:ext cx="274320" cy="274320"/>
+          </a:xfrm>
+          <a:prstGeom prst="rect">
+            <a:avLst/>
           </a:prstGeom>
           <a:solidFill>
             <a:srgbClr val="1C2326"/>
@@ -8500,14 +9623,14 @@
       </p:sp>
       <p:sp>
         <p:nvSpPr>
-          <p:cNvPr id="4" name="Text 2"/>
-          <p:cNvSpPr txBox="1"/>
-          <p:nvPr/>
-        </p:nvSpPr>
-        <p:spPr>
-          <a:xfrm>
-            <a:off x="457200" y="1325880"/>
-            <a:ext cx="384048" cy="384048"/>
+          <p:cNvPr id="19" name="Text 17"/>
+          <p:cNvSpPr txBox="1"/>
+          <p:nvPr/>
+        </p:nvSpPr>
+        <p:spPr>
+          <a:xfrm>
+            <a:off x="4343400" y="1389888"/>
+            <a:ext cx="274320" cy="274320"/>
           </a:xfrm>
           <a:prstGeom prst="rect">
             <a:avLst/>
@@ -8523,15 +9646,93 @@
               <a:buNone/>
             </a:pPr>
             <a:r>
+              <a:rPr lang="en-US" sz="1000" b="1" dirty="0">
+                <a:solidFill>
+                  <a:srgbClr val="FFFFFF"/>
+                </a:solidFill>
+                <a:latin typeface="Arial" pitchFamily="34" charset="0"/>
+                <a:ea typeface="Arial" pitchFamily="34" charset="-122"/>
+                <a:cs typeface="Arial" pitchFamily="34" charset="-120"/>
+              </a:rPr>
+              <a:t>3</a:t>
+            </a:r>
+            <a:endParaRPr lang="en-US" sz="1000" dirty="0"/>
+          </a:p>
+        </p:txBody>
+      </p:sp>
+      <p:sp>
+        <p:nvSpPr>
+          <p:cNvPr id="20" name="Text 18"/>
+          <p:cNvSpPr txBox="1"/>
+          <p:nvPr/>
+        </p:nvSpPr>
+        <p:spPr>
+          <a:xfrm>
+            <a:off x="4709160" y="1389888"/>
+            <a:ext cx="1188720" cy="274320"/>
+          </a:xfrm>
+          <a:prstGeom prst="rect">
+            <a:avLst/>
+          </a:prstGeom>
+          <a:noFill/>
+          <a:ln/>
+        </p:spPr>
+        <p:txBody>
+          <a:bodyPr wrap="square" lIns="0" tIns="0" rIns="0" bIns="0" rtlCol="0" anchor="ctr"/>
+          <a:lstStyle/>
+          <a:p>
+            <a:pPr indent="0" marL="0">
+              <a:buNone/>
+            </a:pPr>
+            <a:r>
+              <a:rPr lang="en-US" sz="1100" b="1" dirty="0">
+                <a:solidFill>
+                  <a:srgbClr val="1C2326"/>
+                </a:solidFill>
+                <a:latin typeface="Arial" pitchFamily="34" charset="0"/>
+                <a:ea typeface="Arial" pitchFamily="34" charset="-122"/>
+                <a:cs typeface="Arial" pitchFamily="34" charset="-120"/>
+              </a:rPr>
+              <a:t>Portfolio-Abo</a:t>
+            </a:r>
+            <a:endParaRPr lang="en-US" sz="1100" dirty="0"/>
+          </a:p>
+        </p:txBody>
+      </p:sp>
+      <p:sp>
+        <p:nvSpPr>
+          <p:cNvPr id="21" name="Text 19"/>
+          <p:cNvSpPr txBox="1"/>
+          <p:nvPr/>
+        </p:nvSpPr>
+        <p:spPr>
+          <a:xfrm>
+            <a:off x="4343400" y="1783080"/>
+            <a:ext cx="1554480" cy="502920"/>
+          </a:xfrm>
+          <a:prstGeom prst="rect">
+            <a:avLst/>
+          </a:prstGeom>
+          <a:noFill/>
+          <a:ln/>
+        </p:spPr>
+        <p:txBody>
+          <a:bodyPr wrap="square" lIns="0" tIns="0" rIns="0" bIns="0" rtlCol="0" anchor="t"/>
+          <a:lstStyle/>
+          <a:p>
+            <a:pPr indent="0" marL="0">
+              <a:buNone/>
+            </a:pPr>
+            <a:r>
               <a:rPr lang="en-US" sz="1300" b="1" dirty="0">
                 <a:solidFill>
-                  <a:srgbClr val="FFFFFF"/>
-                </a:solidFill>
-                <a:latin typeface="Arial" pitchFamily="34" charset="0"/>
-                <a:ea typeface="Arial" pitchFamily="34" charset="-122"/>
-                <a:cs typeface="Arial" pitchFamily="34" charset="-120"/>
-              </a:rPr>
-              <a:t>1</a:t>
+                  <a:srgbClr val="1C2326"/>
+                </a:solidFill>
+                <a:latin typeface="Arial" pitchFamily="34" charset="0"/>
+                <a:ea typeface="Arial" pitchFamily="34" charset="-122"/>
+                <a:cs typeface="Arial" pitchFamily="34" charset="-120"/>
+              </a:rPr>
+              <a:t>CHF 2'000 pro Monat</a:t>
             </a:r>
             <a:endParaRPr lang="en-US" sz="1300" dirty="0"/>
           </a:p>
@@ -8539,14 +9740,53 @@
       </p:sp>
       <p:sp>
         <p:nvSpPr>
-          <p:cNvPr id="5" name="Text 3"/>
-          <p:cNvSpPr txBox="1"/>
-          <p:nvPr/>
-        </p:nvSpPr>
-        <p:spPr>
-          <a:xfrm>
-            <a:off x="960120" y="1325880"/>
-            <a:ext cx="2377440" cy="384048"/>
+          <p:cNvPr id="22" name="Text 20"/>
+          <p:cNvSpPr txBox="1"/>
+          <p:nvPr/>
+        </p:nvSpPr>
+        <p:spPr>
+          <a:xfrm>
+            <a:off x="4343400" y="2304288"/>
+            <a:ext cx="1554480" cy="960120"/>
+          </a:xfrm>
+          <a:prstGeom prst="rect">
+            <a:avLst/>
+          </a:prstGeom>
+          <a:noFill/>
+          <a:ln/>
+        </p:spPr>
+        <p:txBody>
+          <a:bodyPr wrap="square" lIns="0" tIns="0" rIns="0" bIns="0" rtlCol="0" anchor="t"/>
+          <a:lstStyle/>
+          <a:p>
+            <a:pPr indent="0" marL="0">
+              <a:buNone/>
+            </a:pPr>
+            <a:r>
+              <a:rPr lang="en-US" sz="850" dirty="0">
+                <a:solidFill>
+                  <a:srgbClr val="1C2326"/>
+                </a:solidFill>
+                <a:latin typeface="Arial" pitchFamily="34" charset="0"/>
+                <a:ea typeface="Arial" pitchFamily="34" charset="-122"/>
+                <a:cs typeface="Arial" pitchFamily="34" charset="-120"/>
+              </a:rPr>
+              <a:t>für Pensionskassen und grosse Genossenschaften mit mehreren Sanierungen pro Jahr. Annahme, ab 2028.</a:t>
+            </a:r>
+            <a:endParaRPr lang="en-US" sz="850" dirty="0"/>
+          </a:p>
+        </p:txBody>
+      </p:sp>
+      <p:sp>
+        <p:nvSpPr>
+          <p:cNvPr id="23" name="Text 21"/>
+          <p:cNvSpPr txBox="1"/>
+          <p:nvPr/>
+        </p:nvSpPr>
+        <p:spPr>
+          <a:xfrm>
+            <a:off x="4343400" y="3273552"/>
+            <a:ext cx="1554480" cy="182880"/>
           </a:xfrm>
           <a:prstGeom prst="rect">
             <a:avLst/>
@@ -8562,42 +9802,40 @@
               <a:buNone/>
             </a:pPr>
             <a:r>
-              <a:rPr lang="en-US" sz="1600" b="1" dirty="0">
-                <a:solidFill>
-                  <a:srgbClr val="1C2326"/>
-                </a:solidFill>
-                <a:latin typeface="Arial" pitchFamily="34" charset="0"/>
-                <a:ea typeface="Arial" pitchFamily="34" charset="-122"/>
-                <a:cs typeface="Arial" pitchFamily="34" charset="-120"/>
-              </a:rPr>
-              <a:t>Zimmerzahl</a:t>
-            </a:r>
-            <a:endParaRPr lang="en-US" sz="1600" dirty="0"/>
-          </a:p>
-        </p:txBody>
-      </p:sp>
-      <p:sp>
-        <p:nvSpPr>
-          <p:cNvPr id="6" name="Shape 4"/>
+              <a:rPr lang="en-US" sz="750" dirty="0">
+                <a:solidFill>
+                  <a:srgbClr val="5B6468"/>
+                </a:solidFill>
+                <a:latin typeface="Arial" pitchFamily="34" charset="0"/>
+                <a:ea typeface="Arial" pitchFamily="34" charset="-122"/>
+                <a:cs typeface="Arial" pitchFamily="34" charset="-120"/>
+              </a:rPr>
+              <a:t>später</a:t>
+            </a:r>
+            <a:endParaRPr lang="en-US" sz="750" dirty="0"/>
+          </a:p>
+        </p:txBody>
+      </p:sp>
+      <p:sp>
+        <p:nvSpPr>
+          <p:cNvPr id="24" name="Shape 22"/>
           <p:cNvSpPr/>
           <p:nvPr/>
         </p:nvSpPr>
         <p:spPr>
           <a:xfrm>
-            <a:off x="457200" y="1892808"/>
-            <a:ext cx="384048" cy="384048"/>
-          </a:xfrm>
-          <a:prstGeom prst="roundRect">
-            <a:avLst>
-              <a:gd name="adj" fmla="val 19048"/>
-            </a:avLst>
+            <a:off x="6172200" y="1280160"/>
+            <a:ext cx="2514600" cy="2240280"/>
+          </a:xfrm>
+          <a:prstGeom prst="rect">
+            <a:avLst/>
           </a:prstGeom>
           <a:solidFill>
-            <a:srgbClr val="1C2326"/>
+            <a:srgbClr val="24414A"/>
           </a:solidFill>
           <a:ln w="12700">
             <a:solidFill>
-              <a:srgbClr val="1C2326"/>
+              <a:srgbClr val="24414A"/>
             </a:solidFill>
             <a:prstDash val="solid"/>
           </a:ln>
@@ -8605,14 +9843,14 @@
       </p:sp>
       <p:sp>
         <p:nvSpPr>
-          <p:cNvPr id="7" name="Text 5"/>
-          <p:cNvSpPr txBox="1"/>
-          <p:nvPr/>
-        </p:nvSpPr>
-        <p:spPr>
-          <a:xfrm>
-            <a:off x="457200" y="1892808"/>
-            <a:ext cx="384048" cy="384048"/>
+          <p:cNvPr id="25" name="Text 23"/>
+          <p:cNvSpPr txBox="1"/>
+          <p:nvPr/>
+        </p:nvSpPr>
+        <p:spPr>
+          <a:xfrm>
+            <a:off x="6355080" y="1371600"/>
+            <a:ext cx="2194560" cy="274320"/>
           </a:xfrm>
           <a:prstGeom prst="rect">
             <a:avLst/>
@@ -8624,11 +9862,89 @@
           <a:bodyPr wrap="square" lIns="0" tIns="0" rIns="0" bIns="0" rtlCol="0" anchor="ctr"/>
           <a:lstStyle/>
           <a:p>
-            <a:pPr algn="ctr" indent="0" marL="0">
-              <a:buNone/>
-            </a:pPr>
-            <a:r>
-              <a:rPr lang="en-US" sz="1300" b="1" dirty="0">
+            <a:pPr indent="0" marL="0">
+              <a:buNone/>
+            </a:pPr>
+            <a:r>
+              <a:rPr lang="en-US" sz="900" b="1" dirty="0">
+                <a:solidFill>
+                  <a:srgbClr val="B5C9CE"/>
+                </a:solidFill>
+                <a:latin typeface="Arial" pitchFamily="34" charset="0"/>
+                <a:ea typeface="Arial" pitchFamily="34" charset="-122"/>
+                <a:cs typeface="Arial" pitchFamily="34" charset="-120"/>
+              </a:rPr>
+              <a:t>Rechenbeispiel für den Kunden</a:t>
+            </a:r>
+            <a:endParaRPr lang="en-US" sz="900" dirty="0"/>
+          </a:p>
+        </p:txBody>
+      </p:sp>
+      <p:sp>
+        <p:nvSpPr>
+          <p:cNvPr id="26" name="Text 24"/>
+          <p:cNvSpPr txBox="1"/>
+          <p:nvPr/>
+        </p:nvSpPr>
+        <p:spPr>
+          <a:xfrm>
+            <a:off x="6355080" y="1645920"/>
+            <a:ext cx="2194560" cy="457200"/>
+          </a:xfrm>
+          <a:prstGeom prst="rect">
+            <a:avLst/>
+          </a:prstGeom>
+          <a:noFill/>
+          <a:ln/>
+        </p:spPr>
+        <p:txBody>
+          <a:bodyPr wrap="square" lIns="0" tIns="0" rIns="0" bIns="0" rtlCol="0" anchor="ctr"/>
+          <a:lstStyle/>
+          <a:p>
+            <a:pPr indent="0" marL="0">
+              <a:buNone/>
+            </a:pPr>
+            <a:r>
+              <a:rPr lang="en-US" sz="2400" b="1" dirty="0">
+                <a:solidFill>
+                  <a:srgbClr val="F26A1B"/>
+                </a:solidFill>
+                <a:latin typeface="Arial" pitchFamily="34" charset="0"/>
+                <a:ea typeface="Arial" pitchFamily="34" charset="-122"/>
+                <a:cs typeface="Arial" pitchFamily="34" charset="-120"/>
+              </a:rPr>
+              <a:t>CHF 216'000</a:t>
+            </a:r>
+            <a:endParaRPr lang="en-US" sz="2400" dirty="0"/>
+          </a:p>
+        </p:txBody>
+      </p:sp>
+      <p:sp>
+        <p:nvSpPr>
+          <p:cNvPr id="27" name="Text 25"/>
+          <p:cNvSpPr txBox="1"/>
+          <p:nvPr/>
+        </p:nvSpPr>
+        <p:spPr>
+          <a:xfrm>
+            <a:off x="6355080" y="2148840"/>
+            <a:ext cx="2194560" cy="777240"/>
+          </a:xfrm>
+          <a:prstGeom prst="rect">
+            <a:avLst/>
+          </a:prstGeom>
+          <a:noFill/>
+          <a:ln/>
+        </p:spPr>
+        <p:txBody>
+          <a:bodyPr wrap="square" lIns="0" tIns="0" rIns="0" bIns="0" rtlCol="0" anchor="t"/>
+          <a:lstStyle/>
+          <a:p>
+            <a:pPr indent="0" marL="0">
+              <a:buNone/>
+            </a:pPr>
+            <a:r>
+              <a:rPr lang="en-US" sz="900" dirty="0">
                 <a:solidFill>
                   <a:srgbClr val="FFFFFF"/>
                 </a:solidFill>
@@ -8636,315 +9952,64 @@
                 <a:ea typeface="Arial" pitchFamily="34" charset="-122"/>
                 <a:cs typeface="Arial" pitchFamily="34" charset="-120"/>
               </a:rPr>
-              <a:t>2</a:t>
-            </a:r>
-            <a:endParaRPr lang="en-US" sz="1300" dirty="0"/>
-          </a:p>
-        </p:txBody>
-      </p:sp>
-      <p:sp>
-        <p:nvSpPr>
-          <p:cNvPr id="8" name="Text 6"/>
-          <p:cNvSpPr txBox="1"/>
-          <p:nvPr/>
-        </p:nvSpPr>
-        <p:spPr>
-          <a:xfrm>
-            <a:off x="960120" y="1892808"/>
-            <a:ext cx="2377440" cy="384048"/>
-          </a:xfrm>
-          <a:prstGeom prst="rect">
-            <a:avLst/>
-          </a:prstGeom>
-          <a:noFill/>
-          <a:ln/>
-        </p:spPr>
-        <p:txBody>
-          <a:bodyPr wrap="square" lIns="0" tIns="0" rIns="0" bIns="0" rtlCol="0" anchor="ctr"/>
+              <a:t>Mietzinsausfall bei Leerkündigung: 24 Wohnungen × CHF 1'500 × 6 Monate Bauzeit. Die Rochade hält die Mieten am Laufen.</a:t>
+            </a:r>
+            <a:endParaRPr lang="en-US" sz="900" dirty="0"/>
+          </a:p>
+        </p:txBody>
+      </p:sp>
+      <p:sp>
+        <p:nvSpPr>
+          <p:cNvPr id="28" name="Text 26"/>
+          <p:cNvSpPr txBox="1"/>
+          <p:nvPr/>
+        </p:nvSpPr>
+        <p:spPr>
+          <a:xfrm>
+            <a:off x="6355080" y="2971800"/>
+            <a:ext cx="2194560" cy="457200"/>
+          </a:xfrm>
+          <a:prstGeom prst="rect">
+            <a:avLst/>
+          </a:prstGeom>
+          <a:noFill/>
+          <a:ln/>
+        </p:spPr>
+        <p:txBody>
+          <a:bodyPr wrap="square" lIns="0" tIns="0" rIns="0" bIns="0" rtlCol="0" anchor="t"/>
           <a:lstStyle/>
           <a:p>
             <a:pPr indent="0" marL="0">
               <a:buNone/>
             </a:pPr>
             <a:r>
-              <a:rPr lang="en-US" sz="1600" b="1" dirty="0">
-                <a:solidFill>
-                  <a:srgbClr val="1C2326"/>
-                </a:solidFill>
-                <a:latin typeface="Arial" pitchFamily="34" charset="0"/>
-                <a:ea typeface="Arial" pitchFamily="34" charset="-122"/>
-                <a:cs typeface="Arial" pitchFamily="34" charset="-120"/>
-              </a:rPr>
-              <a:t>Hindernisfrei</a:t>
-            </a:r>
-            <a:endParaRPr lang="en-US" sz="1600" dirty="0"/>
-          </a:p>
-        </p:txBody>
-      </p:sp>
-      <p:sp>
-        <p:nvSpPr>
-          <p:cNvPr id="9" name="Shape 7"/>
+              <a:rPr lang="en-US" sz="900" b="1" dirty="0">
+                <a:solidFill>
+                  <a:srgbClr val="D4E1E5"/>
+                </a:solidFill>
+                <a:latin typeface="Arial" pitchFamily="34" charset="0"/>
+                <a:ea typeface="Arial" pitchFamily="34" charset="-122"/>
+                <a:cs typeface="Arial" pitchFamily="34" charset="-120"/>
+              </a:rPr>
+              <a:t>Lizenz dafür: CHF 10'000. Eine Woche Bauverzug kostet mehr.</a:t>
+            </a:r>
+            <a:endParaRPr lang="en-US" sz="900" dirty="0"/>
+          </a:p>
+        </p:txBody>
+      </p:sp>
+      <p:sp>
+        <p:nvSpPr>
+          <p:cNvPr id="29" name="Shape 27"/>
           <p:cNvSpPr/>
           <p:nvPr/>
         </p:nvSpPr>
         <p:spPr>
           <a:xfrm>
-            <a:off x="457200" y="2459736"/>
-            <a:ext cx="384048" cy="384048"/>
-          </a:xfrm>
-          <a:prstGeom prst="roundRect">
-            <a:avLst>
-              <a:gd name="adj" fmla="val 19048"/>
-            </a:avLst>
-          </a:prstGeom>
-          <a:solidFill>
-            <a:srgbClr val="1C2326"/>
-          </a:solidFill>
-          <a:ln w="12700">
-            <a:solidFill>
-              <a:srgbClr val="1C2326"/>
-            </a:solidFill>
-            <a:prstDash val="solid"/>
-          </a:ln>
-        </p:spPr>
-      </p:sp>
-      <p:sp>
-        <p:nvSpPr>
-          <p:cNvPr id="10" name="Text 8"/>
-          <p:cNvSpPr txBox="1"/>
-          <p:nvPr/>
-        </p:nvSpPr>
-        <p:spPr>
-          <a:xfrm>
-            <a:off x="457200" y="2459736"/>
-            <a:ext cx="384048" cy="384048"/>
-          </a:xfrm>
-          <a:prstGeom prst="rect">
-            <a:avLst/>
-          </a:prstGeom>
-          <a:noFill/>
-          <a:ln/>
-        </p:spPr>
-        <p:txBody>
-          <a:bodyPr wrap="square" lIns="0" tIns="0" rIns="0" bIns="0" rtlCol="0" anchor="ctr"/>
-          <a:lstStyle/>
-          <a:p>
-            <a:pPr algn="ctr" indent="0" marL="0">
-              <a:buNone/>
-            </a:pPr>
-            <a:r>
-              <a:rPr lang="en-US" sz="1300" b="1" dirty="0">
-                <a:solidFill>
-                  <a:srgbClr val="FFFFFF"/>
-                </a:solidFill>
-                <a:latin typeface="Arial" pitchFamily="34" charset="0"/>
-                <a:ea typeface="Arial" pitchFamily="34" charset="-122"/>
-                <a:cs typeface="Arial" pitchFamily="34" charset="-120"/>
-              </a:rPr>
-              <a:t>3</a:t>
-            </a:r>
-            <a:endParaRPr lang="en-US" sz="1300" dirty="0"/>
-          </a:p>
-        </p:txBody>
-      </p:sp>
-      <p:sp>
-        <p:nvSpPr>
-          <p:cNvPr id="11" name="Text 9"/>
-          <p:cNvSpPr txBox="1"/>
-          <p:nvPr/>
-        </p:nvSpPr>
-        <p:spPr>
-          <a:xfrm>
-            <a:off x="960120" y="2459736"/>
-            <a:ext cx="2377440" cy="384048"/>
-          </a:xfrm>
-          <a:prstGeom prst="rect">
-            <a:avLst/>
-          </a:prstGeom>
-          <a:noFill/>
-          <a:ln/>
-        </p:spPr>
-        <p:txBody>
-          <a:bodyPr wrap="square" lIns="0" tIns="0" rIns="0" bIns="0" rtlCol="0" anchor="ctr"/>
-          <a:lstStyle/>
-          <a:p>
-            <a:pPr indent="0" marL="0">
-              <a:buNone/>
-            </a:pPr>
-            <a:r>
-              <a:rPr lang="en-US" sz="1600" b="1" dirty="0">
-                <a:solidFill>
-                  <a:srgbClr val="1C2326"/>
-                </a:solidFill>
-                <a:latin typeface="Arial" pitchFamily="34" charset="0"/>
-                <a:ea typeface="Arial" pitchFamily="34" charset="-122"/>
-                <a:cs typeface="Arial" pitchFamily="34" charset="-120"/>
-              </a:rPr>
-              <a:t>Zeitfenster</a:t>
-            </a:r>
-            <a:endParaRPr lang="en-US" sz="1600" dirty="0"/>
-          </a:p>
-        </p:txBody>
-      </p:sp>
-      <p:sp>
-        <p:nvSpPr>
-          <p:cNvPr id="12" name="Shape 10"/>
-          <p:cNvSpPr/>
-          <p:nvPr/>
-        </p:nvSpPr>
-        <p:spPr>
-          <a:xfrm>
-            <a:off x="457200" y="3026664"/>
-            <a:ext cx="384048" cy="384048"/>
-          </a:xfrm>
-          <a:prstGeom prst="roundRect">
-            <a:avLst>
-              <a:gd name="adj" fmla="val 19048"/>
-            </a:avLst>
-          </a:prstGeom>
-          <a:solidFill>
-            <a:srgbClr val="1C2326"/>
-          </a:solidFill>
-          <a:ln w="12700">
-            <a:solidFill>
-              <a:srgbClr val="1C2326"/>
-            </a:solidFill>
-            <a:prstDash val="solid"/>
-          </a:ln>
-        </p:spPr>
-      </p:sp>
-      <p:sp>
-        <p:nvSpPr>
-          <p:cNvPr id="13" name="Text 11"/>
-          <p:cNvSpPr txBox="1"/>
-          <p:nvPr/>
-        </p:nvSpPr>
-        <p:spPr>
-          <a:xfrm>
-            <a:off x="457200" y="3026664"/>
-            <a:ext cx="384048" cy="384048"/>
-          </a:xfrm>
-          <a:prstGeom prst="rect">
-            <a:avLst/>
-          </a:prstGeom>
-          <a:noFill/>
-          <a:ln/>
-        </p:spPr>
-        <p:txBody>
-          <a:bodyPr wrap="square" lIns="0" tIns="0" rIns="0" bIns="0" rtlCol="0" anchor="ctr"/>
-          <a:lstStyle/>
-          <a:p>
-            <a:pPr algn="ctr" indent="0" marL="0">
-              <a:buNone/>
-            </a:pPr>
-            <a:r>
-              <a:rPr lang="en-US" sz="1300" b="1" dirty="0">
-                <a:solidFill>
-                  <a:srgbClr val="FFFFFF"/>
-                </a:solidFill>
-                <a:latin typeface="Arial" pitchFamily="34" charset="0"/>
-                <a:ea typeface="Arial" pitchFamily="34" charset="-122"/>
-                <a:cs typeface="Arial" pitchFamily="34" charset="-120"/>
-              </a:rPr>
-              <a:t>4</a:t>
-            </a:r>
-            <a:endParaRPr lang="en-US" sz="1300" dirty="0"/>
-          </a:p>
-        </p:txBody>
-      </p:sp>
-      <p:sp>
-        <p:nvSpPr>
-          <p:cNvPr id="14" name="Text 12"/>
-          <p:cNvSpPr txBox="1"/>
-          <p:nvPr/>
-        </p:nvSpPr>
-        <p:spPr>
-          <a:xfrm>
-            <a:off x="960120" y="3026664"/>
-            <a:ext cx="2377440" cy="384048"/>
-          </a:xfrm>
-          <a:prstGeom prst="rect">
-            <a:avLst/>
-          </a:prstGeom>
-          <a:noFill/>
-          <a:ln/>
-        </p:spPr>
-        <p:txBody>
-          <a:bodyPr wrap="square" lIns="0" tIns="0" rIns="0" bIns="0" rtlCol="0" anchor="ctr"/>
-          <a:lstStyle/>
-          <a:p>
-            <a:pPr indent="0" marL="0">
-              <a:buNone/>
-            </a:pPr>
-            <a:r>
-              <a:rPr lang="en-US" sz="1600" b="1" dirty="0">
-                <a:solidFill>
-                  <a:srgbClr val="1C2326"/>
-                </a:solidFill>
-                <a:latin typeface="Arial" pitchFamily="34" charset="0"/>
-                <a:ea typeface="Arial" pitchFamily="34" charset="-122"/>
-                <a:cs typeface="Arial" pitchFamily="34" charset="-120"/>
-              </a:rPr>
-              <a:t>Keine Doppelbelegung</a:t>
-            </a:r>
-            <a:endParaRPr lang="en-US" sz="1600" dirty="0"/>
-          </a:p>
-        </p:txBody>
-      </p:sp>
-      <p:sp>
-        <p:nvSpPr>
-          <p:cNvPr id="15" name="Text 13"/>
-          <p:cNvSpPr txBox="1"/>
-          <p:nvPr/>
-        </p:nvSpPr>
-        <p:spPr>
-          <a:xfrm>
             <a:off x="457200" y="3657600"/>
-            <a:ext cx="2926080" cy="731520"/>
-          </a:xfrm>
-          <a:prstGeom prst="rect">
-            <a:avLst/>
-          </a:prstGeom>
-          <a:noFill/>
-          <a:ln/>
-        </p:spPr>
-        <p:txBody>
-          <a:bodyPr wrap="square" lIns="0" tIns="0" rIns="0" bIns="0" rtlCol="0" anchor="t"/>
-          <a:lstStyle/>
-          <a:p>
-            <a:pPr indent="0" marL="0">
-              <a:buNone/>
-            </a:pPr>
-            <a:r>
-              <a:rPr lang="en-US" sz="1200" dirty="0">
-                <a:solidFill>
-                  <a:srgbClr val="5B6468"/>
-                </a:solidFill>
-                <a:latin typeface="Arial" pitchFamily="34" charset="0"/>
-                <a:ea typeface="Arial" pitchFamily="34" charset="-122"/>
-                <a:cs typeface="Arial" pitchFamily="34" charset="-120"/>
-              </a:rPr>
-              <a:t>Nie gebrochen. Geht es nicht auf, sagt ROCHADE, was fehlt.</a:t>
-            </a:r>
-            <a:endParaRPr lang="en-US" sz="1200" dirty="0"/>
-          </a:p>
-        </p:txBody>
-      </p:sp>
-      <p:sp>
-        <p:nvSpPr>
-          <p:cNvPr id="16" name="Shape 14"/>
-          <p:cNvSpPr/>
-          <p:nvPr/>
-        </p:nvSpPr>
-        <p:spPr>
-          <a:xfrm>
-            <a:off x="3657600" y="1280160"/>
-            <a:ext cx="5029200" cy="3246120"/>
-          </a:xfrm>
-          <a:prstGeom prst="roundRect">
-            <a:avLst>
-              <a:gd name="adj" fmla="val 3944"/>
-            </a:avLst>
+            <a:ext cx="2651760" cy="960120"/>
+          </a:xfrm>
+          <a:prstGeom prst="rect">
+            <a:avLst/>
           </a:prstGeom>
           <a:solidFill>
             <a:srgbClr val="FFFFFF"/>
@@ -8957,39 +10022,16 @@
           </a:ln>
         </p:spPr>
       </p:sp>
-      <p:pic>
-        <p:nvPicPr>
-          <p:cNvPr id="17" name="Image 0" descr="/private/tmp/claude-501/-Users-francescorocca--claude-spares-spare-pTP7p5/c9c54887-e9ac-44ae-bd9c-ebf5f8016333/scratchpad/deck/img/status-crop.png">    </p:cNvPr>
-          <p:cNvPicPr>
-            <a:picLocks noChangeAspect="1"/>
-          </p:cNvPicPr>
-          <p:nvPr/>
-        </p:nvPicPr>
-        <p:blipFill>
-          <a:blip r:embed="rId1"/>
-          <a:srcRect l="0" r="0" t="0" b="0"/>
-          <a:stretch/>
-        </p:blipFill>
-        <p:spPr>
-          <a:xfrm>
-            <a:off x="3767328" y="1371600"/>
-            <a:ext cx="4809744" cy="3063240"/>
-          </a:xfrm>
-          <a:prstGeom prst="rect">
-            <a:avLst/>
-          </a:prstGeom>
-        </p:spPr>
-      </p:pic>
-      <p:sp>
-        <p:nvSpPr>
-          <p:cNvPr id="18" name="Text 15"/>
-          <p:cNvSpPr txBox="1"/>
-          <p:nvPr/>
-        </p:nvSpPr>
-        <p:spPr>
-          <a:xfrm>
-            <a:off x="3657600" y="4553712"/>
-            <a:ext cx="5029200" cy="256032"/>
+      <p:sp>
+        <p:nvSpPr>
+          <p:cNvPr id="30" name="Text 28"/>
+          <p:cNvSpPr txBox="1"/>
+          <p:nvPr/>
+        </p:nvSpPr>
+        <p:spPr>
+          <a:xfrm>
+            <a:off x="640080" y="3730752"/>
+            <a:ext cx="2286000" cy="228600"/>
           </a:xfrm>
           <a:prstGeom prst="rect">
             <a:avLst/>
@@ -9005,7 +10047,7 @@
               <a:buNone/>
             </a:pPr>
             <a:r>
-              <a:rPr lang="en-US" sz="900" dirty="0">
+              <a:rPr lang="en-US" sz="850" b="1" dirty="0">
                 <a:solidFill>
                   <a:srgbClr val="5B6468"/>
                 </a:solidFill>
@@ -9013,9 +10055,410 @@
                 <a:ea typeface="Arial" pitchFamily="34" charset="-122"/>
                 <a:cs typeface="Arial" pitchFamily="34" charset="-120"/>
               </a:rPr>
-              <a:t>Etappe 1 verzögert sich um zwei Monate: 11 Konflikte, Vorschlag Etappe 2 ab November 2027.</a:t>
-            </a:r>
-            <a:endParaRPr lang="en-US" sz="900" dirty="0"/>
+              <a:t>Kosten pro Projekt</a:t>
+            </a:r>
+            <a:endParaRPr lang="en-US" sz="850" dirty="0"/>
+          </a:p>
+        </p:txBody>
+      </p:sp>
+      <p:sp>
+        <p:nvSpPr>
+          <p:cNvPr id="31" name="Text 29"/>
+          <p:cNvSpPr txBox="1"/>
+          <p:nvPr/>
+        </p:nvSpPr>
+        <p:spPr>
+          <a:xfrm>
+            <a:off x="640080" y="3950208"/>
+            <a:ext cx="2286000" cy="320040"/>
+          </a:xfrm>
+          <a:prstGeom prst="rect">
+            <a:avLst/>
+          </a:prstGeom>
+          <a:noFill/>
+          <a:ln/>
+        </p:spPr>
+        <p:txBody>
+          <a:bodyPr wrap="square" lIns="0" tIns="0" rIns="0" bIns="0" rtlCol="0" anchor="ctr"/>
+          <a:lstStyle/>
+          <a:p>
+            <a:pPr indent="0" marL="0">
+              <a:buNone/>
+            </a:pPr>
+            <a:r>
+              <a:rPr lang="en-US" sz="1500" b="1" dirty="0">
+                <a:solidFill>
+                  <a:srgbClr val="1C2326"/>
+                </a:solidFill>
+                <a:latin typeface="Arial" pitchFamily="34" charset="0"/>
+                <a:ea typeface="Arial" pitchFamily="34" charset="-122"/>
+                <a:cs typeface="Arial" pitchFamily="34" charset="-120"/>
+              </a:rPr>
+              <a:t>rund CHF 2'000</a:t>
+            </a:r>
+            <a:endParaRPr lang="en-US" sz="1500" dirty="0"/>
+          </a:p>
+        </p:txBody>
+      </p:sp>
+      <p:sp>
+        <p:nvSpPr>
+          <p:cNvPr id="32" name="Text 30"/>
+          <p:cNvSpPr txBox="1"/>
+          <p:nvPr/>
+        </p:nvSpPr>
+        <p:spPr>
+          <a:xfrm>
+            <a:off x="640080" y="4279392"/>
+            <a:ext cx="2286000" cy="274320"/>
+          </a:xfrm>
+          <a:prstGeom prst="rect">
+            <a:avLst/>
+          </a:prstGeom>
+          <a:noFill/>
+          <a:ln/>
+        </p:spPr>
+        <p:txBody>
+          <a:bodyPr wrap="square" lIns="0" tIns="0" rIns="0" bIns="0" rtlCol="0" anchor="ctr"/>
+          <a:lstStyle/>
+          <a:p>
+            <a:pPr indent="0" marL="0">
+              <a:buNone/>
+            </a:pPr>
+            <a:r>
+              <a:rPr lang="en-US" sz="850" dirty="0">
+                <a:solidFill>
+                  <a:srgbClr val="1C2326"/>
+                </a:solidFill>
+                <a:latin typeface="Arial" pitchFamily="34" charset="0"/>
+                <a:ea typeface="Arial" pitchFamily="34" charset="-122"/>
+                <a:cs typeface="Arial" pitchFamily="34" charset="-120"/>
+              </a:rPr>
+              <a:t>zwei Tage Onboarding und Support</a:t>
+            </a:r>
+            <a:endParaRPr lang="en-US" sz="850" dirty="0"/>
+          </a:p>
+        </p:txBody>
+      </p:sp>
+      <p:sp>
+        <p:nvSpPr>
+          <p:cNvPr id="33" name="Shape 31"/>
+          <p:cNvSpPr/>
+          <p:nvPr/>
+        </p:nvSpPr>
+        <p:spPr>
+          <a:xfrm>
+            <a:off x="3246120" y="3657600"/>
+            <a:ext cx="2651760" cy="960120"/>
+          </a:xfrm>
+          <a:prstGeom prst="rect">
+            <a:avLst/>
+          </a:prstGeom>
+          <a:solidFill>
+            <a:srgbClr val="FFFFFF"/>
+          </a:solidFill>
+          <a:ln w="9525">
+            <a:solidFill>
+              <a:srgbClr val="E3DDD4"/>
+            </a:solidFill>
+            <a:prstDash val="solid"/>
+          </a:ln>
+        </p:spPr>
+      </p:sp>
+      <p:sp>
+        <p:nvSpPr>
+          <p:cNvPr id="34" name="Text 32"/>
+          <p:cNvSpPr txBox="1"/>
+          <p:nvPr/>
+        </p:nvSpPr>
+        <p:spPr>
+          <a:xfrm>
+            <a:off x="3429000" y="3730752"/>
+            <a:ext cx="2286000" cy="228600"/>
+          </a:xfrm>
+          <a:prstGeom prst="rect">
+            <a:avLst/>
+          </a:prstGeom>
+          <a:noFill/>
+          <a:ln/>
+        </p:spPr>
+        <p:txBody>
+          <a:bodyPr wrap="square" lIns="0" tIns="0" rIns="0" bIns="0" rtlCol="0" anchor="ctr"/>
+          <a:lstStyle/>
+          <a:p>
+            <a:pPr indent="0" marL="0">
+              <a:buNone/>
+            </a:pPr>
+            <a:r>
+              <a:rPr lang="en-US" sz="850" b="1" dirty="0">
+                <a:solidFill>
+                  <a:srgbClr val="5B6468"/>
+                </a:solidFill>
+                <a:latin typeface="Arial" pitchFamily="34" charset="0"/>
+                <a:ea typeface="Arial" pitchFamily="34" charset="-122"/>
+                <a:cs typeface="Arial" pitchFamily="34" charset="-120"/>
+              </a:rPr>
+              <a:t>Fixkosten Jahr 1</a:t>
+            </a:r>
+            <a:endParaRPr lang="en-US" sz="850" dirty="0"/>
+          </a:p>
+        </p:txBody>
+      </p:sp>
+      <p:sp>
+        <p:nvSpPr>
+          <p:cNvPr id="35" name="Text 33"/>
+          <p:cNvSpPr txBox="1"/>
+          <p:nvPr/>
+        </p:nvSpPr>
+        <p:spPr>
+          <a:xfrm>
+            <a:off x="3429000" y="3950208"/>
+            <a:ext cx="2286000" cy="320040"/>
+          </a:xfrm>
+          <a:prstGeom prst="rect">
+            <a:avLst/>
+          </a:prstGeom>
+          <a:noFill/>
+          <a:ln/>
+        </p:spPr>
+        <p:txBody>
+          <a:bodyPr wrap="square" lIns="0" tIns="0" rIns="0" bIns="0" rtlCol="0" anchor="ctr"/>
+          <a:lstStyle/>
+          <a:p>
+            <a:pPr indent="0" marL="0">
+              <a:buNone/>
+            </a:pPr>
+            <a:r>
+              <a:rPr lang="en-US" sz="1500" b="1" dirty="0">
+                <a:solidFill>
+                  <a:srgbClr val="1C2326"/>
+                </a:solidFill>
+                <a:latin typeface="Arial" pitchFamily="34" charset="0"/>
+                <a:ea typeface="Arial" pitchFamily="34" charset="-122"/>
+                <a:cs typeface="Arial" pitchFamily="34" charset="-120"/>
+              </a:rPr>
+              <a:t>CHF 120'000</a:t>
+            </a:r>
+            <a:endParaRPr lang="en-US" sz="1500" dirty="0"/>
+          </a:p>
+        </p:txBody>
+      </p:sp>
+      <p:sp>
+        <p:nvSpPr>
+          <p:cNvPr id="36" name="Text 34"/>
+          <p:cNvSpPr txBox="1"/>
+          <p:nvPr/>
+        </p:nvSpPr>
+        <p:spPr>
+          <a:xfrm>
+            <a:off x="3429000" y="4279392"/>
+            <a:ext cx="2286000" cy="274320"/>
+          </a:xfrm>
+          <a:prstGeom prst="rect">
+            <a:avLst/>
+          </a:prstGeom>
+          <a:noFill/>
+          <a:ln/>
+        </p:spPr>
+        <p:txBody>
+          <a:bodyPr wrap="square" lIns="0" tIns="0" rIns="0" bIns="0" rtlCol="0" anchor="ctr"/>
+          <a:lstStyle/>
+          <a:p>
+            <a:pPr indent="0" marL="0">
+              <a:buNone/>
+            </a:pPr>
+            <a:r>
+              <a:rPr lang="en-US" sz="850" dirty="0">
+                <a:solidFill>
+                  <a:srgbClr val="1C2326"/>
+                </a:solidFill>
+                <a:latin typeface="Arial" pitchFamily="34" charset="0"/>
+                <a:ea typeface="Arial" pitchFamily="34" charset="-122"/>
+                <a:cs typeface="Arial" pitchFamily="34" charset="-120"/>
+              </a:rPr>
+              <a:t>1,5 Stellen, Hosting, Vertrieb</a:t>
+            </a:r>
+            <a:endParaRPr lang="en-US" sz="850" dirty="0"/>
+          </a:p>
+        </p:txBody>
+      </p:sp>
+      <p:sp>
+        <p:nvSpPr>
+          <p:cNvPr id="37" name="Shape 35"/>
+          <p:cNvSpPr/>
+          <p:nvPr/>
+        </p:nvSpPr>
+        <p:spPr>
+          <a:xfrm>
+            <a:off x="6035040" y="3657600"/>
+            <a:ext cx="2651760" cy="960120"/>
+          </a:xfrm>
+          <a:prstGeom prst="rect">
+            <a:avLst/>
+          </a:prstGeom>
+          <a:solidFill>
+            <a:srgbClr val="FFFFFF"/>
+          </a:solidFill>
+          <a:ln w="9525">
+            <a:solidFill>
+              <a:srgbClr val="E3DDD4"/>
+            </a:solidFill>
+            <a:prstDash val="solid"/>
+          </a:ln>
+        </p:spPr>
+      </p:sp>
+      <p:sp>
+        <p:nvSpPr>
+          <p:cNvPr id="38" name="Text 36"/>
+          <p:cNvSpPr txBox="1"/>
+          <p:nvPr/>
+        </p:nvSpPr>
+        <p:spPr>
+          <a:xfrm>
+            <a:off x="6217920" y="3730752"/>
+            <a:ext cx="2286000" cy="228600"/>
+          </a:xfrm>
+          <a:prstGeom prst="rect">
+            <a:avLst/>
+          </a:prstGeom>
+          <a:noFill/>
+          <a:ln/>
+        </p:spPr>
+        <p:txBody>
+          <a:bodyPr wrap="square" lIns="0" tIns="0" rIns="0" bIns="0" rtlCol="0" anchor="ctr"/>
+          <a:lstStyle/>
+          <a:p>
+            <a:pPr indent="0" marL="0">
+              <a:buNone/>
+            </a:pPr>
+            <a:r>
+              <a:rPr lang="en-US" sz="850" b="1" dirty="0">
+                <a:solidFill>
+                  <a:srgbClr val="5B6468"/>
+                </a:solidFill>
+                <a:latin typeface="Arial" pitchFamily="34" charset="0"/>
+                <a:ea typeface="Arial" pitchFamily="34" charset="-122"/>
+                <a:cs typeface="Arial" pitchFamily="34" charset="-120"/>
+              </a:rPr>
+              <a:t>Break-even</a:t>
+            </a:r>
+            <a:endParaRPr lang="en-US" sz="850" dirty="0"/>
+          </a:p>
+        </p:txBody>
+      </p:sp>
+      <p:sp>
+        <p:nvSpPr>
+          <p:cNvPr id="39" name="Text 37"/>
+          <p:cNvSpPr txBox="1"/>
+          <p:nvPr/>
+        </p:nvSpPr>
+        <p:spPr>
+          <a:xfrm>
+            <a:off x="6217920" y="3950208"/>
+            <a:ext cx="2286000" cy="320040"/>
+          </a:xfrm>
+          <a:prstGeom prst="rect">
+            <a:avLst/>
+          </a:prstGeom>
+          <a:noFill/>
+          <a:ln/>
+        </p:spPr>
+        <p:txBody>
+          <a:bodyPr wrap="square" lIns="0" tIns="0" rIns="0" bIns="0" rtlCol="0" anchor="ctr"/>
+          <a:lstStyle/>
+          <a:p>
+            <a:pPr indent="0" marL="0">
+              <a:buNone/>
+            </a:pPr>
+            <a:r>
+              <a:rPr lang="en-US" sz="1500" b="1" dirty="0">
+                <a:solidFill>
+                  <a:srgbClr val="1C2326"/>
+                </a:solidFill>
+                <a:latin typeface="Arial" pitchFamily="34" charset="0"/>
+                <a:ea typeface="Arial" pitchFamily="34" charset="-122"/>
+                <a:cs typeface="Arial" pitchFamily="34" charset="-120"/>
+              </a:rPr>
+              <a:t>12 Projekte pro Jahr</a:t>
+            </a:r>
+            <a:endParaRPr lang="en-US" sz="1500" dirty="0"/>
+          </a:p>
+        </p:txBody>
+      </p:sp>
+      <p:sp>
+        <p:nvSpPr>
+          <p:cNvPr id="40" name="Text 38"/>
+          <p:cNvSpPr txBox="1"/>
+          <p:nvPr/>
+        </p:nvSpPr>
+        <p:spPr>
+          <a:xfrm>
+            <a:off x="6217920" y="4279392"/>
+            <a:ext cx="2286000" cy="274320"/>
+          </a:xfrm>
+          <a:prstGeom prst="rect">
+            <a:avLst/>
+          </a:prstGeom>
+          <a:noFill/>
+          <a:ln/>
+        </p:spPr>
+        <p:txBody>
+          <a:bodyPr wrap="square" lIns="0" tIns="0" rIns="0" bIns="0" rtlCol="0" anchor="ctr"/>
+          <a:lstStyle/>
+          <a:p>
+            <a:pPr indent="0" marL="0">
+              <a:buNone/>
+            </a:pPr>
+            <a:r>
+              <a:rPr lang="en-US" sz="850" dirty="0">
+                <a:solidFill>
+                  <a:srgbClr val="1C2326"/>
+                </a:solidFill>
+                <a:latin typeface="Arial" pitchFamily="34" charset="0"/>
+                <a:ea typeface="Arial" pitchFamily="34" charset="-122"/>
+                <a:cs typeface="Arial" pitchFamily="34" charset="-120"/>
+              </a:rPr>
+              <a:t>danach rund 80 % Marge pro Projekt</a:t>
+            </a:r>
+            <a:endParaRPr lang="en-US" sz="850" dirty="0"/>
+          </a:p>
+        </p:txBody>
+      </p:sp>
+      <p:sp>
+        <p:nvSpPr>
+          <p:cNvPr id="41" name="Text 39"/>
+          <p:cNvSpPr txBox="1"/>
+          <p:nvPr/>
+        </p:nvSpPr>
+        <p:spPr>
+          <a:xfrm>
+            <a:off x="457200" y="4626864"/>
+            <a:ext cx="8229600" cy="182880"/>
+          </a:xfrm>
+          <a:prstGeom prst="rect">
+            <a:avLst/>
+          </a:prstGeom>
+          <a:noFill/>
+          <a:ln/>
+        </p:spPr>
+        <p:txBody>
+          <a:bodyPr wrap="square" lIns="0" tIns="0" rIns="0" bIns="0" rtlCol="0" anchor="ctr"/>
+          <a:lstStyle/>
+          <a:p>
+            <a:pPr indent="0" marL="0">
+              <a:buNone/>
+            </a:pPr>
+            <a:r>
+              <a:rPr lang="en-US" sz="750" dirty="0">
+                <a:solidFill>
+                  <a:srgbClr val="5B6468"/>
+                </a:solidFill>
+                <a:latin typeface="Arial" pitchFamily="34" charset="0"/>
+                <a:ea typeface="Arial" pitchFamily="34" charset="-122"/>
+                <a:cs typeface="Arial" pitchFamily="34" charset="-120"/>
+              </a:rPr>
+              <a:t>Preise, Kosten und Rechenbeispiel sind Annahmen, die wir in den Pilotgesprächen prüfen.</a:t>
+            </a:r>
+            <a:endParaRPr lang="en-US" sz="750" dirty="0"/>
           </a:p>
         </p:txBody>
       </p:sp>
@@ -9121,7 +10564,7 @@
                   <a:schemeClr val="tx1"/>
                 </a:solidFill>
               </a:rPr>
-              <a:t>Die Eigentümerschaft zahlt pro Projekt. Ein Rochade-Werkzeug fehlt.</a:t>
+              <a:t>Der Markt: jede Sanierung ab 20 Wohnungen. Ein Rochade-Werkzeug fehlt.</a:t>
             </a:r>
             <a:endParaRPr lang="en-US" sz="3000" dirty="0"/>
           </a:p>
@@ -9138,10 +10581,150 @@
             <a:off x="457200" y="1280160"/>
             <a:ext cx="3474720" cy="1005840"/>
           </a:xfrm>
-          <a:prstGeom prst="roundRect">
-            <a:avLst>
-              <a:gd name="adj" fmla="val 12727"/>
-            </a:avLst>
+          <a:prstGeom prst="rect">
+            <a:avLst/>
+          </a:prstGeom>
+          <a:solidFill>
+            <a:srgbClr val="E2ECEE"/>
+          </a:solidFill>
+          <a:ln w="12700">
+            <a:solidFill>
+              <a:srgbClr val="E2ECEE"/>
+            </a:solidFill>
+            <a:prstDash val="solid"/>
+          </a:ln>
+        </p:spPr>
+      </p:sp>
+      <p:sp>
+        <p:nvSpPr>
+          <p:cNvPr id="4" name="Text 2"/>
+          <p:cNvSpPr txBox="1"/>
+          <p:nvPr/>
+        </p:nvSpPr>
+        <p:spPr>
+          <a:xfrm>
+            <a:off x="640080" y="1353312"/>
+            <a:ext cx="3108960" cy="228600"/>
+          </a:xfrm>
+          <a:prstGeom prst="rect">
+            <a:avLst/>
+          </a:prstGeom>
+          <a:noFill/>
+          <a:ln/>
+        </p:spPr>
+        <p:txBody>
+          <a:bodyPr wrap="square" lIns="0" tIns="0" rIns="0" bIns="0" rtlCol="0" anchor="ctr"/>
+          <a:lstStyle/>
+          <a:p>
+            <a:pPr indent="0" marL="0">
+              <a:buNone/>
+            </a:pPr>
+            <a:r>
+              <a:rPr lang="en-US" sz="900" b="1" dirty="0">
+                <a:solidFill>
+                  <a:srgbClr val="5B6468"/>
+                </a:solidFill>
+                <a:latin typeface="Arial" pitchFamily="34" charset="0"/>
+                <a:ea typeface="Arial" pitchFamily="34" charset="-122"/>
+                <a:cs typeface="Arial" pitchFamily="34" charset="-120"/>
+              </a:rPr>
+              <a:t>Markt Schweiz</a:t>
+            </a:r>
+            <a:endParaRPr lang="en-US" sz="900" dirty="0"/>
+          </a:p>
+        </p:txBody>
+      </p:sp>
+      <p:sp>
+        <p:nvSpPr>
+          <p:cNvPr id="5" name="Text 3"/>
+          <p:cNvSpPr txBox="1"/>
+          <p:nvPr/>
+        </p:nvSpPr>
+        <p:spPr>
+          <a:xfrm>
+            <a:off x="640080" y="1572768"/>
+            <a:ext cx="3108960" cy="292608"/>
+          </a:xfrm>
+          <a:prstGeom prst="rect">
+            <a:avLst/>
+          </a:prstGeom>
+          <a:noFill/>
+          <a:ln/>
+        </p:spPr>
+        <p:txBody>
+          <a:bodyPr wrap="square" lIns="0" tIns="0" rIns="0" bIns="0" rtlCol="0" anchor="ctr"/>
+          <a:lstStyle/>
+          <a:p>
+            <a:pPr indent="0" marL="0">
+              <a:buNone/>
+            </a:pPr>
+            <a:r>
+              <a:rPr lang="en-US" sz="1300" b="1" dirty="0">
+                <a:solidFill>
+                  <a:srgbClr val="1C2326"/>
+                </a:solidFill>
+                <a:latin typeface="Arial" pitchFamily="34" charset="0"/>
+                <a:ea typeface="Arial" pitchFamily="34" charset="-122"/>
+                <a:cs typeface="Arial" pitchFamily="34" charset="-120"/>
+              </a:rPr>
+              <a:t>&gt; 2'000 Häuser pro Jahr</a:t>
+            </a:r>
+            <a:endParaRPr lang="en-US" sz="1300" dirty="0"/>
+          </a:p>
+        </p:txBody>
+      </p:sp>
+      <p:sp>
+        <p:nvSpPr>
+          <p:cNvPr id="6" name="Text 4"/>
+          <p:cNvSpPr txBox="1"/>
+          <p:nvPr/>
+        </p:nvSpPr>
+        <p:spPr>
+          <a:xfrm>
+            <a:off x="640080" y="1883664"/>
+            <a:ext cx="3108960" cy="384048"/>
+          </a:xfrm>
+          <a:prstGeom prst="rect">
+            <a:avLst/>
+          </a:prstGeom>
+          <a:noFill/>
+          <a:ln/>
+        </p:spPr>
+        <p:txBody>
+          <a:bodyPr wrap="square" lIns="0" tIns="0" rIns="0" bIns="0" rtlCol="0" anchor="t"/>
+          <a:lstStyle/>
+          <a:p>
+            <a:pPr indent="0" marL="0">
+              <a:buNone/>
+            </a:pPr>
+            <a:r>
+              <a:rPr lang="en-US" sz="850" dirty="0">
+                <a:solidFill>
+                  <a:srgbClr val="1C2326"/>
+                </a:solidFill>
+                <a:latin typeface="Arial" pitchFamily="34" charset="0"/>
+                <a:ea typeface="Arial" pitchFamily="34" charset="-122"/>
+                <a:cs typeface="Arial" pitchFamily="34" charset="-120"/>
+              </a:rPr>
+              <a:t>werden komplett leergekündigt; über 1 Mio. Wohngebäude sind sanierungsbedürftig, saniert wird 1 % pro Jahr.</a:t>
+            </a:r>
+            <a:endParaRPr lang="en-US" sz="850" dirty="0"/>
+          </a:p>
+        </p:txBody>
+      </p:sp>
+      <p:sp>
+        <p:nvSpPr>
+          <p:cNvPr id="7" name="Shape 5"/>
+          <p:cNvSpPr/>
+          <p:nvPr/>
+        </p:nvSpPr>
+        <p:spPr>
+          <a:xfrm>
+            <a:off x="457200" y="2395728"/>
+            <a:ext cx="3474720" cy="1005840"/>
+          </a:xfrm>
+          <a:prstGeom prst="rect">
+            <a:avLst/>
           </a:prstGeom>
           <a:solidFill>
             <a:srgbClr val="FDEBDD"/>
@@ -9156,13 +10739,13 @@
       </p:sp>
       <p:sp>
         <p:nvSpPr>
-          <p:cNvPr id="4" name="Text 2"/>
-          <p:cNvSpPr txBox="1"/>
-          <p:nvPr/>
-        </p:nvSpPr>
-        <p:spPr>
-          <a:xfrm>
-            <a:off x="640080" y="1353312"/>
+          <p:cNvPr id="8" name="Text 6"/>
+          <p:cNvSpPr txBox="1"/>
+          <p:nvPr/>
+        </p:nvSpPr>
+        <p:spPr>
+          <a:xfrm>
+            <a:off x="640080" y="2468880"/>
             <a:ext cx="3108960" cy="228600"/>
           </a:xfrm>
           <a:prstGeom prst="rect">
@@ -9187,7 +10770,7 @@
                 <a:ea typeface="Arial" pitchFamily="34" charset="-122"/>
                 <a:cs typeface="Arial" pitchFamily="34" charset="-120"/>
               </a:rPr>
-              <a:t>Preis</a:t>
+              <a:t>Erster Markt Zürich</a:t>
             </a:r>
             <a:endParaRPr lang="en-US" sz="900" dirty="0"/>
           </a:p>
@@ -9195,13 +10778,13 @@
       </p:sp>
       <p:sp>
         <p:nvSpPr>
-          <p:cNvPr id="5" name="Text 3"/>
-          <p:cNvSpPr txBox="1"/>
-          <p:nvPr/>
-        </p:nvSpPr>
-        <p:spPr>
-          <a:xfrm>
-            <a:off x="640080" y="1572768"/>
+          <p:cNvPr id="9" name="Text 7"/>
+          <p:cNvSpPr txBox="1"/>
+          <p:nvPr/>
+        </p:nvSpPr>
+        <p:spPr>
+          <a:xfrm>
+            <a:off x="640080" y="2688336"/>
             <a:ext cx="3108960" cy="292608"/>
           </a:xfrm>
           <a:prstGeom prst="rect">
@@ -9226,7 +10809,7 @@
                 <a:ea typeface="Arial" pitchFamily="34" charset="-122"/>
                 <a:cs typeface="Arial" pitchFamily="34" charset="-120"/>
               </a:rPr>
-              <a:t>1 ‰ der Sanierungssumme</a:t>
+              <a:t>58'100 gemeinnützige Wohnungen</a:t>
             </a:r>
             <a:endParaRPr lang="en-US" sz="1300" dirty="0"/>
           </a:p>
@@ -9234,14 +10817,14 @@
       </p:sp>
       <p:sp>
         <p:nvSpPr>
-          <p:cNvPr id="6" name="Text 4"/>
-          <p:cNvSpPr txBox="1"/>
-          <p:nvPr/>
-        </p:nvSpPr>
-        <p:spPr>
-          <a:xfrm>
-            <a:off x="640080" y="1883664"/>
-            <a:ext cx="3108960" cy="365760"/>
+          <p:cNvPr id="10" name="Text 8"/>
+          <p:cNvSpPr txBox="1"/>
+          <p:nvPr/>
+        </p:nvSpPr>
+        <p:spPr>
+          <a:xfrm>
+            <a:off x="640080" y="2999232"/>
+            <a:ext cx="3108960" cy="384048"/>
           </a:xfrm>
           <a:prstGeom prst="rect">
             <a:avLst/>
@@ -9257,7 +10840,7 @@
               <a:buNone/>
             </a:pPr>
             <a:r>
-              <a:rPr lang="en-US" sz="900" dirty="0">
+              <a:rPr lang="en-US" sz="850" dirty="0">
                 <a:solidFill>
                   <a:srgbClr val="1C2326"/>
                 </a:solidFill>
@@ -9265,27 +10848,25 @@
                 <a:ea typeface="Arial" pitchFamily="34" charset="-122"/>
                 <a:cs typeface="Arial" pitchFamily="34" charset="-120"/>
               </a:rPr>
-              <a:t>Mindestens CHF 5'000. 10 Mio. → CHF 10'000. Eine Woche Bauverzug kostet mehr.</a:t>
-            </a:r>
-            <a:endParaRPr lang="en-US" sz="900" dirty="0"/>
-          </a:p>
-        </p:txBody>
-      </p:sp>
-      <p:sp>
-        <p:nvSpPr>
-          <p:cNvPr id="7" name="Shape 5"/>
+              <a:t>27 % der Mietwohnungen, Ziel 2050 ein Drittel. Genossenschaften dürfen nicht kündigen und sanieren in Etappen.</a:t>
+            </a:r>
+            <a:endParaRPr lang="en-US" sz="850" dirty="0"/>
+          </a:p>
+        </p:txBody>
+      </p:sp>
+      <p:sp>
+        <p:nvSpPr>
+          <p:cNvPr id="11" name="Shape 9"/>
           <p:cNvSpPr/>
           <p:nvPr/>
         </p:nvSpPr>
         <p:spPr>
           <a:xfrm>
-            <a:off x="457200" y="2395728"/>
+            <a:off x="457200" y="3511296"/>
             <a:ext cx="3474720" cy="1005840"/>
           </a:xfrm>
-          <a:prstGeom prst="roundRect">
-            <a:avLst>
-              <a:gd name="adj" fmla="val 12727"/>
-            </a:avLst>
+          <a:prstGeom prst="rect">
+            <a:avLst/>
           </a:prstGeom>
           <a:solidFill>
             <a:srgbClr val="F1EDE6"/>
@@ -9300,150 +10881,6 @@
       </p:sp>
       <p:sp>
         <p:nvSpPr>
-          <p:cNvPr id="8" name="Text 6"/>
-          <p:cNvSpPr txBox="1"/>
-          <p:nvPr/>
-        </p:nvSpPr>
-        <p:spPr>
-          <a:xfrm>
-            <a:off x="640080" y="2468880"/>
-            <a:ext cx="3108960" cy="228600"/>
-          </a:xfrm>
-          <a:prstGeom prst="rect">
-            <a:avLst/>
-          </a:prstGeom>
-          <a:noFill/>
-          <a:ln/>
-        </p:spPr>
-        <p:txBody>
-          <a:bodyPr wrap="square" lIns="0" tIns="0" rIns="0" bIns="0" rtlCol="0" anchor="ctr"/>
-          <a:lstStyle/>
-          <a:p>
-            <a:pPr indent="0" marL="0">
-              <a:buNone/>
-            </a:pPr>
-            <a:r>
-              <a:rPr lang="en-US" sz="900" b="1" dirty="0">
-                <a:solidFill>
-                  <a:srgbClr val="5B6468"/>
-                </a:solidFill>
-                <a:latin typeface="Arial" pitchFamily="34" charset="0"/>
-                <a:ea typeface="Arial" pitchFamily="34" charset="-122"/>
-                <a:cs typeface="Arial" pitchFamily="34" charset="-120"/>
-              </a:rPr>
-              <a:t>Break-even</a:t>
-            </a:r>
-            <a:endParaRPr lang="en-US" sz="900" dirty="0"/>
-          </a:p>
-        </p:txBody>
-      </p:sp>
-      <p:sp>
-        <p:nvSpPr>
-          <p:cNvPr id="9" name="Text 7"/>
-          <p:cNvSpPr txBox="1"/>
-          <p:nvPr/>
-        </p:nvSpPr>
-        <p:spPr>
-          <a:xfrm>
-            <a:off x="640080" y="2688336"/>
-            <a:ext cx="3108960" cy="292608"/>
-          </a:xfrm>
-          <a:prstGeom prst="rect">
-            <a:avLst/>
-          </a:prstGeom>
-          <a:noFill/>
-          <a:ln/>
-        </p:spPr>
-        <p:txBody>
-          <a:bodyPr wrap="square" lIns="0" tIns="0" rIns="0" bIns="0" rtlCol="0" anchor="ctr"/>
-          <a:lstStyle/>
-          <a:p>
-            <a:pPr indent="0" marL="0">
-              <a:buNone/>
-            </a:pPr>
-            <a:r>
-              <a:rPr lang="en-US" sz="1300" b="1" dirty="0">
-                <a:solidFill>
-                  <a:srgbClr val="1C2326"/>
-                </a:solidFill>
-                <a:latin typeface="Arial" pitchFamily="34" charset="0"/>
-                <a:ea typeface="Arial" pitchFamily="34" charset="-122"/>
-                <a:cs typeface="Arial" pitchFamily="34" charset="-120"/>
-              </a:rPr>
-              <a:t>12 Projekte pro Jahr</a:t>
-            </a:r>
-            <a:endParaRPr lang="en-US" sz="1300" dirty="0"/>
-          </a:p>
-        </p:txBody>
-      </p:sp>
-      <p:sp>
-        <p:nvSpPr>
-          <p:cNvPr id="10" name="Text 8"/>
-          <p:cNvSpPr txBox="1"/>
-          <p:nvPr/>
-        </p:nvSpPr>
-        <p:spPr>
-          <a:xfrm>
-            <a:off x="640080" y="2999232"/>
-            <a:ext cx="3108960" cy="365760"/>
-          </a:xfrm>
-          <a:prstGeom prst="rect">
-            <a:avLst/>
-          </a:prstGeom>
-          <a:noFill/>
-          <a:ln/>
-        </p:spPr>
-        <p:txBody>
-          <a:bodyPr wrap="square" lIns="0" tIns="0" rIns="0" bIns="0" rtlCol="0" anchor="t"/>
-          <a:lstStyle/>
-          <a:p>
-            <a:pPr indent="0" marL="0">
-              <a:buNone/>
-            </a:pPr>
-            <a:r>
-              <a:rPr lang="en-US" sz="900" dirty="0">
-                <a:solidFill>
-                  <a:srgbClr val="1C2326"/>
-                </a:solidFill>
-                <a:latin typeface="Arial" pitchFamily="34" charset="0"/>
-                <a:ea typeface="Arial" pitchFamily="34" charset="-122"/>
-                <a:cs typeface="Arial" pitchFamily="34" charset="-120"/>
-              </a:rPr>
-              <a:t>Kosten Jahr 1 rund CHF 120'000: 1,5 Stellen, Hosting, Vertrieb. Annahmen.</a:t>
-            </a:r>
-            <a:endParaRPr lang="en-US" sz="900" dirty="0"/>
-          </a:p>
-        </p:txBody>
-      </p:sp>
-      <p:sp>
-        <p:nvSpPr>
-          <p:cNvPr id="11" name="Shape 9"/>
-          <p:cNvSpPr/>
-          <p:nvPr/>
-        </p:nvSpPr>
-        <p:spPr>
-          <a:xfrm>
-            <a:off x="457200" y="3511296"/>
-            <a:ext cx="3474720" cy="1005840"/>
-          </a:xfrm>
-          <a:prstGeom prst="roundRect">
-            <a:avLst>
-              <a:gd name="adj" fmla="val 12727"/>
-            </a:avLst>
-          </a:prstGeom>
-          <a:solidFill>
-            <a:srgbClr val="E2ECEE"/>
-          </a:solidFill>
-          <a:ln w="12700">
-            <a:solidFill>
-              <a:srgbClr val="E2ECEE"/>
-            </a:solidFill>
-            <a:prstDash val="solid"/>
-          </a:ln>
-        </p:spPr>
-      </p:sp>
-      <p:sp>
-        <p:nvSpPr>
           <p:cNvPr id="12" name="Text 10"/>
           <p:cNvSpPr txBox="1"/>
           <p:nvPr/>
@@ -9475,7 +10912,7 @@
                 <a:ea typeface="Arial" pitchFamily="34" charset="-122"/>
                 <a:cs typeface="Arial" pitchFamily="34" charset="-120"/>
               </a:rPr>
-              <a:t>Markt</a:t>
+              <a:t>Einstieg</a:t>
             </a:r>
             <a:endParaRPr lang="en-US" sz="900" dirty="0"/>
           </a:p>
@@ -9514,7 +10951,7 @@
                 <a:ea typeface="Arial" pitchFamily="34" charset="-122"/>
                 <a:cs typeface="Arial" pitchFamily="34" charset="-120"/>
               </a:rPr>
-              <a:t>58'100 gemeinnützige Wohnungen</a:t>
+              <a:t>Pilot 2027, zwei Genossenschaften</a:t>
             </a:r>
             <a:endParaRPr lang="en-US" sz="1300" dirty="0"/>
           </a:p>
@@ -9529,7 +10966,7 @@
         <p:spPr>
           <a:xfrm>
             <a:off x="640080" y="4114800"/>
-            <a:ext cx="3108960" cy="365760"/>
+            <a:ext cx="3108960" cy="384048"/>
           </a:xfrm>
           <a:prstGeom prst="rect">
             <a:avLst/>
@@ -9545,7 +10982,7 @@
               <a:buNone/>
             </a:pPr>
             <a:r>
-              <a:rPr lang="en-US" sz="900" dirty="0">
+              <a:rPr lang="en-US" sz="850" dirty="0">
                 <a:solidFill>
                   <a:srgbClr val="1C2326"/>
                 </a:solidFill>
@@ -9553,9 +10990,9 @@
                 <a:ea typeface="Arial" pitchFamily="34" charset="-122"/>
                 <a:cs typeface="Arial" pitchFamily="34" charset="-120"/>
               </a:rPr>
-              <a:t>in der Stadt Zürich. Schweizweit &gt; 1 Mio. sanierungsbedürftige Wohngebäude, 1 % pro Jahr.</a:t>
-            </a:r>
-            <a:endParaRPr lang="en-US" sz="900" dirty="0"/>
+              <a:t>gratis gegen echte Daten. Dann über die Verbände. Hebel: die Zürcher Prüfpflicht.</a:t>
+            </a:r>
+            <a:endParaRPr lang="en-US" sz="850" dirty="0"/>
           </a:p>
         </p:txBody>
       </p:sp>
@@ -9587,7 +11024,7 @@
                 <a:gridCol w="1051560"/>
                 <a:gridCol w="960120"/>
               </a:tblGrid>
-              <a:tr h="338328">
+              <a:tr h="384048">
                 <a:tc>
                   <a:txBody>
                     <a:bodyPr/>
@@ -9861,7 +11298,7 @@
                   </a:tcPr>
                 </a:tc>
               </a:tr>
-              <a:tr h="338328">
+              <a:tr h="384048">
                 <a:tc>
                   <a:txBody>
                     <a:bodyPr/>
@@ -10135,7 +11572,7 @@
                   </a:tcPr>
                 </a:tc>
               </a:tr>
-              <a:tr h="338328">
+              <a:tr h="384048">
                 <a:tc>
                   <a:txBody>
                     <a:bodyPr/>
@@ -10409,7 +11846,7 @@
                   </a:tcPr>
                 </a:tc>
               </a:tr>
-              <a:tr h="338328">
+              <a:tr h="384048">
                 <a:tc>
                   <a:txBody>
                     <a:bodyPr/>
@@ -10683,7 +12120,7 @@
                   </a:tcPr>
                 </a:tc>
               </a:tr>
-              <a:tr h="338328">
+              <a:tr h="384048">
                 <a:tc>
                   <a:txBody>
                     <a:bodyPr/>
@@ -10957,7 +12394,7 @@
                   </a:tcPr>
                 </a:tc>
               </a:tr>
-              <a:tr h="338328">
+              <a:tr h="384048">
                 <a:tc>
                   <a:txBody>
                     <a:bodyPr/>
@@ -11231,7 +12668,7 @@
                   </a:tcPr>
                 </a:tc>
               </a:tr>
-              <a:tr h="338328">
+              <a:tr h="384048">
                 <a:tc>
                   <a:txBody>
                     <a:bodyPr/>
@@ -11517,24 +12954,24 @@
         </p:nvSpPr>
         <p:spPr>
           <a:xfrm>
-            <a:off x="4114800" y="3675888"/>
-            <a:ext cx="4572000" cy="228600"/>
-          </a:xfrm>
-          <a:prstGeom prst="rect">
-            <a:avLst/>
-          </a:prstGeom>
-          <a:noFill/>
-          <a:ln/>
-        </p:spPr>
-        <p:txBody>
-          <a:bodyPr wrap="square" lIns="0" tIns="0" rIns="0" bIns="0" rtlCol="0" anchor="ctr"/>
+            <a:off x="4114800" y="4023360"/>
+            <a:ext cx="4572000" cy="548640"/>
+          </a:xfrm>
+          <a:prstGeom prst="rect">
+            <a:avLst/>
+          </a:prstGeom>
+          <a:noFill/>
+          <a:ln/>
+        </p:spPr>
+        <p:txBody>
+          <a:bodyPr wrap="square" lIns="0" tIns="0" rIns="0" bIns="0" rtlCol="0" anchor="t"/>
           <a:lstStyle/>
           <a:p>
             <a:pPr indent="0" marL="0">
               <a:buNone/>
             </a:pPr>
             <a:r>
-              <a:rPr lang="en-US" sz="800" dirty="0">
+              <a:rPr lang="en-US" sz="850" dirty="0">
                 <a:solidFill>
                   <a:srgbClr val="5B6468"/>
                 </a:solidFill>
@@ -11542,114 +12979,9 @@
                 <a:ea typeface="Arial" pitchFamily="34" charset="-122"/>
                 <a:cs typeface="Arial" pitchFamily="34" charset="-120"/>
               </a:rPr>
-              <a:t>Produktseiten, 24. Oktober 2026. In Grossbritannien existiert «Decant» für Mieterumzüge.</a:t>
-            </a:r>
-            <a:endParaRPr lang="en-US" sz="800" dirty="0"/>
-          </a:p>
-        </p:txBody>
-      </p:sp>
-      <p:sp>
-        <p:nvSpPr>
-          <p:cNvPr id="17" name="Shape 14"/>
-          <p:cNvSpPr/>
-          <p:nvPr/>
-        </p:nvSpPr>
-        <p:spPr>
-          <a:xfrm>
-            <a:off x="4114800" y="3977640"/>
-            <a:ext cx="4572000" cy="640080"/>
-          </a:xfrm>
-          <a:prstGeom prst="roundRect">
-            <a:avLst>
-              <a:gd name="adj" fmla="val 20000"/>
-            </a:avLst>
-          </a:prstGeom>
-          <a:solidFill>
-            <a:srgbClr val="FFFFFF"/>
-          </a:solidFill>
-          <a:ln w="9525">
-            <a:solidFill>
-              <a:srgbClr val="E3DDD4"/>
-            </a:solidFill>
-            <a:prstDash val="solid"/>
-          </a:ln>
-        </p:spPr>
-      </p:sp>
-      <p:sp>
-        <p:nvSpPr>
-          <p:cNvPr id="18" name="Text 15"/>
-          <p:cNvSpPr txBox="1"/>
-          <p:nvPr/>
-        </p:nvSpPr>
-        <p:spPr>
-          <a:xfrm>
-            <a:off x="4297680" y="4023360"/>
-            <a:ext cx="914400" cy="228600"/>
-          </a:xfrm>
-          <a:prstGeom prst="rect">
-            <a:avLst/>
-          </a:prstGeom>
-          <a:noFill/>
-          <a:ln/>
-        </p:spPr>
-        <p:txBody>
-          <a:bodyPr wrap="square" lIns="0" tIns="0" rIns="0" bIns="0" rtlCol="0" anchor="ctr"/>
-          <a:lstStyle/>
-          <a:p>
-            <a:pPr indent="0" marL="0">
-              <a:buNone/>
-            </a:pPr>
-            <a:r>
-              <a:rPr lang="en-US" sz="900" b="1" dirty="0">
-                <a:solidFill>
-                  <a:srgbClr val="5B6468"/>
-                </a:solidFill>
-                <a:latin typeface="Arial" pitchFamily="34" charset="0"/>
-                <a:ea typeface="Arial" pitchFamily="34" charset="-122"/>
-                <a:cs typeface="Arial" pitchFamily="34" charset="-120"/>
-              </a:rPr>
-              <a:t>Einstieg</a:t>
-            </a:r>
-            <a:endParaRPr lang="en-US" sz="900" dirty="0"/>
-          </a:p>
-        </p:txBody>
-      </p:sp>
-      <p:sp>
-        <p:nvSpPr>
-          <p:cNvPr id="19" name="Text 16"/>
-          <p:cNvSpPr txBox="1"/>
-          <p:nvPr/>
-        </p:nvSpPr>
-        <p:spPr>
-          <a:xfrm>
-            <a:off x="4297680" y="4224528"/>
-            <a:ext cx="4206240" cy="365760"/>
-          </a:xfrm>
-          <a:prstGeom prst="rect">
-            <a:avLst/>
-          </a:prstGeom>
-          <a:noFill/>
-          <a:ln/>
-        </p:spPr>
-        <p:txBody>
-          <a:bodyPr wrap="square" lIns="0" tIns="0" rIns="0" bIns="0" rtlCol="0" anchor="t"/>
-          <a:lstStyle/>
-          <a:p>
-            <a:pPr indent="0" marL="0">
-              <a:buNone/>
-            </a:pPr>
-            <a:r>
-              <a:rPr lang="en-US" sz="950" dirty="0">
-                <a:solidFill>
-                  <a:srgbClr val="1C2326"/>
-                </a:solidFill>
-                <a:latin typeface="Arial" pitchFamily="34" charset="0"/>
-                <a:ea typeface="Arial" pitchFamily="34" charset="-122"/>
-                <a:cs typeface="Arial" pitchFamily="34" charset="-120"/>
-              </a:rPr>
-              <a:t>Pilot 2027 mit zwei Zürcher Genossenschaften, gratis gegen echte Daten. Dann über die Verbände. Hebel: die Zürcher Prüfpflicht.</a:t>
-            </a:r>
-            <a:endParaRPr lang="en-US" sz="950" dirty="0"/>
+              <a:t>Produktseiten, 24. Oktober 2026. Die Bewirtschaftungs-Software kennt Verträge, die Vermietungsplattformen die Interessenten. Die Rochade plant niemand. In Grossbritannien existiert «Decant» für Mieterumzüge.</a:t>
+            </a:r>
+            <a:endParaRPr lang="en-US" sz="850" dirty="0"/>
           </a:p>
         </p:txBody>
       </p:sp>

</xml_diff>

<commit_message>
docs: two-minute pitch script, hide reserve slides 3, 6, 9
Co-Authored-By: Claude Fable 5.1 <noreply@anthropic.com>
</commit_message>
<xml_diff>
--- a/pitch/ROCHADE_Pitch.pptx
+++ b/pitch/ROCHADE_Pitch.pptx
@@ -116,7 +116,7 @@
   <p:extLst>
     <p:ext uri="{521415D9-36F7-43E2-AB2F-B90AF26B5E84}">
       <p14:sectionLst xmlns:p14="http://schemas.microsoft.com/office/powerpoint/2010/main">
-        <p14:section name="Pitch" id="{872131a1-06cb-533c-b4db-540381dcd525}">
+        <p14:section name="Pitch" id="{285a35db-a92a-1e9a-2685-39bf48290703}">
           <p14:sldIdLst>
             <p14:sldId id="256"/>
             <p14:sldId id="257"/>
@@ -795,7 +795,7 @@
           <a:p>
             <a:r>
               <a:rPr lang="en-US" dirty="0"/>
-              <a:t>[0:00–0:15] Frau Meier, 78, wohnt seit 1994 in Höngg. Dann kommt der Brief: Sanierung, alle müssen raus. Wir sind ROCHADE. Wir sorgen dafür, dass dieser Brief nicht mehr geschrieben werden muss.</a:t>
+              <a:t>[0:00–0:12] Frau Meier, 78, seit 1994 in Höngg. Letzten März lag ein Brief im Kasten: Sanierung, Kündigung per Ende Jahr. Alle 24 Haushalte. Wir sind ROCHADE. Wir sorgen dafür, dass dieser Brief nicht mehr geschrieben werden muss.</a:t>
             </a:r>
             <a:endParaRPr lang="en-US" dirty="0"/>
           </a:p>
@@ -883,7 +883,7 @@
           <a:p>
             <a:r>
               <a:rPr lang="en-US" dirty="0"/>
-              <a:t>[3:40–4:00] Nach 24 Stunden stehen Website, Prototyp und App. Was wir jetzt brauchen: zwei Pilot-Genossenschaften, die 2027 eine Etappensanierung planen, ein Gespräch mit einer Bewirtschaftung, und euer Feedback. Jede Rochade, die gelingt, ist eine Kündigung, die nicht geschrieben wird. Danke.</a:t>
+              <a:t>[1:50–2:00] Wir brauchen zwei Genossenschaften, die 2027 in Etappen sanieren, und Ihr Feedback. Jede Rochade, die gelingt, ist ein Brief, den Frau Meier nie bekommt. Danke.</a:t>
             </a:r>
             <a:endParaRPr lang="en-US" dirty="0"/>
           </a:p>
@@ -971,7 +971,7 @@
           <a:p>
             <a:r>
               <a:rPr lang="en-US" dirty="0"/>
-              <a:t>[0:15–0:40] Das ist kein Einzelfall. 2018 bis 2022 wurden in der Schweiz 10'900 Mehrfamilienhäuser komplett leergekündigt, knapp 30'000 Menschen pro Jahr. 1'270 Häuser allein in der Stadt Zürich, Basel 380, Genf mit seinen strengen Regeln rund 100. Jedes vierte geleerte Haus in Zürich gehörte einer Genossenschaft, also genau denen, die niemanden rauswerfen wollen. Und die Angst ist da: 84 Prozent der Zürcher Mietenden sorgen sich deswegen, bei den über 55-Jährigen 91 Prozent. Die Umfrage hat der Mieterverband bezahlt, die Zahlen der ZKB nicht.</a:t>
+              <a:t>[0:12–0:32] Kein Einzelfall: 10'900 Häuser in fünf Jahren komplett leergekündigt, 30'000 Menschen pro Jahr. Zürich 1'270, Genf 100, gleiches Mietrecht. Es liegt nicht am Gesetz, sondern daran, wie saniert wird. Und 84 Prozent der Zürcher Mietenden haben Angst davor.</a:t>
             </a:r>
             <a:endParaRPr lang="en-US" dirty="0"/>
           </a:p>
@@ -1059,7 +1059,7 @@
           <a:p>
             <a:r>
               <a:rPr lang="en-US" dirty="0"/>
-              <a:t>[0:40–1:05] Drei Menschen. Rosa Meier bekommt den Brief, findet bei 0,11 Prozent Leerstand nichts, zahlt im Neubau 30 Prozent mehr; jede dritte Gekündigte muss die Gemeinde verlassen. Sandra Keller soll 49 Mietparteien durch drei Etappen schieben, in Excel, mit vierfachem Aufwand, und wenn der Bau sich verschiebt, fängt sie von vorne an. Und Reto Huber im Vorstand weiss seit den Sugus-Häusern, was eine Leerkündigung kostet: Schlichtungsbehörde, Schlagzeilen, ein Jahr Stillstand. Zürich verlangt von ihm neu den Nachweis, dass es nicht anders geht. Er ist unser Kunde.</a:t>
+              <a:t>Ausgeblendet im 2-Minuten-Pitch. Personas, Reserve für die Fragerunde «Wer ist die Zielgruppe?».</a:t>
             </a:r>
             <a:endParaRPr lang="en-US" dirty="0"/>
           </a:p>
@@ -1147,7 +1147,7 @@
           <a:p>
             <a:r>
               <a:rPr lang="en-US" dirty="0"/>
-              <a:t>[1:05–1:25] Es geht anders: die Rochade. Frau Meier zieht für fünf Monate in eine freie Wohnung in der Siedlung, ihre eigene wird saniert, dann kommt sie zurück. Ihr Mietvertrag bleibt die ganze Zeit bestehen. Die Uni Zürich hat zwölf Eigentümer und Genossenschaften befragt: Rochaden sind die mit Abstand effektivste Massnahme, aber «enorm aufwändig». Flächen finden, zuteilen, zwei Übergaben pro Haushalt, und jede Bauverschiebung wirft den Plan um. Darum machen es viele nicht, und kündigen.</a:t>
+              <a:t>[0:32–0:52] Die Lösung ist bekannt: die Rochade. Frau Meier zieht für fünf Monate ins Nachbarhaus, ihre Wohnung wird saniert, sie kommt zurück, der Mietvertrag bleibt. Die Uni Zürich nennt das die mit Abstand effektivste Massnahme, und im selben Satz: enorm aufwändig. Excel, E-Mails, vierfacher Aufwand. Darum machen es viele nicht. Und kündigen.</a:t>
             </a:r>
             <a:endParaRPr lang="en-US" dirty="0"/>
           </a:p>
@@ -1235,7 +1235,7 @@
           <a:p>
             <a:r>
               <a:rPr lang="en-US" dirty="0"/>
-              <a:t>[1:25–1:55] Darf man leerkündigen? Ja. Das Bundesgericht sagt: Die Kündigung hält, wenn der Verbleib der Mietenden die Arbeiten erheblich erschwert. Geht es bewohnt oder in Etappen, ist sie anfechtbar, und die Mietenden können bis vier Jahre Erstreckung verlangen. Genau da setzt Zürich jetzt an: Seit dem Ja vom 14. Juni müssen Eigentümer ab 20 Mietverhältnissen nachweisen, dass sie bewohnt oder etappiert geprüft haben, zwölf Monate vorher informieren, eine Ansprechperson stellen, bei der Wohnungssuche helfen. Sonst gibt es keine Baubewilligung. In Kraft frühestens Ende 2026. Für Genossenschaften ist eine Sanierung ohne Statutengrundlage gar kein Kündigungsgrund, ihre Mitglieder sind Mitbesitzer. Luzern streitet um sein Wohnraum-Gesetz, Zug hat keines, aber beim Herti-Quartier ist die Leerkündigung von 68 Wohnungen am Veto der Korporation gescheitert. Schwyz hat nur Bundesrecht und den stärksten Mietanstieg.</a:t>
+              <a:t>[0:52–1:05] Darf man das? Ja, aber nur, wenn es bewohnt oder in Etappen nicht geht. Und Zürich verlangt seit Juni ab 20 Wohnungen genau diesen Nachweis, sonst keine Baubewilligung. Den Nachweis rechnet ROCHADE.</a:t>
             </a:r>
             <a:endParaRPr lang="en-US" dirty="0"/>
           </a:p>
@@ -1323,7 +1323,7 @@
           <a:p>
             <a:r>
               <a:rPr lang="en-US" dirty="0"/>
-              <a:t>[1:55–2:20] Wer redet mit? Die Eigentümerschaft entscheidet und zahlt. Die Bewirtschaftung organisiert, heute mit vierfachem Aufwand. Die Bauleitung braucht leere Etappen zum Termin. Die Mietenden ziehen freiwillig um und wollen wissen: wohin, wann, wann zurück. Und die Gemeinde erteilt die Baubewilligung, in Zürich neu nur mit Nachweis. Rechtlich hält die Rochade so: Der Mietvertrag bleibt, also keine Kündigung und kein Gericht. Die Ausweichwohnung wird befristet vereinbart, mit Terminen, Umzugskosten und Rückkehr. Ist das Ersatzangebot gleichwertig, entfallen die Mängelrechte weitgehend, das hat das Zürcher Obergericht 2025 bestätigt. Und nach der Sanierung darf nur der wertvermehrende Anteil auf die Miete, 50 bis 70 Prozent bei einer umfassenden Überholung. ROCHADE liefert für Punkt 2 und 3 die Daten: wer, wohin, wann, zurück.</a:t>
+              <a:t>Ausgeblendet im 2-Minuten-Pitch. Parteien und Vertrag, Reserve für die Fragerunde «Kann man Mietende zwingen? Hält das rechtlich?».</a:t>
             </a:r>
             <a:endParaRPr lang="en-US" dirty="0"/>
           </a:p>
@@ -1411,7 +1411,7 @@
           <a:p>
             <a:r>
               <a:rPr lang="en-US" dirty="0"/>
-              <a:t>[2:20–2:50] Darum bauen wir ROCHADE. Die Verwaltung sieht die ganze Siedlung: Haus A wird saniert, die acht Haushalte sitzen in freien Wohnungen von Haus B, Haus C und zwei externen. Vier Regeln werden nie gebrochen: Zimmerzahl, Hindernisfreiheit, Zeitfenster, keine Doppelbelegung. Verzögert sich Etappe 1 um zwei Monate, sagt ROCHADE: 11 Konflikte. Für Hr. Aydin fehlt ab Juni 2027 eine 2,5-Zimmer-Wohnung. Etappe 2 ab November 2027 löst alles, ein Klick; in Excel wäre das ein Wochenende. Die Bewohnenden sehen auf dem Handy nur, was sie betrifft: Auszug, Wohnung, Rückkehr, live.</a:t>
+              <a:t>[1:05–1:35] Alex, live. Die Verwaltung sieht die ganze Siedlung, jeder Chip ein Haushalt. Vier Regeln, nie gebrochen: Zimmerzahl, Lift, Zeitfenster, keine Doppelbelegung. Klick: Etappe 1 zwei Monate später. Elf Konflikte, mit Namen: Für Herrn Aydin fehlt ab Juni eine 2,5-Zimmer-Wohnung. Vorschlag: Etappe 2 ab November. Klick, alles grün. In Excel ein Wochenende, hier ein Klick, und Frau Meier sieht ihr neues Datum sofort auf dem Handy.</a:t>
             </a:r>
             <a:endParaRPr lang="en-US" dirty="0"/>
           </a:p>
@@ -1499,7 +1499,7 @@
           <a:p>
             <a:r>
               <a:rPr lang="en-US" dirty="0"/>
-              <a:t>[2:50–3:15] Wie verdienen wir Geld? Die Eigentümerschaft zahlt, pro Sanierungsprojekt: ein Promille der Sanierungssumme, mindestens 5'000 Franken. Bei 10 Millionen sind das 10'000 Franken, inklusive Bewohner-App und Live-Updates. Das Nachweis-Dossier für das Baugesuch ist drin, in Zürich ab 20 Mietverhältnissen Pflicht, das ist unser Türöffner. Später ein Abo für Pensionskassen und grosse Genossenschaften mit mehreren Sanierungen im Jahr. Für den Kunden rechnet es sich sofort: Eine Leerkündigung von 24 Wohnungen kostet sechs Monate Mietzinsausfall, rund 216'000 Franken, die Rochade hält die Mieten am Laufen. Unsere Kosten pro Projekt liegen bei rund 2'000 Franken, die Fixkosten im ersten Jahr bei 120'000. Mit zwölf Projekten sind wir kostendeckend, danach rund 80 Prozent Marge. Alles Annahmen, die wir in den Pilotgesprächen prüfen.</a:t>
+              <a:t>[1:35–1:50] Die Eigentümerschaft zahlt pro Projekt ein Promille der Bausumme, mindestens 5'000 Franken. Dafür spart sie bei 24 Wohnungen rund 216'000 Franken Mietzinsausfall, weil niemand auszieht. Zwölf Projekte im Jahr, und wir sind kostendeckend. Annahmen, die wir mit zwei Pilot-Genossenschaften 2027 prüfen.</a:t>
             </a:r>
             <a:endParaRPr lang="en-US" dirty="0"/>
           </a:p>
@@ -1587,7 +1587,7 @@
           <a:p>
             <a:r>
               <a:rPr lang="en-US" dirty="0"/>
-              <a:t>[3:15–3:40] Der Markt: Über 2'000 Häuser werden in der Schweiz jedes Jahr komplett leergekündigt, über eine Million Gebäude sind sanierungsbedürftig. Wir starten in Zürich, bei den Genossenschaften: 58'100 Wohnungen, sie dürfen nicht kündigen und sanieren ohnehin in Etappen. 2027 zwei Pilot-Genossenschaften, gratis gegen echte Daten, dann über die Verbände; unser Hebel ist die Zürcher Prüfpflicht. Konkurrenz: Garaio, Abacus und Rimo kennen Verträge, emonitor und Flatfox die Vermietung. Die Rochade plant niemand, ausser Excel, von Hand.</a:t>
+              <a:t>Ausgeblendet im 2-Minuten-Pitch. Markt und Wettbewerb, Reserve für die Fragerunde «Wie gross ist der Markt? Wer ist die Konkurrenz?».</a:t>
             </a:r>
             <a:endParaRPr lang="en-US" dirty="0"/>
           </a:p>
@@ -3778,7 +3778,7 @@
 </file>
 
 <file path=ppt/slides/slide3.xml><?xml version="1.0" encoding="utf-8"?>
-<p:sld xmlns:a="http://schemas.openxmlformats.org/drawingml/2006/main" xmlns:r="http://schemas.openxmlformats.org/officeDocument/2006/relationships" xmlns:p="http://schemas.openxmlformats.org/presentationml/2006/main">
+<p:sld xmlns:a="http://schemas.openxmlformats.org/drawingml/2006/main" xmlns:r="http://schemas.openxmlformats.org/officeDocument/2006/relationships" xmlns:p="http://schemas.openxmlformats.org/presentationml/2006/main" show="0">
   <p:cSld name="Slide 3">
     <p:spTree>
       <p:nvGrpSpPr>
@@ -6883,7 +6883,7 @@
 </file>
 
 <file path=ppt/slides/slide6.xml><?xml version="1.0" encoding="utf-8"?>
-<p:sld xmlns:a="http://schemas.openxmlformats.org/drawingml/2006/main" xmlns:r="http://schemas.openxmlformats.org/officeDocument/2006/relationships" xmlns:p="http://schemas.openxmlformats.org/presentationml/2006/main">
+<p:sld xmlns:a="http://schemas.openxmlformats.org/drawingml/2006/main" xmlns:r="http://schemas.openxmlformats.org/officeDocument/2006/relationships" xmlns:p="http://schemas.openxmlformats.org/presentationml/2006/main" show="0">
   <p:cSld name="Slide 6">
     <p:spTree>
       <p:nvGrpSpPr>
@@ -10516,7 +10516,7 @@
 </file>
 
 <file path=ppt/slides/slide9.xml><?xml version="1.0" encoding="utf-8"?>
-<p:sld xmlns:a="http://schemas.openxmlformats.org/drawingml/2006/main" xmlns:r="http://schemas.openxmlformats.org/officeDocument/2006/relationships" xmlns:p="http://schemas.openxmlformats.org/presentationml/2006/main">
+<p:sld xmlns:a="http://schemas.openxmlformats.org/drawingml/2006/main" xmlns:r="http://schemas.openxmlformats.org/officeDocument/2006/relationships" xmlns:p="http://schemas.openxmlformats.org/presentationml/2006/main" show="0">
   <p:cSld name="Slide 9">
     <p:spTree>
       <p:nvGrpSpPr>

</xml_diff>

<commit_message>
docs: slide 5 answers whether ROCHADE may operate and who the players are
Co-Authored-By: Claude Fable 5.1 <noreply@anthropic.com>
</commit_message>
<xml_diff>
--- a/pitch/ROCHADE_Pitch.pptx
+++ b/pitch/ROCHADE_Pitch.pptx
@@ -116,7 +116,7 @@
   <p:extLst>
     <p:ext uri="{521415D9-36F7-43E2-AB2F-B90AF26B5E84}">
       <p14:sectionLst xmlns:p14="http://schemas.microsoft.com/office/powerpoint/2010/main">
-        <p14:section name="Pitch" id="{285a35db-a92a-1e9a-2685-39bf48290703}">
+        <p14:section name="Pitch" id="{880a67e7-d1ed-0428-a89c-6b8bd858bcae}">
           <p14:sldIdLst>
             <p14:sldId id="256"/>
             <p14:sldId id="257"/>
@@ -1235,7 +1235,7 @@
           <a:p>
             <a:r>
               <a:rPr lang="en-US" dirty="0"/>
-              <a:t>[0:52–1:05] Darf man das? Ja, aber nur, wenn es bewohnt oder in Etappen nicht geht. Und Zürich verlangt seit Juni ab 20 Wohnungen genau diesen Nachweis, sonst keine Baubewilligung. Den Nachweis rechnet ROCHADE.</a:t>
+              <a:t>[0:52–1:10] Dürfen wir das? Ja. ROCHADE ist ein Planungswerkzeug der Eigentümerin, keine Bewilligung nötig, kein Rechtsprodukt. Die Rochade selbst ist eine Vereinbarung, der Mietvertrag bleibt. Die Mitspieler: die Genossenschaft als Kundin, ihre Bewirtschaftung als Nutzerin, die Mietenden mit der App, die Bauleitung mit den Terminen, die Gemeinde mit der Baubewilligung, in Zürich neu mit unserem Nachweis, und der Mieterverband als Verbündeter.</a:t>
             </a:r>
             <a:endParaRPr lang="en-US" dirty="0"/>
           </a:p>
@@ -1323,7 +1323,7 @@
           <a:p>
             <a:r>
               <a:rPr lang="en-US" dirty="0"/>
-              <a:t>Ausgeblendet im 2-Minuten-Pitch. Parteien und Vertrag, Reserve für die Fragerunde «Kann man Mietende zwingen? Hält das rechtlich?».</a:t>
+              <a:t>Ausgeblendet im 2-Minuten-Pitch. Reserve für «Darf man leerkündigen? Was gilt in Luzern, Zug, Schwyz?». Bund: Sanierungskündigung hält nur, wenn der Verbleib der Mietenden die Arbeiten erheblich erschwert (BGE 135 III 112); sonst anfechtbar, Erstreckung bis 4 Jahre. Zürich: seit dem Ja vom 14. Juni 2026 ab 20 Mietverhältnissen Prüfpflicht bewohnt oder etappiert, 12 Monate Vorlauf, Ansprechperson, Hilfe bei der Wohnungssuche, sonst keine Baubewilligung; in Kraft frühestens Ende 2026. Genossenschaften: Sanierung ohne Statutengrundlage kein Kündigungsgrund (OR 846). Luzern: Wohnraum-Erhaltungsgesetz umkämpft, Stadt lehnte Unterstellung 24:23 ab, Initiative läuft, Abschaffung droht. Zug: kein Gesetz, Herti-Leerkündigung von 68 Wohnungen am Veto der Korporation gescheitert. Schwyz: nur Bundesrecht, Mieten +10,5 % in einem Jahr.</a:t>
             </a:r>
             <a:endParaRPr lang="en-US" dirty="0"/>
           </a:p>
@@ -5885,7 +5885,7 @@
                   <a:schemeClr val="tx1"/>
                 </a:solidFill>
               </a:rPr>
-              <a:t>Leerkündigen ist erlaubt, wenn es nicht anders geht. Zürich prüft das jetzt.</a:t>
+              <a:t>Dürfen wir das? Ja. Und das sind die Mitspieler.</a:t>
             </a:r>
             <a:endParaRPr lang="en-US" sz="3000" dirty="0"/>
           </a:p>
@@ -5900,7 +5900,689 @@
         <p:spPr>
           <a:xfrm>
             <a:off x="457200" y="1280160"/>
-            <a:ext cx="2651760" cy="2286000"/>
+            <a:ext cx="3291840" cy="3337560"/>
+          </a:xfrm>
+          <a:prstGeom prst="rect">
+            <a:avLst/>
+          </a:prstGeom>
+          <a:solidFill>
+            <a:srgbClr val="24414A"/>
+          </a:solidFill>
+          <a:ln w="12700">
+            <a:solidFill>
+              <a:srgbClr val="24414A"/>
+            </a:solidFill>
+            <a:prstDash val="solid"/>
+          </a:ln>
+        </p:spPr>
+      </p:sp>
+      <p:sp>
+        <p:nvSpPr>
+          <p:cNvPr id="4" name="Text 2"/>
+          <p:cNvSpPr txBox="1"/>
+          <p:nvPr/>
+        </p:nvSpPr>
+        <p:spPr>
+          <a:xfrm>
+            <a:off x="640080" y="1371600"/>
+            <a:ext cx="2926080" cy="274320"/>
+          </a:xfrm>
+          <a:prstGeom prst="rect">
+            <a:avLst/>
+          </a:prstGeom>
+          <a:noFill/>
+          <a:ln/>
+        </p:spPr>
+        <p:txBody>
+          <a:bodyPr wrap="square" lIns="0" tIns="0" rIns="0" bIns="0" rtlCol="0" anchor="ctr"/>
+          <a:lstStyle/>
+          <a:p>
+            <a:pPr indent="0" marL="0">
+              <a:buNone/>
+            </a:pPr>
+            <a:r>
+              <a:rPr lang="en-US" sz="1100" b="1" dirty="0">
+                <a:solidFill>
+                  <a:srgbClr val="B5C9CE"/>
+                </a:solidFill>
+                <a:latin typeface="Arial" pitchFamily="34" charset="0"/>
+                <a:ea typeface="Arial" pitchFamily="34" charset="-122"/>
+                <a:cs typeface="Arial" pitchFamily="34" charset="-120"/>
+              </a:rPr>
+              <a:t>Was ROCHADE darf</a:t>
+            </a:r>
+            <a:endParaRPr lang="en-US" sz="1100" dirty="0"/>
+          </a:p>
+        </p:txBody>
+      </p:sp>
+      <p:sp>
+        <p:nvSpPr>
+          <p:cNvPr id="5" name="Shape 3"/>
+          <p:cNvSpPr/>
+          <p:nvPr/>
+        </p:nvSpPr>
+        <p:spPr>
+          <a:xfrm>
+            <a:off x="640080" y="1764792"/>
+            <a:ext cx="274320" cy="274320"/>
+          </a:xfrm>
+          <a:prstGeom prst="rect">
+            <a:avLst/>
+          </a:prstGeom>
+          <a:solidFill>
+            <a:srgbClr val="F26A1B"/>
+          </a:solidFill>
+          <a:ln w="12700">
+            <a:solidFill>
+              <a:srgbClr val="F26A1B"/>
+            </a:solidFill>
+            <a:prstDash val="solid"/>
+          </a:ln>
+        </p:spPr>
+      </p:sp>
+      <p:sp>
+        <p:nvSpPr>
+          <p:cNvPr id="6" name="Text 4"/>
+          <p:cNvSpPr txBox="1"/>
+          <p:nvPr/>
+        </p:nvSpPr>
+        <p:spPr>
+          <a:xfrm>
+            <a:off x="640080" y="1764792"/>
+            <a:ext cx="274320" cy="274320"/>
+          </a:xfrm>
+          <a:prstGeom prst="rect">
+            <a:avLst/>
+          </a:prstGeom>
+          <a:noFill/>
+          <a:ln/>
+        </p:spPr>
+        <p:txBody>
+          <a:bodyPr wrap="square" lIns="0" tIns="0" rIns="0" bIns="0" rtlCol="0" anchor="ctr"/>
+          <a:lstStyle/>
+          <a:p>
+            <a:pPr algn="ctr" indent="0" marL="0">
+              <a:buNone/>
+            </a:pPr>
+            <a:r>
+              <a:rPr lang="en-US" sz="1000" b="1" dirty="0">
+                <a:solidFill>
+                  <a:srgbClr val="FFFFFF"/>
+                </a:solidFill>
+                <a:latin typeface="Arial" pitchFamily="34" charset="0"/>
+                <a:ea typeface="Arial" pitchFamily="34" charset="-122"/>
+                <a:cs typeface="Arial" pitchFamily="34" charset="-120"/>
+              </a:rPr>
+              <a:t>1</a:t>
+            </a:r>
+            <a:endParaRPr lang="en-US" sz="1000" dirty="0"/>
+          </a:p>
+        </p:txBody>
+      </p:sp>
+      <p:sp>
+        <p:nvSpPr>
+          <p:cNvPr id="7" name="Text 5"/>
+          <p:cNvSpPr txBox="1"/>
+          <p:nvPr/>
+        </p:nvSpPr>
+        <p:spPr>
+          <a:xfrm>
+            <a:off x="1005840" y="1737360"/>
+            <a:ext cx="2560320" cy="274320"/>
+          </a:xfrm>
+          <a:prstGeom prst="rect">
+            <a:avLst/>
+          </a:prstGeom>
+          <a:noFill/>
+          <a:ln/>
+        </p:spPr>
+        <p:txBody>
+          <a:bodyPr wrap="square" lIns="0" tIns="0" rIns="0" bIns="0" rtlCol="0" anchor="ctr"/>
+          <a:lstStyle/>
+          <a:p>
+            <a:pPr indent="0" marL="0">
+              <a:buNone/>
+            </a:pPr>
+            <a:r>
+              <a:rPr lang="en-US" sz="1150" b="1" dirty="0">
+                <a:solidFill>
+                  <a:srgbClr val="FFFFFF"/>
+                </a:solidFill>
+                <a:latin typeface="Arial" pitchFamily="34" charset="0"/>
+                <a:ea typeface="Arial" pitchFamily="34" charset="-122"/>
+                <a:cs typeface="Arial" pitchFamily="34" charset="-120"/>
+              </a:rPr>
+              <a:t>Planen, nicht entscheiden.</a:t>
+            </a:r>
+            <a:endParaRPr lang="en-US" sz="1150" dirty="0"/>
+          </a:p>
+        </p:txBody>
+      </p:sp>
+      <p:sp>
+        <p:nvSpPr>
+          <p:cNvPr id="8" name="Text 6"/>
+          <p:cNvSpPr txBox="1"/>
+          <p:nvPr/>
+        </p:nvSpPr>
+        <p:spPr>
+          <a:xfrm>
+            <a:off x="1005840" y="2011680"/>
+            <a:ext cx="2560320" cy="640080"/>
+          </a:xfrm>
+          <a:prstGeom prst="rect">
+            <a:avLst/>
+          </a:prstGeom>
+          <a:noFill/>
+          <a:ln/>
+        </p:spPr>
+        <p:txBody>
+          <a:bodyPr wrap="square" lIns="0" tIns="0" rIns="0" bIns="0" rtlCol="0" anchor="t"/>
+          <a:lstStyle/>
+          <a:p>
+            <a:pPr indent="0" marL="0">
+              <a:buNone/>
+            </a:pPr>
+            <a:r>
+              <a:rPr lang="en-US" sz="850" dirty="0">
+                <a:solidFill>
+                  <a:srgbClr val="D4E1E5"/>
+                </a:solidFill>
+                <a:latin typeface="Arial" pitchFamily="34" charset="0"/>
+                <a:ea typeface="Arial" pitchFamily="34" charset="-122"/>
+                <a:cs typeface="Arial" pitchFamily="34" charset="-120"/>
+              </a:rPr>
+              <a:t>Werkzeug der Eigentümerin. Keine Bewilligung nötig, kein Rechtsprodukt: Verträge bleiben Sache von Verwaltung und Mietenden.</a:t>
+            </a:r>
+            <a:endParaRPr lang="en-US" sz="850" dirty="0"/>
+          </a:p>
+        </p:txBody>
+      </p:sp>
+      <p:sp>
+        <p:nvSpPr>
+          <p:cNvPr id="9" name="Shape 7"/>
+          <p:cNvSpPr/>
+          <p:nvPr/>
+        </p:nvSpPr>
+        <p:spPr>
+          <a:xfrm>
+            <a:off x="640080" y="2697480"/>
+            <a:ext cx="274320" cy="274320"/>
+          </a:xfrm>
+          <a:prstGeom prst="rect">
+            <a:avLst/>
+          </a:prstGeom>
+          <a:solidFill>
+            <a:srgbClr val="F26A1B"/>
+          </a:solidFill>
+          <a:ln w="12700">
+            <a:solidFill>
+              <a:srgbClr val="F26A1B"/>
+            </a:solidFill>
+            <a:prstDash val="solid"/>
+          </a:ln>
+        </p:spPr>
+      </p:sp>
+      <p:sp>
+        <p:nvSpPr>
+          <p:cNvPr id="10" name="Text 8"/>
+          <p:cNvSpPr txBox="1"/>
+          <p:nvPr/>
+        </p:nvSpPr>
+        <p:spPr>
+          <a:xfrm>
+            <a:off x="640080" y="2697480"/>
+            <a:ext cx="274320" cy="274320"/>
+          </a:xfrm>
+          <a:prstGeom prst="rect">
+            <a:avLst/>
+          </a:prstGeom>
+          <a:noFill/>
+          <a:ln/>
+        </p:spPr>
+        <p:txBody>
+          <a:bodyPr wrap="square" lIns="0" tIns="0" rIns="0" bIns="0" rtlCol="0" anchor="ctr"/>
+          <a:lstStyle/>
+          <a:p>
+            <a:pPr algn="ctr" indent="0" marL="0">
+              <a:buNone/>
+            </a:pPr>
+            <a:r>
+              <a:rPr lang="en-US" sz="1000" b="1" dirty="0">
+                <a:solidFill>
+                  <a:srgbClr val="FFFFFF"/>
+                </a:solidFill>
+                <a:latin typeface="Arial" pitchFamily="34" charset="0"/>
+                <a:ea typeface="Arial" pitchFamily="34" charset="-122"/>
+                <a:cs typeface="Arial" pitchFamily="34" charset="-120"/>
+              </a:rPr>
+              <a:t>2</a:t>
+            </a:r>
+            <a:endParaRPr lang="en-US" sz="1000" dirty="0"/>
+          </a:p>
+        </p:txBody>
+      </p:sp>
+      <p:sp>
+        <p:nvSpPr>
+          <p:cNvPr id="11" name="Text 9"/>
+          <p:cNvSpPr txBox="1"/>
+          <p:nvPr/>
+        </p:nvSpPr>
+        <p:spPr>
+          <a:xfrm>
+            <a:off x="1005840" y="2670048"/>
+            <a:ext cx="2560320" cy="274320"/>
+          </a:xfrm>
+          <a:prstGeom prst="rect">
+            <a:avLst/>
+          </a:prstGeom>
+          <a:noFill/>
+          <a:ln/>
+        </p:spPr>
+        <p:txBody>
+          <a:bodyPr wrap="square" lIns="0" tIns="0" rIns="0" bIns="0" rtlCol="0" anchor="ctr"/>
+          <a:lstStyle/>
+          <a:p>
+            <a:pPr indent="0" marL="0">
+              <a:buNone/>
+            </a:pPr>
+            <a:r>
+              <a:rPr lang="en-US" sz="1150" b="1" dirty="0">
+                <a:solidFill>
+                  <a:srgbClr val="FFFFFF"/>
+                </a:solidFill>
+                <a:latin typeface="Arial" pitchFamily="34" charset="0"/>
+                <a:ea typeface="Arial" pitchFamily="34" charset="-122"/>
+                <a:cs typeface="Arial" pitchFamily="34" charset="-120"/>
+              </a:rPr>
+              <a:t>Die Rochade ist legal.</a:t>
+            </a:r>
+            <a:endParaRPr lang="en-US" sz="1150" dirty="0"/>
+          </a:p>
+        </p:txBody>
+      </p:sp>
+      <p:sp>
+        <p:nvSpPr>
+          <p:cNvPr id="12" name="Text 10"/>
+          <p:cNvSpPr txBox="1"/>
+          <p:nvPr/>
+        </p:nvSpPr>
+        <p:spPr>
+          <a:xfrm>
+            <a:off x="1005840" y="2944368"/>
+            <a:ext cx="2560320" cy="640080"/>
+          </a:xfrm>
+          <a:prstGeom prst="rect">
+            <a:avLst/>
+          </a:prstGeom>
+          <a:noFill/>
+          <a:ln/>
+        </p:spPr>
+        <p:txBody>
+          <a:bodyPr wrap="square" lIns="0" tIns="0" rIns="0" bIns="0" rtlCol="0" anchor="t"/>
+          <a:lstStyle/>
+          <a:p>
+            <a:pPr indent="0" marL="0">
+              <a:buNone/>
+            </a:pPr>
+            <a:r>
+              <a:rPr lang="en-US" sz="850" dirty="0">
+                <a:solidFill>
+                  <a:srgbClr val="D4E1E5"/>
+                </a:solidFill>
+                <a:latin typeface="Arial" pitchFamily="34" charset="0"/>
+                <a:ea typeface="Arial" pitchFamily="34" charset="-122"/>
+                <a:cs typeface="Arial" pitchFamily="34" charset="-120"/>
+              </a:rPr>
+              <a:t>Der Mietvertrag bleibt. Die Ausweichwohnung wird befristet vereinbart; ist sie gleichwertig, entfallen die Mängelrechte (OR 259c).</a:t>
+            </a:r>
+            <a:endParaRPr lang="en-US" sz="850" dirty="0"/>
+          </a:p>
+        </p:txBody>
+      </p:sp>
+      <p:sp>
+        <p:nvSpPr>
+          <p:cNvPr id="13" name="Shape 11"/>
+          <p:cNvSpPr/>
+          <p:nvPr/>
+        </p:nvSpPr>
+        <p:spPr>
+          <a:xfrm>
+            <a:off x="640080" y="3630168"/>
+            <a:ext cx="274320" cy="274320"/>
+          </a:xfrm>
+          <a:prstGeom prst="rect">
+            <a:avLst/>
+          </a:prstGeom>
+          <a:solidFill>
+            <a:srgbClr val="F26A1B"/>
+          </a:solidFill>
+          <a:ln w="12700">
+            <a:solidFill>
+              <a:srgbClr val="F26A1B"/>
+            </a:solidFill>
+            <a:prstDash val="solid"/>
+          </a:ln>
+        </p:spPr>
+      </p:sp>
+      <p:sp>
+        <p:nvSpPr>
+          <p:cNvPr id="14" name="Text 12"/>
+          <p:cNvSpPr txBox="1"/>
+          <p:nvPr/>
+        </p:nvSpPr>
+        <p:spPr>
+          <a:xfrm>
+            <a:off x="640080" y="3630168"/>
+            <a:ext cx="274320" cy="274320"/>
+          </a:xfrm>
+          <a:prstGeom prst="rect">
+            <a:avLst/>
+          </a:prstGeom>
+          <a:noFill/>
+          <a:ln/>
+        </p:spPr>
+        <p:txBody>
+          <a:bodyPr wrap="square" lIns="0" tIns="0" rIns="0" bIns="0" rtlCol="0" anchor="ctr"/>
+          <a:lstStyle/>
+          <a:p>
+            <a:pPr algn="ctr" indent="0" marL="0">
+              <a:buNone/>
+            </a:pPr>
+            <a:r>
+              <a:rPr lang="en-US" sz="1000" b="1" dirty="0">
+                <a:solidFill>
+                  <a:srgbClr val="FFFFFF"/>
+                </a:solidFill>
+                <a:latin typeface="Arial" pitchFamily="34" charset="0"/>
+                <a:ea typeface="Arial" pitchFamily="34" charset="-122"/>
+                <a:cs typeface="Arial" pitchFamily="34" charset="-120"/>
+              </a:rPr>
+              <a:t>3</a:t>
+            </a:r>
+            <a:endParaRPr lang="en-US" sz="1000" dirty="0"/>
+          </a:p>
+        </p:txBody>
+      </p:sp>
+      <p:sp>
+        <p:nvSpPr>
+          <p:cNvPr id="15" name="Text 13"/>
+          <p:cNvSpPr txBox="1"/>
+          <p:nvPr/>
+        </p:nvSpPr>
+        <p:spPr>
+          <a:xfrm>
+            <a:off x="1005840" y="3602736"/>
+            <a:ext cx="2560320" cy="274320"/>
+          </a:xfrm>
+          <a:prstGeom prst="rect">
+            <a:avLst/>
+          </a:prstGeom>
+          <a:noFill/>
+          <a:ln/>
+        </p:spPr>
+        <p:txBody>
+          <a:bodyPr wrap="square" lIns="0" tIns="0" rIns="0" bIns="0" rtlCol="0" anchor="ctr"/>
+          <a:lstStyle/>
+          <a:p>
+            <a:pPr indent="0" marL="0">
+              <a:buNone/>
+            </a:pPr>
+            <a:r>
+              <a:rPr lang="en-US" sz="1150" b="1" dirty="0">
+                <a:solidFill>
+                  <a:srgbClr val="FFFFFF"/>
+                </a:solidFill>
+                <a:latin typeface="Arial" pitchFamily="34" charset="0"/>
+                <a:ea typeface="Arial" pitchFamily="34" charset="-122"/>
+                <a:cs typeface="Arial" pitchFamily="34" charset="-120"/>
+              </a:rPr>
+              <a:t>Daten im Auftrag.</a:t>
+            </a:r>
+            <a:endParaRPr lang="en-US" sz="1150" dirty="0"/>
+          </a:p>
+        </p:txBody>
+      </p:sp>
+      <p:sp>
+        <p:nvSpPr>
+          <p:cNvPr id="16" name="Text 14"/>
+          <p:cNvSpPr txBox="1"/>
+          <p:nvPr/>
+        </p:nvSpPr>
+        <p:spPr>
+          <a:xfrm>
+            <a:off x="1005840" y="3877056"/>
+            <a:ext cx="2560320" cy="640080"/>
+          </a:xfrm>
+          <a:prstGeom prst="rect">
+            <a:avLst/>
+          </a:prstGeom>
+          <a:noFill/>
+          <a:ln/>
+        </p:spPr>
+        <p:txBody>
+          <a:bodyPr wrap="square" lIns="0" tIns="0" rIns="0" bIns="0" rtlCol="0" anchor="t"/>
+          <a:lstStyle/>
+          <a:p>
+            <a:pPr indent="0" marL="0">
+              <a:buNone/>
+            </a:pPr>
+            <a:r>
+              <a:rPr lang="en-US" sz="850" dirty="0">
+                <a:solidFill>
+                  <a:srgbClr val="D4E1E5"/>
+                </a:solidFill>
+                <a:latin typeface="Arial" pitchFamily="34" charset="0"/>
+                <a:ea typeface="Arial" pitchFamily="34" charset="-122"/>
+                <a:cs typeface="Arial" pitchFamily="34" charset="-120"/>
+              </a:rPr>
+              <a:t>Haushaltsdaten gehören der Eigentümerin. ROCHADE bearbeitet sie in ihrem Auftrag nach DSG, Hosting in der Schweiz geplant.</a:t>
+            </a:r>
+            <a:endParaRPr lang="en-US" sz="850" dirty="0"/>
+          </a:p>
+        </p:txBody>
+      </p:sp>
+      <p:sp>
+        <p:nvSpPr>
+          <p:cNvPr id="17" name="Shape 15"/>
+          <p:cNvSpPr/>
+          <p:nvPr/>
+        </p:nvSpPr>
+        <p:spPr>
+          <a:xfrm>
+            <a:off x="3931920" y="1280160"/>
+            <a:ext cx="1536192" cy="1609344"/>
+          </a:xfrm>
+          <a:prstGeom prst="rect">
+            <a:avLst/>
+          </a:prstGeom>
+          <a:solidFill>
+            <a:srgbClr val="FDEBDD"/>
+          </a:solidFill>
+          <a:ln w="9525">
+            <a:solidFill>
+              <a:srgbClr val="FDEBDD"/>
+            </a:solidFill>
+            <a:prstDash val="solid"/>
+          </a:ln>
+        </p:spPr>
+      </p:sp>
+      <p:sp>
+        <p:nvSpPr>
+          <p:cNvPr id="18" name="Shape 16"/>
+          <p:cNvSpPr/>
+          <p:nvPr/>
+        </p:nvSpPr>
+        <p:spPr>
+          <a:xfrm>
+            <a:off x="3931920" y="1280160"/>
+            <a:ext cx="1536192" cy="54864"/>
+          </a:xfrm>
+          <a:prstGeom prst="rect">
+            <a:avLst/>
+          </a:prstGeom>
+          <a:solidFill>
+            <a:srgbClr val="B8460E"/>
+          </a:solidFill>
+          <a:ln w="12700">
+            <a:solidFill>
+              <a:srgbClr val="B8460E"/>
+            </a:solidFill>
+            <a:prstDash val="solid"/>
+          </a:ln>
+        </p:spPr>
+      </p:sp>
+      <p:sp>
+        <p:nvSpPr>
+          <p:cNvPr id="19" name="Text 17"/>
+          <p:cNvSpPr txBox="1"/>
+          <p:nvPr/>
+        </p:nvSpPr>
+        <p:spPr>
+          <a:xfrm>
+            <a:off x="4059936" y="1426464"/>
+            <a:ext cx="1298448" cy="457200"/>
+          </a:xfrm>
+          <a:prstGeom prst="rect">
+            <a:avLst/>
+          </a:prstGeom>
+          <a:noFill/>
+          <a:ln/>
+        </p:spPr>
+        <p:txBody>
+          <a:bodyPr wrap="square" lIns="0" tIns="0" rIns="0" bIns="0" rtlCol="0" anchor="t"/>
+          <a:lstStyle/>
+          <a:p>
+            <a:pPr indent="0" marL="0">
+              <a:buNone/>
+            </a:pPr>
+            <a:r>
+              <a:rPr lang="en-US" sz="1050" b="1" dirty="0">
+                <a:solidFill>
+                  <a:srgbClr val="1C2326"/>
+                </a:solidFill>
+                <a:latin typeface="Arial" pitchFamily="34" charset="0"/>
+                <a:ea typeface="Arial" pitchFamily="34" charset="-122"/>
+                <a:cs typeface="Arial" pitchFamily="34" charset="-120"/>
+              </a:rPr>
+              <a:t>Genossenschaft, Eigentümerin</a:t>
+            </a:r>
+            <a:endParaRPr lang="en-US" sz="1050" dirty="0"/>
+          </a:p>
+        </p:txBody>
+      </p:sp>
+      <p:sp>
+        <p:nvSpPr>
+          <p:cNvPr id="20" name="Text 18"/>
+          <p:cNvSpPr txBox="1"/>
+          <p:nvPr/>
+        </p:nvSpPr>
+        <p:spPr>
+          <a:xfrm>
+            <a:off x="4059936" y="1901952"/>
+            <a:ext cx="1298448" cy="731520"/>
+          </a:xfrm>
+          <a:prstGeom prst="rect">
+            <a:avLst/>
+          </a:prstGeom>
+          <a:noFill/>
+          <a:ln/>
+        </p:spPr>
+        <p:txBody>
+          <a:bodyPr wrap="square" lIns="0" tIns="0" rIns="0" bIns="0" rtlCol="0" anchor="t"/>
+          <a:lstStyle/>
+          <a:p>
+            <a:pPr indent="0" marL="0">
+              <a:buNone/>
+            </a:pPr>
+            <a:r>
+              <a:rPr lang="en-US" sz="850" dirty="0">
+                <a:solidFill>
+                  <a:srgbClr val="1C2326"/>
+                </a:solidFill>
+                <a:latin typeface="Arial" pitchFamily="34" charset="0"/>
+                <a:ea typeface="Arial" pitchFamily="34" charset="-122"/>
+                <a:cs typeface="Arial" pitchFamily="34" charset="-120"/>
+              </a:rPr>
+              <a:t>Kundin. Entscheidet, zahlt, trägt das Risiko.</a:t>
+            </a:r>
+            <a:endParaRPr lang="en-US" sz="850" dirty="0"/>
+          </a:p>
+        </p:txBody>
+      </p:sp>
+      <p:sp>
+        <p:nvSpPr>
+          <p:cNvPr id="21" name="Shape 19"/>
+          <p:cNvSpPr/>
+          <p:nvPr/>
+        </p:nvSpPr>
+        <p:spPr>
+          <a:xfrm>
+            <a:off x="4059936" y="2596896"/>
+            <a:ext cx="685800" cy="201168"/>
+          </a:xfrm>
+          <a:prstGeom prst="rect">
+            <a:avLst/>
+          </a:prstGeom>
+          <a:solidFill>
+            <a:srgbClr val="B8460E"/>
+          </a:solidFill>
+          <a:ln w="12700">
+            <a:solidFill>
+              <a:srgbClr val="B8460E"/>
+            </a:solidFill>
+            <a:prstDash val="solid"/>
+          </a:ln>
+        </p:spPr>
+      </p:sp>
+      <p:sp>
+        <p:nvSpPr>
+          <p:cNvPr id="22" name="Text 20"/>
+          <p:cNvSpPr txBox="1"/>
+          <p:nvPr/>
+        </p:nvSpPr>
+        <p:spPr>
+          <a:xfrm>
+            <a:off x="4059936" y="2596896"/>
+            <a:ext cx="685800" cy="201168"/>
+          </a:xfrm>
+          <a:prstGeom prst="rect">
+            <a:avLst/>
+          </a:prstGeom>
+          <a:noFill/>
+          <a:ln/>
+        </p:spPr>
+        <p:txBody>
+          <a:bodyPr wrap="square" lIns="0" tIns="0" rIns="0" bIns="0" rtlCol="0" anchor="ctr"/>
+          <a:lstStyle/>
+          <a:p>
+            <a:pPr algn="ctr" indent="0" marL="0">
+              <a:buNone/>
+            </a:pPr>
+            <a:r>
+              <a:rPr lang="en-US" sz="750" b="1" dirty="0">
+                <a:solidFill>
+                  <a:srgbClr val="FFFFFF"/>
+                </a:solidFill>
+                <a:latin typeface="Arial" pitchFamily="34" charset="0"/>
+                <a:ea typeface="Arial" pitchFamily="34" charset="-122"/>
+                <a:cs typeface="Arial" pitchFamily="34" charset="-120"/>
+              </a:rPr>
+              <a:t>zahlt</a:t>
+            </a:r>
+            <a:endParaRPr lang="en-US" sz="750" dirty="0"/>
+          </a:p>
+        </p:txBody>
+      </p:sp>
+      <p:sp>
+        <p:nvSpPr>
+          <p:cNvPr id="23" name="Shape 21"/>
+          <p:cNvSpPr/>
+          <p:nvPr/>
+        </p:nvSpPr>
+        <p:spPr>
+          <a:xfrm>
+            <a:off x="5559552" y="1280160"/>
+            <a:ext cx="1536192" cy="1609344"/>
           </a:xfrm>
           <a:prstGeom prst="rect">
             <a:avLst/>
@@ -5918,53 +6600,78 @@
       </p:sp>
       <p:sp>
         <p:nvSpPr>
-          <p:cNvPr id="4" name="Text 2"/>
-          <p:cNvSpPr txBox="1"/>
-          <p:nvPr/>
-        </p:nvSpPr>
-        <p:spPr>
-          <a:xfrm>
-            <a:off x="640080" y="1371600"/>
-            <a:ext cx="2286000" cy="274320"/>
-          </a:xfrm>
-          <a:prstGeom prst="rect">
-            <a:avLst/>
-          </a:prstGeom>
-          <a:noFill/>
-          <a:ln/>
-        </p:spPr>
-        <p:txBody>
-          <a:bodyPr wrap="square" lIns="0" tIns="0" rIns="0" bIns="0" rtlCol="0" anchor="ctr"/>
+          <p:cNvPr id="24" name="Shape 22"/>
+          <p:cNvSpPr/>
+          <p:nvPr/>
+        </p:nvSpPr>
+        <p:spPr>
+          <a:xfrm>
+            <a:off x="5559552" y="1280160"/>
+            <a:ext cx="1536192" cy="54864"/>
+          </a:xfrm>
+          <a:prstGeom prst="rect">
+            <a:avLst/>
+          </a:prstGeom>
+          <a:solidFill>
+            <a:srgbClr val="24414A"/>
+          </a:solidFill>
+          <a:ln w="12700">
+            <a:solidFill>
+              <a:srgbClr val="24414A"/>
+            </a:solidFill>
+            <a:prstDash val="solid"/>
+          </a:ln>
+        </p:spPr>
+      </p:sp>
+      <p:sp>
+        <p:nvSpPr>
+          <p:cNvPr id="25" name="Text 23"/>
+          <p:cNvSpPr txBox="1"/>
+          <p:nvPr/>
+        </p:nvSpPr>
+        <p:spPr>
+          <a:xfrm>
+            <a:off x="5687568" y="1426464"/>
+            <a:ext cx="1298448" cy="457200"/>
+          </a:xfrm>
+          <a:prstGeom prst="rect">
+            <a:avLst/>
+          </a:prstGeom>
+          <a:noFill/>
+          <a:ln/>
+        </p:spPr>
+        <p:txBody>
+          <a:bodyPr wrap="square" lIns="0" tIns="0" rIns="0" bIns="0" rtlCol="0" anchor="t"/>
           <a:lstStyle/>
           <a:p>
             <a:pPr indent="0" marL="0">
               <a:buNone/>
             </a:pPr>
             <a:r>
-              <a:rPr lang="en-US" sz="900" b="1" dirty="0">
-                <a:solidFill>
-                  <a:srgbClr val="5B6468"/>
-                </a:solidFill>
-                <a:latin typeface="Arial" pitchFamily="34" charset="0"/>
-                <a:ea typeface="Arial" pitchFamily="34" charset="-122"/>
-                <a:cs typeface="Arial" pitchFamily="34" charset="-120"/>
-              </a:rPr>
-              <a:t>Bund · OR 271</a:t>
-            </a:r>
-            <a:endParaRPr lang="en-US" sz="900" dirty="0"/>
-          </a:p>
-        </p:txBody>
-      </p:sp>
-      <p:sp>
-        <p:nvSpPr>
-          <p:cNvPr id="5" name="Text 3"/>
-          <p:cNvSpPr txBox="1"/>
-          <p:nvPr/>
-        </p:nvSpPr>
-        <p:spPr>
-          <a:xfrm>
-            <a:off x="640080" y="1645920"/>
-            <a:ext cx="2286000" cy="640080"/>
+              <a:rPr lang="en-US" sz="1050" b="1" dirty="0">
+                <a:solidFill>
+                  <a:srgbClr val="1C2326"/>
+                </a:solidFill>
+                <a:latin typeface="Arial" pitchFamily="34" charset="0"/>
+                <a:ea typeface="Arial" pitchFamily="34" charset="-122"/>
+                <a:cs typeface="Arial" pitchFamily="34" charset="-120"/>
+              </a:rPr>
+              <a:t>Bewirtschaftung</a:t>
+            </a:r>
+            <a:endParaRPr lang="en-US" sz="1050" dirty="0"/>
+          </a:p>
+        </p:txBody>
+      </p:sp>
+      <p:sp>
+        <p:nvSpPr>
+          <p:cNvPr id="26" name="Text 24"/>
+          <p:cNvSpPr txBox="1"/>
+          <p:nvPr/>
+        </p:nvSpPr>
+        <p:spPr>
+          <a:xfrm>
+            <a:off x="5687568" y="1901952"/>
+            <a:ext cx="1298448" cy="731520"/>
           </a:xfrm>
           <a:prstGeom prst="rect">
             <a:avLst/>
@@ -5980,7 +6687,7 @@
               <a:buNone/>
             </a:pPr>
             <a:r>
-              <a:rPr lang="en-US" sz="1600" b="1" dirty="0">
+              <a:rPr lang="en-US" sz="850" dirty="0">
                 <a:solidFill>
                   <a:srgbClr val="1C2326"/>
                 </a:solidFill>
@@ -5988,71 +6695,32 @@
                 <a:ea typeface="Arial" pitchFamily="34" charset="-122"/>
                 <a:cs typeface="Arial" pitchFamily="34" charset="-120"/>
               </a:rPr>
-              <a:t>Erlaubt, wenn nötig</a:t>
-            </a:r>
-            <a:endParaRPr lang="en-US" sz="1600" dirty="0"/>
-          </a:p>
-        </p:txBody>
-      </p:sp>
-      <p:sp>
-        <p:nvSpPr>
-          <p:cNvPr id="6" name="Text 4"/>
-          <p:cNvSpPr txBox="1"/>
-          <p:nvPr/>
-        </p:nvSpPr>
-        <p:spPr>
-          <a:xfrm>
-            <a:off x="640080" y="2304288"/>
-            <a:ext cx="2286000" cy="1188720"/>
-          </a:xfrm>
-          <a:prstGeom prst="rect">
-            <a:avLst/>
-          </a:prstGeom>
-          <a:noFill/>
-          <a:ln/>
-        </p:spPr>
-        <p:txBody>
-          <a:bodyPr wrap="square" lIns="0" tIns="0" rIns="0" bIns="0" rtlCol="0" anchor="t"/>
-          <a:lstStyle/>
-          <a:p>
-            <a:pPr indent="0" marL="0">
-              <a:buNone/>
-            </a:pPr>
-            <a:r>
-              <a:rPr lang="en-US" sz="1000" dirty="0">
-                <a:solidFill>
-                  <a:srgbClr val="1C2326"/>
-                </a:solidFill>
-                <a:latin typeface="Arial" pitchFamily="34" charset="0"/>
-                <a:ea typeface="Arial" pitchFamily="34" charset="-122"/>
-                <a:cs typeface="Arial" pitchFamily="34" charset="-120"/>
-              </a:rPr>
-              <a:t>Eine Sanierungskündigung hält, wenn der Verbleib der Mietenden die Arbeiten erheblich erschwert (BGE 135 III 112). Geht es bewohnt oder in Etappen, ist sie anfechtbar. Erstreckung bis 4 Jahre.</a:t>
-            </a:r>
-            <a:endParaRPr lang="en-US" sz="1000" dirty="0"/>
-          </a:p>
-        </p:txBody>
-      </p:sp>
-      <p:sp>
-        <p:nvSpPr>
-          <p:cNvPr id="7" name="Shape 5"/>
+              <a:t>Nutzerin. Plant, teilt zu, informiert. Heute vierfacher Aufwand.</a:t>
+            </a:r>
+            <a:endParaRPr lang="en-US" sz="850" dirty="0"/>
+          </a:p>
+        </p:txBody>
+      </p:sp>
+      <p:sp>
+        <p:nvSpPr>
+          <p:cNvPr id="27" name="Shape 25"/>
           <p:cNvSpPr/>
           <p:nvPr/>
         </p:nvSpPr>
         <p:spPr>
           <a:xfrm>
-            <a:off x="3246120" y="1280160"/>
-            <a:ext cx="2651760" cy="2286000"/>
+            <a:off x="7187184" y="1280160"/>
+            <a:ext cx="1536192" cy="1609344"/>
           </a:xfrm>
           <a:prstGeom prst="rect">
             <a:avLst/>
           </a:prstGeom>
           <a:solidFill>
-            <a:srgbClr val="FDEBDD"/>
+            <a:srgbClr val="FFFFFF"/>
           </a:solidFill>
           <a:ln w="9525">
             <a:solidFill>
-              <a:srgbClr val="FDEBDD"/>
+              <a:srgbClr val="E3DDD4"/>
             </a:solidFill>
             <a:prstDash val="solid"/>
           </a:ln>
@@ -6060,53 +6728,78 @@
       </p:sp>
       <p:sp>
         <p:nvSpPr>
-          <p:cNvPr id="8" name="Text 6"/>
-          <p:cNvSpPr txBox="1"/>
-          <p:nvPr/>
-        </p:nvSpPr>
-        <p:spPr>
-          <a:xfrm>
-            <a:off x="3429000" y="1371600"/>
-            <a:ext cx="2286000" cy="274320"/>
-          </a:xfrm>
-          <a:prstGeom prst="rect">
-            <a:avLst/>
-          </a:prstGeom>
-          <a:noFill/>
-          <a:ln/>
-        </p:spPr>
-        <p:txBody>
-          <a:bodyPr wrap="square" lIns="0" tIns="0" rIns="0" bIns="0" rtlCol="0" anchor="ctr"/>
+          <p:cNvPr id="28" name="Shape 26"/>
+          <p:cNvSpPr/>
+          <p:nvPr/>
+        </p:nvSpPr>
+        <p:spPr>
+          <a:xfrm>
+            <a:off x="7187184" y="1280160"/>
+            <a:ext cx="1536192" cy="54864"/>
+          </a:xfrm>
+          <a:prstGeom prst="rect">
+            <a:avLst/>
+          </a:prstGeom>
+          <a:solidFill>
+            <a:srgbClr val="24414A"/>
+          </a:solidFill>
+          <a:ln w="12700">
+            <a:solidFill>
+              <a:srgbClr val="24414A"/>
+            </a:solidFill>
+            <a:prstDash val="solid"/>
+          </a:ln>
+        </p:spPr>
+      </p:sp>
+      <p:sp>
+        <p:nvSpPr>
+          <p:cNvPr id="29" name="Text 27"/>
+          <p:cNvSpPr txBox="1"/>
+          <p:nvPr/>
+        </p:nvSpPr>
+        <p:spPr>
+          <a:xfrm>
+            <a:off x="7315200" y="1426464"/>
+            <a:ext cx="1298448" cy="457200"/>
+          </a:xfrm>
+          <a:prstGeom prst="rect">
+            <a:avLst/>
+          </a:prstGeom>
+          <a:noFill/>
+          <a:ln/>
+        </p:spPr>
+        <p:txBody>
+          <a:bodyPr wrap="square" lIns="0" tIns="0" rIns="0" bIns="0" rtlCol="0" anchor="t"/>
           <a:lstStyle/>
           <a:p>
             <a:pPr indent="0" marL="0">
               <a:buNone/>
             </a:pPr>
             <a:r>
-              <a:rPr lang="en-US" sz="900" b="1" dirty="0">
-                <a:solidFill>
-                  <a:srgbClr val="5B6468"/>
-                </a:solidFill>
-                <a:latin typeface="Arial" pitchFamily="34" charset="0"/>
-                <a:ea typeface="Arial" pitchFamily="34" charset="-122"/>
-                <a:cs typeface="Arial" pitchFamily="34" charset="-120"/>
-              </a:rPr>
-              <a:t>Kanton Zürich · WBFG, Ja 54,3 % am 14.6.2026</a:t>
-            </a:r>
-            <a:endParaRPr lang="en-US" sz="900" dirty="0"/>
-          </a:p>
-        </p:txBody>
-      </p:sp>
-      <p:sp>
-        <p:nvSpPr>
-          <p:cNvPr id="9" name="Text 7"/>
-          <p:cNvSpPr txBox="1"/>
-          <p:nvPr/>
-        </p:nvSpPr>
-        <p:spPr>
-          <a:xfrm>
-            <a:off x="3429000" y="1645920"/>
-            <a:ext cx="2286000" cy="640080"/>
+              <a:rPr lang="en-US" sz="1050" b="1" dirty="0">
+                <a:solidFill>
+                  <a:srgbClr val="1C2326"/>
+                </a:solidFill>
+                <a:latin typeface="Arial" pitchFamily="34" charset="0"/>
+                <a:ea typeface="Arial" pitchFamily="34" charset="-122"/>
+                <a:cs typeface="Arial" pitchFamily="34" charset="-120"/>
+              </a:rPr>
+              <a:t>Mietende</a:t>
+            </a:r>
+            <a:endParaRPr lang="en-US" sz="1050" dirty="0"/>
+          </a:p>
+        </p:txBody>
+      </p:sp>
+      <p:sp>
+        <p:nvSpPr>
+          <p:cNvPr id="30" name="Text 28"/>
+          <p:cNvSpPr txBox="1"/>
+          <p:nvPr/>
+        </p:nvSpPr>
+        <p:spPr>
+          <a:xfrm>
+            <a:off x="7315200" y="1901952"/>
+            <a:ext cx="1298448" cy="731520"/>
           </a:xfrm>
           <a:prstGeom prst="rect">
             <a:avLst/>
@@ -6122,30 +6815,80 @@
               <a:buNone/>
             </a:pPr>
             <a:r>
-              <a:rPr lang="en-US" sz="1600" b="1" dirty="0">
-                <a:solidFill>
-                  <a:srgbClr val="B8460E"/>
-                </a:solidFill>
-                <a:latin typeface="Arial" pitchFamily="34" charset="0"/>
-                <a:ea typeface="Arial" pitchFamily="34" charset="-122"/>
-                <a:cs typeface="Arial" pitchFamily="34" charset="-120"/>
-              </a:rPr>
-              <a:t>Prüfpflicht ab 20 Mietverhältnissen</a:t>
-            </a:r>
-            <a:endParaRPr lang="en-US" sz="1600" dirty="0"/>
-          </a:p>
-        </p:txBody>
-      </p:sp>
-      <p:sp>
-        <p:nvSpPr>
-          <p:cNvPr id="10" name="Text 8"/>
-          <p:cNvSpPr txBox="1"/>
-          <p:nvPr/>
-        </p:nvSpPr>
-        <p:spPr>
-          <a:xfrm>
-            <a:off x="3429000" y="2304288"/>
-            <a:ext cx="2286000" cy="1188720"/>
+              <a:rPr lang="en-US" sz="850" dirty="0">
+                <a:solidFill>
+                  <a:srgbClr val="1C2326"/>
+                </a:solidFill>
+                <a:latin typeface="Arial" pitchFamily="34" charset="0"/>
+                <a:ea typeface="Arial" pitchFamily="34" charset="-122"/>
+                <a:cs typeface="Arial" pitchFamily="34" charset="-120"/>
+              </a:rPr>
+              <a:t>App. Stimmen freiwillig zu, sehen Auszug, Wohnung, Rückkehr.</a:t>
+            </a:r>
+            <a:endParaRPr lang="en-US" sz="850" dirty="0"/>
+          </a:p>
+        </p:txBody>
+      </p:sp>
+      <p:sp>
+        <p:nvSpPr>
+          <p:cNvPr id="31" name="Shape 29"/>
+          <p:cNvSpPr/>
+          <p:nvPr/>
+        </p:nvSpPr>
+        <p:spPr>
+          <a:xfrm>
+            <a:off x="3931920" y="2980944"/>
+            <a:ext cx="1536192" cy="1609344"/>
+          </a:xfrm>
+          <a:prstGeom prst="rect">
+            <a:avLst/>
+          </a:prstGeom>
+          <a:solidFill>
+            <a:srgbClr val="FFFFFF"/>
+          </a:solidFill>
+          <a:ln w="9525">
+            <a:solidFill>
+              <a:srgbClr val="E3DDD4"/>
+            </a:solidFill>
+            <a:prstDash val="solid"/>
+          </a:ln>
+        </p:spPr>
+      </p:sp>
+      <p:sp>
+        <p:nvSpPr>
+          <p:cNvPr id="32" name="Shape 30"/>
+          <p:cNvSpPr/>
+          <p:nvPr/>
+        </p:nvSpPr>
+        <p:spPr>
+          <a:xfrm>
+            <a:off x="3931920" y="2980944"/>
+            <a:ext cx="1536192" cy="54864"/>
+          </a:xfrm>
+          <a:prstGeom prst="rect">
+            <a:avLst/>
+          </a:prstGeom>
+          <a:solidFill>
+            <a:srgbClr val="24414A"/>
+          </a:solidFill>
+          <a:ln w="12700">
+            <a:solidFill>
+              <a:srgbClr val="24414A"/>
+            </a:solidFill>
+            <a:prstDash val="solid"/>
+          </a:ln>
+        </p:spPr>
+      </p:sp>
+      <p:sp>
+        <p:nvSpPr>
+          <p:cNvPr id="33" name="Text 31"/>
+          <p:cNvSpPr txBox="1"/>
+          <p:nvPr/>
+        </p:nvSpPr>
+        <p:spPr>
+          <a:xfrm>
+            <a:off x="4059936" y="3127248"/>
+            <a:ext cx="1298448" cy="457200"/>
           </a:xfrm>
           <a:prstGeom prst="rect">
             <a:avLst/>
@@ -6161,7 +6904,7 @@
               <a:buNone/>
             </a:pPr>
             <a:r>
-              <a:rPr lang="en-US" sz="1000" dirty="0">
+              <a:rPr lang="en-US" sz="1050" b="1" dirty="0">
                 <a:solidFill>
                   <a:srgbClr val="1C2326"/>
                 </a:solidFill>
@@ -6169,22 +6912,61 @@
                 <a:ea typeface="Arial" pitchFamily="34" charset="-122"/>
                 <a:cs typeface="Arial" pitchFamily="34" charset="-120"/>
               </a:rPr>
-              <a:t>Bewohnt oder etappiert sanieren prüfen, 12 Monate Vorlauf, Ansprechperson, Hilfe bei der Wohnungssuche. Sonst keine Baubewilligung. In Kraft frühestens Ende 2026.</a:t>
-            </a:r>
-            <a:endParaRPr lang="en-US" sz="1000" dirty="0"/>
-          </a:p>
-        </p:txBody>
-      </p:sp>
-      <p:sp>
-        <p:nvSpPr>
-          <p:cNvPr id="11" name="Shape 9"/>
+              <a:t>Bauleitung</a:t>
+            </a:r>
+            <a:endParaRPr lang="en-US" sz="1050" dirty="0"/>
+          </a:p>
+        </p:txBody>
+      </p:sp>
+      <p:sp>
+        <p:nvSpPr>
+          <p:cNvPr id="34" name="Text 32"/>
+          <p:cNvSpPr txBox="1"/>
+          <p:nvPr/>
+        </p:nvSpPr>
+        <p:spPr>
+          <a:xfrm>
+            <a:off x="4059936" y="3602736"/>
+            <a:ext cx="1298448" cy="731520"/>
+          </a:xfrm>
+          <a:prstGeom prst="rect">
+            <a:avLst/>
+          </a:prstGeom>
+          <a:noFill/>
+          <a:ln/>
+        </p:spPr>
+        <p:txBody>
+          <a:bodyPr wrap="square" lIns="0" tIns="0" rIns="0" bIns="0" rtlCol="0" anchor="t"/>
+          <a:lstStyle/>
+          <a:p>
+            <a:pPr indent="0" marL="0">
+              <a:buNone/>
+            </a:pPr>
+            <a:r>
+              <a:rPr lang="en-US" sz="850" dirty="0">
+                <a:solidFill>
+                  <a:srgbClr val="1C2326"/>
+                </a:solidFill>
+                <a:latin typeface="Arial" pitchFamily="34" charset="0"/>
+                <a:ea typeface="Arial" pitchFamily="34" charset="-122"/>
+                <a:cs typeface="Arial" pitchFamily="34" charset="-120"/>
+              </a:rPr>
+              <a:t>Liefert Etappen und Termine, bekommt leere Wohnungen.</a:t>
+            </a:r>
+            <a:endParaRPr lang="en-US" sz="850" dirty="0"/>
+          </a:p>
+        </p:txBody>
+      </p:sp>
+      <p:sp>
+        <p:nvSpPr>
+          <p:cNvPr id="35" name="Shape 33"/>
           <p:cNvSpPr/>
           <p:nvPr/>
         </p:nvSpPr>
         <p:spPr>
           <a:xfrm>
-            <a:off x="6035040" y="1280160"/>
-            <a:ext cx="2651760" cy="2286000"/>
+            <a:off x="5559552" y="2980944"/>
+            <a:ext cx="1536192" cy="1609344"/>
           </a:xfrm>
           <a:prstGeom prst="rect">
             <a:avLst/>
@@ -6202,14 +6984,142 @@
       </p:sp>
       <p:sp>
         <p:nvSpPr>
-          <p:cNvPr id="12" name="Text 10"/>
-          <p:cNvSpPr txBox="1"/>
-          <p:nvPr/>
-        </p:nvSpPr>
-        <p:spPr>
-          <a:xfrm>
-            <a:off x="6217920" y="1371600"/>
-            <a:ext cx="2286000" cy="274320"/>
+          <p:cNvPr id="36" name="Shape 34"/>
+          <p:cNvSpPr/>
+          <p:nvPr/>
+        </p:nvSpPr>
+        <p:spPr>
+          <a:xfrm>
+            <a:off x="5559552" y="2980944"/>
+            <a:ext cx="1536192" cy="54864"/>
+          </a:xfrm>
+          <a:prstGeom prst="rect">
+            <a:avLst/>
+          </a:prstGeom>
+          <a:solidFill>
+            <a:srgbClr val="24414A"/>
+          </a:solidFill>
+          <a:ln w="12700">
+            <a:solidFill>
+              <a:srgbClr val="24414A"/>
+            </a:solidFill>
+            <a:prstDash val="solid"/>
+          </a:ln>
+        </p:spPr>
+      </p:sp>
+      <p:sp>
+        <p:nvSpPr>
+          <p:cNvPr id="37" name="Text 35"/>
+          <p:cNvSpPr txBox="1"/>
+          <p:nvPr/>
+        </p:nvSpPr>
+        <p:spPr>
+          <a:xfrm>
+            <a:off x="5687568" y="3127248"/>
+            <a:ext cx="1298448" cy="457200"/>
+          </a:xfrm>
+          <a:prstGeom prst="rect">
+            <a:avLst/>
+          </a:prstGeom>
+          <a:noFill/>
+          <a:ln/>
+        </p:spPr>
+        <p:txBody>
+          <a:bodyPr wrap="square" lIns="0" tIns="0" rIns="0" bIns="0" rtlCol="0" anchor="t"/>
+          <a:lstStyle/>
+          <a:p>
+            <a:pPr indent="0" marL="0">
+              <a:buNone/>
+            </a:pPr>
+            <a:r>
+              <a:rPr lang="en-US" sz="1050" b="1" dirty="0">
+                <a:solidFill>
+                  <a:srgbClr val="1C2326"/>
+                </a:solidFill>
+                <a:latin typeface="Arial" pitchFamily="34" charset="0"/>
+                <a:ea typeface="Arial" pitchFamily="34" charset="-122"/>
+                <a:cs typeface="Arial" pitchFamily="34" charset="-120"/>
+              </a:rPr>
+              <a:t>Gemeinde</a:t>
+            </a:r>
+            <a:endParaRPr lang="en-US" sz="1050" dirty="0"/>
+          </a:p>
+        </p:txBody>
+      </p:sp>
+      <p:sp>
+        <p:nvSpPr>
+          <p:cNvPr id="38" name="Text 36"/>
+          <p:cNvSpPr txBox="1"/>
+          <p:nvPr/>
+        </p:nvSpPr>
+        <p:spPr>
+          <a:xfrm>
+            <a:off x="5687568" y="3602736"/>
+            <a:ext cx="1298448" cy="731520"/>
+          </a:xfrm>
+          <a:prstGeom prst="rect">
+            <a:avLst/>
+          </a:prstGeom>
+          <a:noFill/>
+          <a:ln/>
+        </p:spPr>
+        <p:txBody>
+          <a:bodyPr wrap="square" lIns="0" tIns="0" rIns="0" bIns="0" rtlCol="0" anchor="t"/>
+          <a:lstStyle/>
+          <a:p>
+            <a:pPr indent="0" marL="0">
+              <a:buNone/>
+            </a:pPr>
+            <a:r>
+              <a:rPr lang="en-US" sz="850" dirty="0">
+                <a:solidFill>
+                  <a:srgbClr val="1C2326"/>
+                </a:solidFill>
+                <a:latin typeface="Arial" pitchFamily="34" charset="0"/>
+                <a:ea typeface="Arial" pitchFamily="34" charset="-122"/>
+                <a:cs typeface="Arial" pitchFamily="34" charset="-120"/>
+              </a:rPr>
+              <a:t>Baubewilligung. Zürich prüft neu den Nachweis, wir liefern ihn.</a:t>
+            </a:r>
+            <a:endParaRPr lang="en-US" sz="850" dirty="0"/>
+          </a:p>
+        </p:txBody>
+      </p:sp>
+      <p:sp>
+        <p:nvSpPr>
+          <p:cNvPr id="39" name="Shape 37"/>
+          <p:cNvSpPr/>
+          <p:nvPr/>
+        </p:nvSpPr>
+        <p:spPr>
+          <a:xfrm>
+            <a:off x="5687568" y="4297680"/>
+            <a:ext cx="685800" cy="201168"/>
+          </a:xfrm>
+          <a:prstGeom prst="rect">
+            <a:avLst/>
+          </a:prstGeom>
+          <a:solidFill>
+            <a:srgbClr val="24414A"/>
+          </a:solidFill>
+          <a:ln w="12700">
+            <a:solidFill>
+              <a:srgbClr val="24414A"/>
+            </a:solidFill>
+            <a:prstDash val="solid"/>
+          </a:ln>
+        </p:spPr>
+      </p:sp>
+      <p:sp>
+        <p:nvSpPr>
+          <p:cNvPr id="40" name="Text 38"/>
+          <p:cNvSpPr txBox="1"/>
+          <p:nvPr/>
+        </p:nvSpPr>
+        <p:spPr>
+          <a:xfrm>
+            <a:off x="5687568" y="4297680"/>
+            <a:ext cx="685800" cy="201168"/>
           </a:xfrm>
           <a:prstGeom prst="rect">
             <a:avLst/>
@@ -6221,112 +7131,34 @@
           <a:bodyPr wrap="square" lIns="0" tIns="0" rIns="0" bIns="0" rtlCol="0" anchor="ctr"/>
           <a:lstStyle/>
           <a:p>
-            <a:pPr indent="0" marL="0">
-              <a:buNone/>
-            </a:pPr>
-            <a:r>
-              <a:rPr lang="en-US" sz="900" b="1" dirty="0">
-                <a:solidFill>
-                  <a:srgbClr val="5B6468"/>
-                </a:solidFill>
-                <a:latin typeface="Arial" pitchFamily="34" charset="0"/>
-                <a:ea typeface="Arial" pitchFamily="34" charset="-122"/>
-                <a:cs typeface="Arial" pitchFamily="34" charset="-120"/>
-              </a:rPr>
-              <a:t>Genossenschaften · OR 846</a:t>
-            </a:r>
-            <a:endParaRPr lang="en-US" sz="900" dirty="0"/>
-          </a:p>
-        </p:txBody>
-      </p:sp>
-      <p:sp>
-        <p:nvSpPr>
-          <p:cNvPr id="13" name="Text 11"/>
-          <p:cNvSpPr txBox="1"/>
-          <p:nvPr/>
-        </p:nvSpPr>
-        <p:spPr>
-          <a:xfrm>
-            <a:off x="6217920" y="1645920"/>
-            <a:ext cx="2286000" cy="640080"/>
-          </a:xfrm>
-          <a:prstGeom prst="rect">
-            <a:avLst/>
-          </a:prstGeom>
-          <a:noFill/>
-          <a:ln/>
-        </p:spPr>
-        <p:txBody>
-          <a:bodyPr wrap="square" lIns="0" tIns="0" rIns="0" bIns="0" rtlCol="0" anchor="t"/>
-          <a:lstStyle/>
-          <a:p>
-            <a:pPr indent="0" marL="0">
-              <a:buNone/>
-            </a:pPr>
-            <a:r>
-              <a:rPr lang="en-US" sz="1600" b="1" dirty="0">
-                <a:solidFill>
-                  <a:srgbClr val="24414A"/>
-                </a:solidFill>
-                <a:latin typeface="Arial" pitchFamily="34" charset="0"/>
-                <a:ea typeface="Arial" pitchFamily="34" charset="-122"/>
-                <a:cs typeface="Arial" pitchFamily="34" charset="-120"/>
-              </a:rPr>
-              <a:t>Sanierung ist kein Kündigungsgrund</a:t>
-            </a:r>
-            <a:endParaRPr lang="en-US" sz="1600" dirty="0"/>
-          </a:p>
-        </p:txBody>
-      </p:sp>
-      <p:sp>
-        <p:nvSpPr>
-          <p:cNvPr id="14" name="Text 12"/>
-          <p:cNvSpPr txBox="1"/>
-          <p:nvPr/>
-        </p:nvSpPr>
-        <p:spPr>
-          <a:xfrm>
-            <a:off x="6217920" y="2304288"/>
-            <a:ext cx="2286000" cy="1188720"/>
-          </a:xfrm>
-          <a:prstGeom prst="rect">
-            <a:avLst/>
-          </a:prstGeom>
-          <a:noFill/>
-          <a:ln/>
-        </p:spPr>
-        <p:txBody>
-          <a:bodyPr wrap="square" lIns="0" tIns="0" rIns="0" bIns="0" rtlCol="0" anchor="t"/>
-          <a:lstStyle/>
-          <a:p>
-            <a:pPr indent="0" marL="0">
-              <a:buNone/>
-            </a:pPr>
-            <a:r>
-              <a:rPr lang="en-US" sz="1000" dirty="0">
-                <a:solidFill>
-                  <a:srgbClr val="1C2326"/>
-                </a:solidFill>
-                <a:latin typeface="Arial" pitchFamily="34" charset="0"/>
-                <a:ea typeface="Arial" pitchFamily="34" charset="-122"/>
-                <a:cs typeface="Arial" pitchFamily="34" charset="-120"/>
-              </a:rPr>
-              <a:t>Mitglieder sind Mitbesitzer. Ohne Statutengrundlage kann die Genossenschaft wegen einer Sanierung nicht kündigen. Darum: Rochade oder befristete Zwischenvermietung.</a:t>
-            </a:r>
-            <a:endParaRPr lang="en-US" sz="1000" dirty="0"/>
-          </a:p>
-        </p:txBody>
-      </p:sp>
-      <p:sp>
-        <p:nvSpPr>
-          <p:cNvPr id="15" name="Shape 13"/>
+            <a:pPr algn="ctr" indent="0" marL="0">
+              <a:buNone/>
+            </a:pPr>
+            <a:r>
+              <a:rPr lang="en-US" sz="750" b="1" dirty="0">
+                <a:solidFill>
+                  <a:srgbClr val="FFFFFF"/>
+                </a:solidFill>
+                <a:latin typeface="Arial" pitchFamily="34" charset="0"/>
+                <a:ea typeface="Arial" pitchFamily="34" charset="-122"/>
+                <a:cs typeface="Arial" pitchFamily="34" charset="-120"/>
+              </a:rPr>
+              <a:t>Nachweis</a:t>
+            </a:r>
+            <a:endParaRPr lang="en-US" sz="750" dirty="0"/>
+          </a:p>
+        </p:txBody>
+      </p:sp>
+      <p:sp>
+        <p:nvSpPr>
+          <p:cNvPr id="41" name="Shape 39"/>
           <p:cNvSpPr/>
           <p:nvPr/>
         </p:nvSpPr>
         <p:spPr>
           <a:xfrm>
-            <a:off x="457200" y="3703320"/>
-            <a:ext cx="1988820" cy="914400"/>
+            <a:off x="7187184" y="2980944"/>
+            <a:ext cx="1536192" cy="1609344"/>
           </a:xfrm>
           <a:prstGeom prst="rect">
             <a:avLst/>
@@ -6344,24 +7176,24 @@
       </p:sp>
       <p:sp>
         <p:nvSpPr>
-          <p:cNvPr id="16" name="Shape 14"/>
+          <p:cNvPr id="42" name="Shape 40"/>
           <p:cNvSpPr/>
           <p:nvPr/>
         </p:nvSpPr>
         <p:spPr>
           <a:xfrm>
-            <a:off x="594360" y="3831336"/>
-            <a:ext cx="128016" cy="128016"/>
+            <a:off x="7187184" y="2980944"/>
+            <a:ext cx="1536192" cy="54864"/>
           </a:xfrm>
           <a:prstGeom prst="rect">
             <a:avLst/>
           </a:prstGeom>
           <a:solidFill>
-            <a:srgbClr val="276B43"/>
+            <a:srgbClr val="24414A"/>
           </a:solidFill>
           <a:ln w="12700">
             <a:solidFill>
-              <a:srgbClr val="276B43"/>
+              <a:srgbClr val="24414A"/>
             </a:solidFill>
             <a:prstDash val="solid"/>
           </a:ln>
@@ -6369,14 +7201,92 @@
       </p:sp>
       <p:sp>
         <p:nvSpPr>
-          <p:cNvPr id="17" name="Text 15"/>
-          <p:cNvSpPr txBox="1"/>
-          <p:nvPr/>
-        </p:nvSpPr>
-        <p:spPr>
-          <a:xfrm>
-            <a:off x="786384" y="3767328"/>
-            <a:ext cx="1554480" cy="256032"/>
+          <p:cNvPr id="43" name="Text 41"/>
+          <p:cNvSpPr txBox="1"/>
+          <p:nvPr/>
+        </p:nvSpPr>
+        <p:spPr>
+          <a:xfrm>
+            <a:off x="7315200" y="3127248"/>
+            <a:ext cx="1298448" cy="457200"/>
+          </a:xfrm>
+          <a:prstGeom prst="rect">
+            <a:avLst/>
+          </a:prstGeom>
+          <a:noFill/>
+          <a:ln/>
+        </p:spPr>
+        <p:txBody>
+          <a:bodyPr wrap="square" lIns="0" tIns="0" rIns="0" bIns="0" rtlCol="0" anchor="t"/>
+          <a:lstStyle/>
+          <a:p>
+            <a:pPr indent="0" marL="0">
+              <a:buNone/>
+            </a:pPr>
+            <a:r>
+              <a:rPr lang="en-US" sz="1050" b="1" dirty="0">
+                <a:solidFill>
+                  <a:srgbClr val="1C2326"/>
+                </a:solidFill>
+                <a:latin typeface="Arial" pitchFamily="34" charset="0"/>
+                <a:ea typeface="Arial" pitchFamily="34" charset="-122"/>
+                <a:cs typeface="Arial" pitchFamily="34" charset="-120"/>
+              </a:rPr>
+              <a:t>Mieterverband</a:t>
+            </a:r>
+            <a:endParaRPr lang="en-US" sz="1050" dirty="0"/>
+          </a:p>
+        </p:txBody>
+      </p:sp>
+      <p:sp>
+        <p:nvSpPr>
+          <p:cNvPr id="44" name="Text 42"/>
+          <p:cNvSpPr txBox="1"/>
+          <p:nvPr/>
+        </p:nvSpPr>
+        <p:spPr>
+          <a:xfrm>
+            <a:off x="7315200" y="3602736"/>
+            <a:ext cx="1298448" cy="731520"/>
+          </a:xfrm>
+          <a:prstGeom prst="rect">
+            <a:avLst/>
+          </a:prstGeom>
+          <a:noFill/>
+          <a:ln/>
+        </p:spPr>
+        <p:txBody>
+          <a:bodyPr wrap="square" lIns="0" tIns="0" rIns="0" bIns="0" rtlCol="0" anchor="t"/>
+          <a:lstStyle/>
+          <a:p>
+            <a:pPr indent="0" marL="0">
+              <a:buNone/>
+            </a:pPr>
+            <a:r>
+              <a:rPr lang="en-US" sz="850" dirty="0">
+                <a:solidFill>
+                  <a:srgbClr val="1C2326"/>
+                </a:solidFill>
+                <a:latin typeface="Arial" pitchFamily="34" charset="0"/>
+                <a:ea typeface="Arial" pitchFamily="34" charset="-122"/>
+                <a:cs typeface="Arial" pitchFamily="34" charset="-120"/>
+              </a:rPr>
+              <a:t>Berät die Mietenden. Für uns Verbündeter, nicht Gegner.</a:t>
+            </a:r>
+            <a:endParaRPr lang="en-US" sz="850" dirty="0"/>
+          </a:p>
+        </p:txBody>
+      </p:sp>
+      <p:sp>
+        <p:nvSpPr>
+          <p:cNvPr id="45" name="Text 43"/>
+          <p:cNvSpPr txBox="1"/>
+          <p:nvPr/>
+        </p:nvSpPr>
+        <p:spPr>
+          <a:xfrm>
+            <a:off x="457200" y="4626864"/>
+            <a:ext cx="8229600" cy="182880"/>
           </a:xfrm>
           <a:prstGeom prst="rect">
             <a:avLst/>
@@ -6392,440 +7302,17 @@
               <a:buNone/>
             </a:pPr>
             <a:r>
-              <a:rPr lang="en-US" sz="1100" b="1" dirty="0">
-                <a:solidFill>
-                  <a:srgbClr val="1C2326"/>
-                </a:solidFill>
-                <a:latin typeface="Arial" pitchFamily="34" charset="0"/>
-                <a:ea typeface="Arial" pitchFamily="34" charset="-122"/>
-                <a:cs typeface="Arial" pitchFamily="34" charset="-120"/>
-              </a:rPr>
-              <a:t>Zürich</a:t>
-            </a:r>
-            <a:endParaRPr lang="en-US" sz="1100" dirty="0"/>
-          </a:p>
-        </p:txBody>
-      </p:sp>
-      <p:sp>
-        <p:nvSpPr>
-          <p:cNvPr id="18" name="Text 16"/>
-          <p:cNvSpPr txBox="1"/>
-          <p:nvPr/>
-        </p:nvSpPr>
-        <p:spPr>
-          <a:xfrm>
-            <a:off x="594360" y="4041648"/>
-            <a:ext cx="1737360" cy="530352"/>
-          </a:xfrm>
-          <a:prstGeom prst="rect">
-            <a:avLst/>
-          </a:prstGeom>
-          <a:noFill/>
-          <a:ln/>
-        </p:spPr>
-        <p:txBody>
-          <a:bodyPr wrap="square" lIns="0" tIns="0" rIns="0" bIns="0" rtlCol="0" anchor="t"/>
-          <a:lstStyle/>
-          <a:p>
-            <a:pPr indent="0" marL="0">
-              <a:buNone/>
-            </a:pPr>
-            <a:r>
-              <a:rPr lang="en-US" sz="850" dirty="0">
-                <a:solidFill>
-                  <a:srgbClr val="1C2326"/>
-                </a:solidFill>
-                <a:latin typeface="Arial" pitchFamily="34" charset="0"/>
-                <a:ea typeface="Arial" pitchFamily="34" charset="-122"/>
-                <a:cs typeface="Arial" pitchFamily="34" charset="-120"/>
-              </a:rPr>
-              <a:t>Prüfpflicht neu. Der Nachweis, den ROCHADE liefert.</a:t>
-            </a:r>
-            <a:endParaRPr lang="en-US" sz="850" dirty="0"/>
-          </a:p>
-        </p:txBody>
-      </p:sp>
-      <p:sp>
-        <p:nvSpPr>
-          <p:cNvPr id="19" name="Shape 17"/>
-          <p:cNvSpPr/>
-          <p:nvPr/>
-        </p:nvSpPr>
-        <p:spPr>
-          <a:xfrm>
-            <a:off x="2537460" y="3703320"/>
-            <a:ext cx="1988820" cy="914400"/>
-          </a:xfrm>
-          <a:prstGeom prst="rect">
-            <a:avLst/>
-          </a:prstGeom>
-          <a:solidFill>
-            <a:srgbClr val="FFFFFF"/>
-          </a:solidFill>
-          <a:ln w="9525">
-            <a:solidFill>
-              <a:srgbClr val="E3DDD4"/>
-            </a:solidFill>
-            <a:prstDash val="solid"/>
-          </a:ln>
-        </p:spPr>
-      </p:sp>
-      <p:sp>
-        <p:nvSpPr>
-          <p:cNvPr id="20" name="Shape 18"/>
-          <p:cNvSpPr/>
-          <p:nvPr/>
-        </p:nvSpPr>
-        <p:spPr>
-          <a:xfrm>
-            <a:off x="2674620" y="3831336"/>
-            <a:ext cx="128016" cy="128016"/>
-          </a:xfrm>
-          <a:prstGeom prst="rect">
-            <a:avLst/>
-          </a:prstGeom>
-          <a:solidFill>
-            <a:srgbClr val="F26A1B"/>
-          </a:solidFill>
-          <a:ln w="12700">
-            <a:solidFill>
-              <a:srgbClr val="F26A1B"/>
-            </a:solidFill>
-            <a:prstDash val="solid"/>
-          </a:ln>
-        </p:spPr>
-      </p:sp>
-      <p:sp>
-        <p:nvSpPr>
-          <p:cNvPr id="21" name="Text 19"/>
-          <p:cNvSpPr txBox="1"/>
-          <p:nvPr/>
-        </p:nvSpPr>
-        <p:spPr>
-          <a:xfrm>
-            <a:off x="2866644" y="3767328"/>
-            <a:ext cx="1554480" cy="256032"/>
-          </a:xfrm>
-          <a:prstGeom prst="rect">
-            <a:avLst/>
-          </a:prstGeom>
-          <a:noFill/>
-          <a:ln/>
-        </p:spPr>
-        <p:txBody>
-          <a:bodyPr wrap="square" lIns="0" tIns="0" rIns="0" bIns="0" rtlCol="0" anchor="ctr"/>
-          <a:lstStyle/>
-          <a:p>
-            <a:pPr indent="0" marL="0">
-              <a:buNone/>
-            </a:pPr>
-            <a:r>
-              <a:rPr lang="en-US" sz="1100" b="1" dirty="0">
-                <a:solidFill>
-                  <a:srgbClr val="1C2326"/>
-                </a:solidFill>
-                <a:latin typeface="Arial" pitchFamily="34" charset="0"/>
-                <a:ea typeface="Arial" pitchFamily="34" charset="-122"/>
-                <a:cs typeface="Arial" pitchFamily="34" charset="-120"/>
-              </a:rPr>
-              <a:t>Luzern</a:t>
-            </a:r>
-            <a:endParaRPr lang="en-US" sz="1100" dirty="0"/>
-          </a:p>
-        </p:txBody>
-      </p:sp>
-      <p:sp>
-        <p:nvSpPr>
-          <p:cNvPr id="22" name="Text 20"/>
-          <p:cNvSpPr txBox="1"/>
-          <p:nvPr/>
-        </p:nvSpPr>
-        <p:spPr>
-          <a:xfrm>
-            <a:off x="2674620" y="4041648"/>
-            <a:ext cx="1737360" cy="530352"/>
-          </a:xfrm>
-          <a:prstGeom prst="rect">
-            <a:avLst/>
-          </a:prstGeom>
-          <a:noFill/>
-          <a:ln/>
-        </p:spPr>
-        <p:txBody>
-          <a:bodyPr wrap="square" lIns="0" tIns="0" rIns="0" bIns="0" rtlCol="0" anchor="t"/>
-          <a:lstStyle/>
-          <a:p>
-            <a:pPr indent="0" marL="0">
-              <a:buNone/>
-            </a:pPr>
-            <a:r>
-              <a:rPr lang="en-US" sz="850" dirty="0">
-                <a:solidFill>
-                  <a:srgbClr val="1C2326"/>
-                </a:solidFill>
-                <a:latin typeface="Arial" pitchFamily="34" charset="0"/>
-                <a:ea typeface="Arial" pitchFamily="34" charset="-122"/>
-                <a:cs typeface="Arial" pitchFamily="34" charset="-120"/>
-              </a:rPr>
-              <a:t>Wohnraum-Gesetz umkämpft: Stadt Nein 24:23, Initiative läuft.</a:t>
-            </a:r>
-            <a:endParaRPr lang="en-US" sz="850" dirty="0"/>
-          </a:p>
-        </p:txBody>
-      </p:sp>
-      <p:sp>
-        <p:nvSpPr>
-          <p:cNvPr id="23" name="Shape 21"/>
-          <p:cNvSpPr/>
-          <p:nvPr/>
-        </p:nvSpPr>
-        <p:spPr>
-          <a:xfrm>
-            <a:off x="4617720" y="3703320"/>
-            <a:ext cx="1988820" cy="914400"/>
-          </a:xfrm>
-          <a:prstGeom prst="rect">
-            <a:avLst/>
-          </a:prstGeom>
-          <a:solidFill>
-            <a:srgbClr val="FFFFFF"/>
-          </a:solidFill>
-          <a:ln w="9525">
-            <a:solidFill>
-              <a:srgbClr val="E3DDD4"/>
-            </a:solidFill>
-            <a:prstDash val="solid"/>
-          </a:ln>
-        </p:spPr>
-      </p:sp>
-      <p:sp>
-        <p:nvSpPr>
-          <p:cNvPr id="24" name="Shape 22"/>
-          <p:cNvSpPr/>
-          <p:nvPr/>
-        </p:nvSpPr>
-        <p:spPr>
-          <a:xfrm>
-            <a:off x="4754880" y="3831336"/>
-            <a:ext cx="128016" cy="128016"/>
-          </a:xfrm>
-          <a:prstGeom prst="rect">
-            <a:avLst/>
-          </a:prstGeom>
-          <a:solidFill>
-            <a:srgbClr val="F26A1B"/>
-          </a:solidFill>
-          <a:ln w="12700">
-            <a:solidFill>
-              <a:srgbClr val="F26A1B"/>
-            </a:solidFill>
-            <a:prstDash val="solid"/>
-          </a:ln>
-        </p:spPr>
-      </p:sp>
-      <p:sp>
-        <p:nvSpPr>
-          <p:cNvPr id="25" name="Text 23"/>
-          <p:cNvSpPr txBox="1"/>
-          <p:nvPr/>
-        </p:nvSpPr>
-        <p:spPr>
-          <a:xfrm>
-            <a:off x="4946904" y="3767328"/>
-            <a:ext cx="1554480" cy="256032"/>
-          </a:xfrm>
-          <a:prstGeom prst="rect">
-            <a:avLst/>
-          </a:prstGeom>
-          <a:noFill/>
-          <a:ln/>
-        </p:spPr>
-        <p:txBody>
-          <a:bodyPr wrap="square" lIns="0" tIns="0" rIns="0" bIns="0" rtlCol="0" anchor="ctr"/>
-          <a:lstStyle/>
-          <a:p>
-            <a:pPr indent="0" marL="0">
-              <a:buNone/>
-            </a:pPr>
-            <a:r>
-              <a:rPr lang="en-US" sz="1100" b="1" dirty="0">
-                <a:solidFill>
-                  <a:srgbClr val="1C2326"/>
-                </a:solidFill>
-                <a:latin typeface="Arial" pitchFamily="34" charset="0"/>
-                <a:ea typeface="Arial" pitchFamily="34" charset="-122"/>
-                <a:cs typeface="Arial" pitchFamily="34" charset="-120"/>
-              </a:rPr>
-              <a:t>Zug</a:t>
-            </a:r>
-            <a:endParaRPr lang="en-US" sz="1100" dirty="0"/>
-          </a:p>
-        </p:txBody>
-      </p:sp>
-      <p:sp>
-        <p:nvSpPr>
-          <p:cNvPr id="26" name="Text 24"/>
-          <p:cNvSpPr txBox="1"/>
-          <p:nvPr/>
-        </p:nvSpPr>
-        <p:spPr>
-          <a:xfrm>
-            <a:off x="4754880" y="4041648"/>
-            <a:ext cx="1737360" cy="530352"/>
-          </a:xfrm>
-          <a:prstGeom prst="rect">
-            <a:avLst/>
-          </a:prstGeom>
-          <a:noFill/>
-          <a:ln/>
-        </p:spPr>
-        <p:txBody>
-          <a:bodyPr wrap="square" lIns="0" tIns="0" rIns="0" bIns="0" rtlCol="0" anchor="t"/>
-          <a:lstStyle/>
-          <a:p>
-            <a:pPr indent="0" marL="0">
-              <a:buNone/>
-            </a:pPr>
-            <a:r>
-              <a:rPr lang="en-US" sz="850" dirty="0">
-                <a:solidFill>
-                  <a:srgbClr val="1C2326"/>
-                </a:solidFill>
-                <a:latin typeface="Arial" pitchFamily="34" charset="0"/>
-                <a:ea typeface="Arial" pitchFamily="34" charset="-122"/>
-                <a:cs typeface="Arial" pitchFamily="34" charset="-120"/>
-              </a:rPr>
-              <a:t>Kein Gesetz. Herti: Veto, 68 Wohnungen werden bewohnt saniert.</a:t>
-            </a:r>
-            <a:endParaRPr lang="en-US" sz="850" dirty="0"/>
-          </a:p>
-        </p:txBody>
-      </p:sp>
-      <p:sp>
-        <p:nvSpPr>
-          <p:cNvPr id="27" name="Shape 25"/>
-          <p:cNvSpPr/>
-          <p:nvPr/>
-        </p:nvSpPr>
-        <p:spPr>
-          <a:xfrm>
-            <a:off x="6697980" y="3703320"/>
-            <a:ext cx="1988820" cy="914400"/>
-          </a:xfrm>
-          <a:prstGeom prst="rect">
-            <a:avLst/>
-          </a:prstGeom>
-          <a:solidFill>
-            <a:srgbClr val="FFFFFF"/>
-          </a:solidFill>
-          <a:ln w="9525">
-            <a:solidFill>
-              <a:srgbClr val="E3DDD4"/>
-            </a:solidFill>
-            <a:prstDash val="solid"/>
-          </a:ln>
-        </p:spPr>
-      </p:sp>
-      <p:sp>
-        <p:nvSpPr>
-          <p:cNvPr id="28" name="Shape 26"/>
-          <p:cNvSpPr/>
-          <p:nvPr/>
-        </p:nvSpPr>
-        <p:spPr>
-          <a:xfrm>
-            <a:off x="6835140" y="3831336"/>
-            <a:ext cx="128016" cy="128016"/>
-          </a:xfrm>
-          <a:prstGeom prst="rect">
-            <a:avLst/>
-          </a:prstGeom>
-          <a:solidFill>
-            <a:srgbClr val="8A8178"/>
-          </a:solidFill>
-          <a:ln w="12700">
-            <a:solidFill>
-              <a:srgbClr val="8A8178"/>
-            </a:solidFill>
-            <a:prstDash val="solid"/>
-          </a:ln>
-        </p:spPr>
-      </p:sp>
-      <p:sp>
-        <p:nvSpPr>
-          <p:cNvPr id="29" name="Text 27"/>
-          <p:cNvSpPr txBox="1"/>
-          <p:nvPr/>
-        </p:nvSpPr>
-        <p:spPr>
-          <a:xfrm>
-            <a:off x="7027164" y="3767328"/>
-            <a:ext cx="1554480" cy="256032"/>
-          </a:xfrm>
-          <a:prstGeom prst="rect">
-            <a:avLst/>
-          </a:prstGeom>
-          <a:noFill/>
-          <a:ln/>
-        </p:spPr>
-        <p:txBody>
-          <a:bodyPr wrap="square" lIns="0" tIns="0" rIns="0" bIns="0" rtlCol="0" anchor="ctr"/>
-          <a:lstStyle/>
-          <a:p>
-            <a:pPr indent="0" marL="0">
-              <a:buNone/>
-            </a:pPr>
-            <a:r>
-              <a:rPr lang="en-US" sz="1100" b="1" dirty="0">
-                <a:solidFill>
-                  <a:srgbClr val="1C2326"/>
-                </a:solidFill>
-                <a:latin typeface="Arial" pitchFamily="34" charset="0"/>
-                <a:ea typeface="Arial" pitchFamily="34" charset="-122"/>
-                <a:cs typeface="Arial" pitchFamily="34" charset="-120"/>
-              </a:rPr>
-              <a:t>Schwyz</a:t>
-            </a:r>
-            <a:endParaRPr lang="en-US" sz="1100" dirty="0"/>
-          </a:p>
-        </p:txBody>
-      </p:sp>
-      <p:sp>
-        <p:nvSpPr>
-          <p:cNvPr id="30" name="Text 28"/>
-          <p:cNvSpPr txBox="1"/>
-          <p:nvPr/>
-        </p:nvSpPr>
-        <p:spPr>
-          <a:xfrm>
-            <a:off x="6835140" y="4041648"/>
-            <a:ext cx="1737360" cy="530352"/>
-          </a:xfrm>
-          <a:prstGeom prst="rect">
-            <a:avLst/>
-          </a:prstGeom>
-          <a:noFill/>
-          <a:ln/>
-        </p:spPr>
-        <p:txBody>
-          <a:bodyPr wrap="square" lIns="0" tIns="0" rIns="0" bIns="0" rtlCol="0" anchor="t"/>
-          <a:lstStyle/>
-          <a:p>
-            <a:pPr indent="0" marL="0">
-              <a:buNone/>
-            </a:pPr>
-            <a:r>
-              <a:rPr lang="en-US" sz="850" dirty="0">
-                <a:solidFill>
-                  <a:srgbClr val="1C2326"/>
-                </a:solidFill>
-                <a:latin typeface="Arial" pitchFamily="34" charset="0"/>
-                <a:ea typeface="Arial" pitchFamily="34" charset="-122"/>
-                <a:cs typeface="Arial" pitchFamily="34" charset="-120"/>
-              </a:rPr>
-              <a:t>Nur Bundesrecht. Mieten +10,5 % in einem Jahr.</a:t>
-            </a:r>
-            <a:endParaRPr lang="en-US" sz="850" dirty="0"/>
+              <a:rPr lang="en-US" sz="750" dirty="0">
+                <a:solidFill>
+                  <a:srgbClr val="5B6468"/>
+                </a:solidFill>
+                <a:latin typeface="Arial" pitchFamily="34" charset="0"/>
+                <a:ea typeface="Arial" pitchFamily="34" charset="-122"/>
+                <a:cs typeface="Arial" pitchFamily="34" charset="-120"/>
+              </a:rPr>
+              <a:t>Rechtslage Bund und Kantone Zürich, Luzern, Zug, Schwyz: Reservefolie 6.</a:t>
+            </a:r>
+            <a:endParaRPr lang="en-US" sz="750" dirty="0"/>
           </a:p>
         </p:txBody>
       </p:sp>
@@ -6931,7 +7418,7 @@
                   <a:schemeClr val="tx1"/>
                 </a:solidFill>
               </a:rPr>
-              <a:t>Fünf Parteien, ein Plan. So hält die Rochade rechtlich.</a:t>
+              <a:t>Leerkündigen ist erlaubt, wenn es nicht anders geht. Zürich prüft das jetzt.</a:t>
             </a:r>
             <a:endParaRPr lang="en-US" sz="3000" dirty="0"/>
           </a:p>
@@ -6946,7 +7433,7 @@
         <p:spPr>
           <a:xfrm>
             <a:off x="457200" y="1280160"/>
-            <a:ext cx="4023360" cy="530352"/>
+            <a:ext cx="2651760" cy="2286000"/>
           </a:xfrm>
           <a:prstGeom prst="rect">
             <a:avLst/>
@@ -6964,24 +7451,141 @@
       </p:sp>
       <p:sp>
         <p:nvSpPr>
-          <p:cNvPr id="4" name="Shape 2"/>
+          <p:cNvPr id="4" name="Text 2"/>
+          <p:cNvSpPr txBox="1"/>
+          <p:nvPr/>
+        </p:nvSpPr>
+        <p:spPr>
+          <a:xfrm>
+            <a:off x="640080" y="1371600"/>
+            <a:ext cx="2286000" cy="274320"/>
+          </a:xfrm>
+          <a:prstGeom prst="rect">
+            <a:avLst/>
+          </a:prstGeom>
+          <a:noFill/>
+          <a:ln/>
+        </p:spPr>
+        <p:txBody>
+          <a:bodyPr wrap="square" lIns="0" tIns="0" rIns="0" bIns="0" rtlCol="0" anchor="ctr"/>
+          <a:lstStyle/>
+          <a:p>
+            <a:pPr indent="0" marL="0">
+              <a:buNone/>
+            </a:pPr>
+            <a:r>
+              <a:rPr lang="en-US" sz="900" b="1" dirty="0">
+                <a:solidFill>
+                  <a:srgbClr val="5B6468"/>
+                </a:solidFill>
+                <a:latin typeface="Arial" pitchFamily="34" charset="0"/>
+                <a:ea typeface="Arial" pitchFamily="34" charset="-122"/>
+                <a:cs typeface="Arial" pitchFamily="34" charset="-120"/>
+              </a:rPr>
+              <a:t>Bund · OR 271</a:t>
+            </a:r>
+            <a:endParaRPr lang="en-US" sz="900" dirty="0"/>
+          </a:p>
+        </p:txBody>
+      </p:sp>
+      <p:sp>
+        <p:nvSpPr>
+          <p:cNvPr id="5" name="Text 3"/>
+          <p:cNvSpPr txBox="1"/>
+          <p:nvPr/>
+        </p:nvSpPr>
+        <p:spPr>
+          <a:xfrm>
+            <a:off x="640080" y="1645920"/>
+            <a:ext cx="2286000" cy="640080"/>
+          </a:xfrm>
+          <a:prstGeom prst="rect">
+            <a:avLst/>
+          </a:prstGeom>
+          <a:noFill/>
+          <a:ln/>
+        </p:spPr>
+        <p:txBody>
+          <a:bodyPr wrap="square" lIns="0" tIns="0" rIns="0" bIns="0" rtlCol="0" anchor="t"/>
+          <a:lstStyle/>
+          <a:p>
+            <a:pPr indent="0" marL="0">
+              <a:buNone/>
+            </a:pPr>
+            <a:r>
+              <a:rPr lang="en-US" sz="1600" b="1" dirty="0">
+                <a:solidFill>
+                  <a:srgbClr val="1C2326"/>
+                </a:solidFill>
+                <a:latin typeface="Arial" pitchFamily="34" charset="0"/>
+                <a:ea typeface="Arial" pitchFamily="34" charset="-122"/>
+                <a:cs typeface="Arial" pitchFamily="34" charset="-120"/>
+              </a:rPr>
+              <a:t>Erlaubt, wenn nötig</a:t>
+            </a:r>
+            <a:endParaRPr lang="en-US" sz="1600" dirty="0"/>
+          </a:p>
+        </p:txBody>
+      </p:sp>
+      <p:sp>
+        <p:nvSpPr>
+          <p:cNvPr id="6" name="Text 4"/>
+          <p:cNvSpPr txBox="1"/>
+          <p:nvPr/>
+        </p:nvSpPr>
+        <p:spPr>
+          <a:xfrm>
+            <a:off x="640080" y="2304288"/>
+            <a:ext cx="2286000" cy="1188720"/>
+          </a:xfrm>
+          <a:prstGeom prst="rect">
+            <a:avLst/>
+          </a:prstGeom>
+          <a:noFill/>
+          <a:ln/>
+        </p:spPr>
+        <p:txBody>
+          <a:bodyPr wrap="square" lIns="0" tIns="0" rIns="0" bIns="0" rtlCol="0" anchor="t"/>
+          <a:lstStyle/>
+          <a:p>
+            <a:pPr indent="0" marL="0">
+              <a:buNone/>
+            </a:pPr>
+            <a:r>
+              <a:rPr lang="en-US" sz="1000" dirty="0">
+                <a:solidFill>
+                  <a:srgbClr val="1C2326"/>
+                </a:solidFill>
+                <a:latin typeface="Arial" pitchFamily="34" charset="0"/>
+                <a:ea typeface="Arial" pitchFamily="34" charset="-122"/>
+                <a:cs typeface="Arial" pitchFamily="34" charset="-120"/>
+              </a:rPr>
+              <a:t>Eine Sanierungskündigung hält, wenn der Verbleib der Mietenden die Arbeiten erheblich erschwert (BGE 135 III 112). Geht es bewohnt oder in Etappen, ist sie anfechtbar. Erstreckung bis 4 Jahre.</a:t>
+            </a:r>
+            <a:endParaRPr lang="en-US" sz="1000" dirty="0"/>
+          </a:p>
+        </p:txBody>
+      </p:sp>
+      <p:sp>
+        <p:nvSpPr>
+          <p:cNvPr id="7" name="Shape 5"/>
           <p:cNvSpPr/>
           <p:nvPr/>
         </p:nvSpPr>
         <p:spPr>
           <a:xfrm>
-            <a:off x="457200" y="1280160"/>
-            <a:ext cx="64008" cy="530352"/>
+            <a:off x="3246120" y="1280160"/>
+            <a:ext cx="2651760" cy="2286000"/>
           </a:xfrm>
           <a:prstGeom prst="rect">
             <a:avLst/>
           </a:prstGeom>
           <a:solidFill>
-            <a:srgbClr val="24414A"/>
+            <a:srgbClr val="FDEBDD"/>
           </a:solidFill>
-          <a:ln w="12700">
+          <a:ln w="9525">
             <a:solidFill>
-              <a:srgbClr val="24414A"/>
+              <a:srgbClr val="FDEBDD"/>
             </a:solidFill>
             <a:prstDash val="solid"/>
           </a:ln>
@@ -6989,14 +7593,14 @@
       </p:sp>
       <p:sp>
         <p:nvSpPr>
-          <p:cNvPr id="5" name="Text 3"/>
-          <p:cNvSpPr txBox="1"/>
-          <p:nvPr/>
-        </p:nvSpPr>
-        <p:spPr>
-          <a:xfrm>
-            <a:off x="658368" y="1280160"/>
-            <a:ext cx="1234440" cy="530352"/>
+          <p:cNvPr id="8" name="Text 6"/>
+          <p:cNvSpPr txBox="1"/>
+          <p:nvPr/>
+        </p:nvSpPr>
+        <p:spPr>
+          <a:xfrm>
+            <a:off x="3429000" y="1371600"/>
+            <a:ext cx="2286000" cy="274320"/>
           </a:xfrm>
           <a:prstGeom prst="rect">
             <a:avLst/>
@@ -7012,7 +7616,85 @@
               <a:buNone/>
             </a:pPr>
             <a:r>
-              <a:rPr lang="en-US" sz="1100" b="1" dirty="0">
+              <a:rPr lang="en-US" sz="900" b="1" dirty="0">
+                <a:solidFill>
+                  <a:srgbClr val="5B6468"/>
+                </a:solidFill>
+                <a:latin typeface="Arial" pitchFamily="34" charset="0"/>
+                <a:ea typeface="Arial" pitchFamily="34" charset="-122"/>
+                <a:cs typeface="Arial" pitchFamily="34" charset="-120"/>
+              </a:rPr>
+              <a:t>Kanton Zürich · WBFG, Ja 54,3 % am 14.6.2026</a:t>
+            </a:r>
+            <a:endParaRPr lang="en-US" sz="900" dirty="0"/>
+          </a:p>
+        </p:txBody>
+      </p:sp>
+      <p:sp>
+        <p:nvSpPr>
+          <p:cNvPr id="9" name="Text 7"/>
+          <p:cNvSpPr txBox="1"/>
+          <p:nvPr/>
+        </p:nvSpPr>
+        <p:spPr>
+          <a:xfrm>
+            <a:off x="3429000" y="1645920"/>
+            <a:ext cx="2286000" cy="640080"/>
+          </a:xfrm>
+          <a:prstGeom prst="rect">
+            <a:avLst/>
+          </a:prstGeom>
+          <a:noFill/>
+          <a:ln/>
+        </p:spPr>
+        <p:txBody>
+          <a:bodyPr wrap="square" lIns="0" tIns="0" rIns="0" bIns="0" rtlCol="0" anchor="t"/>
+          <a:lstStyle/>
+          <a:p>
+            <a:pPr indent="0" marL="0">
+              <a:buNone/>
+            </a:pPr>
+            <a:r>
+              <a:rPr lang="en-US" sz="1600" b="1" dirty="0">
+                <a:solidFill>
+                  <a:srgbClr val="B8460E"/>
+                </a:solidFill>
+                <a:latin typeface="Arial" pitchFamily="34" charset="0"/>
+                <a:ea typeface="Arial" pitchFamily="34" charset="-122"/>
+                <a:cs typeface="Arial" pitchFamily="34" charset="-120"/>
+              </a:rPr>
+              <a:t>Prüfpflicht ab 20 Mietverhältnissen</a:t>
+            </a:r>
+            <a:endParaRPr lang="en-US" sz="1600" dirty="0"/>
+          </a:p>
+        </p:txBody>
+      </p:sp>
+      <p:sp>
+        <p:nvSpPr>
+          <p:cNvPr id="10" name="Text 8"/>
+          <p:cNvSpPr txBox="1"/>
+          <p:nvPr/>
+        </p:nvSpPr>
+        <p:spPr>
+          <a:xfrm>
+            <a:off x="3429000" y="2304288"/>
+            <a:ext cx="2286000" cy="1188720"/>
+          </a:xfrm>
+          <a:prstGeom prst="rect">
+            <a:avLst/>
+          </a:prstGeom>
+          <a:noFill/>
+          <a:ln/>
+        </p:spPr>
+        <p:txBody>
+          <a:bodyPr wrap="square" lIns="0" tIns="0" rIns="0" bIns="0" rtlCol="0" anchor="t"/>
+          <a:lstStyle/>
+          <a:p>
+            <a:pPr indent="0" marL="0">
+              <a:buNone/>
+            </a:pPr>
+            <a:r>
+              <a:rPr lang="en-US" sz="1000" dirty="0">
                 <a:solidFill>
                   <a:srgbClr val="1C2326"/>
                 </a:solidFill>
@@ -7020,22 +7702,47 @@
                 <a:ea typeface="Arial" pitchFamily="34" charset="-122"/>
                 <a:cs typeface="Arial" pitchFamily="34" charset="-120"/>
               </a:rPr>
-              <a:t>Eigentümerschaft</a:t>
-            </a:r>
-            <a:endParaRPr lang="en-US" sz="1100" dirty="0"/>
-          </a:p>
-        </p:txBody>
-      </p:sp>
-      <p:sp>
-        <p:nvSpPr>
-          <p:cNvPr id="6" name="Text 4"/>
-          <p:cNvSpPr txBox="1"/>
-          <p:nvPr/>
-        </p:nvSpPr>
-        <p:spPr>
-          <a:xfrm>
-            <a:off x="1892808" y="1280160"/>
-            <a:ext cx="2496312" cy="530352"/>
+              <a:t>Bewohnt oder etappiert sanieren prüfen, 12 Monate Vorlauf, Ansprechperson, Hilfe bei der Wohnungssuche. Sonst keine Baubewilligung. In Kraft frühestens Ende 2026.</a:t>
+            </a:r>
+            <a:endParaRPr lang="en-US" sz="1000" dirty="0"/>
+          </a:p>
+        </p:txBody>
+      </p:sp>
+      <p:sp>
+        <p:nvSpPr>
+          <p:cNvPr id="11" name="Shape 9"/>
+          <p:cNvSpPr/>
+          <p:nvPr/>
+        </p:nvSpPr>
+        <p:spPr>
+          <a:xfrm>
+            <a:off x="6035040" y="1280160"/>
+            <a:ext cx="2651760" cy="2286000"/>
+          </a:xfrm>
+          <a:prstGeom prst="rect">
+            <a:avLst/>
+          </a:prstGeom>
+          <a:solidFill>
+            <a:srgbClr val="E2ECEE"/>
+          </a:solidFill>
+          <a:ln w="9525">
+            <a:solidFill>
+              <a:srgbClr val="E2ECEE"/>
+            </a:solidFill>
+            <a:prstDash val="solid"/>
+          </a:ln>
+        </p:spPr>
+      </p:sp>
+      <p:sp>
+        <p:nvSpPr>
+          <p:cNvPr id="12" name="Text 10"/>
+          <p:cNvSpPr txBox="1"/>
+          <p:nvPr/>
+        </p:nvSpPr>
+        <p:spPr>
+          <a:xfrm>
+            <a:off x="6217920" y="1371600"/>
+            <a:ext cx="2286000" cy="274320"/>
           </a:xfrm>
           <a:prstGeom prst="rect">
             <a:avLst/>
@@ -7051,7 +7758,85 @@
               <a:buNone/>
             </a:pPr>
             <a:r>
-              <a:rPr lang="en-US" sz="900" dirty="0">
+              <a:rPr lang="en-US" sz="900" b="1" dirty="0">
+                <a:solidFill>
+                  <a:srgbClr val="5B6468"/>
+                </a:solidFill>
+                <a:latin typeface="Arial" pitchFamily="34" charset="0"/>
+                <a:ea typeface="Arial" pitchFamily="34" charset="-122"/>
+                <a:cs typeface="Arial" pitchFamily="34" charset="-120"/>
+              </a:rPr>
+              <a:t>Genossenschaften · OR 846</a:t>
+            </a:r>
+            <a:endParaRPr lang="en-US" sz="900" dirty="0"/>
+          </a:p>
+        </p:txBody>
+      </p:sp>
+      <p:sp>
+        <p:nvSpPr>
+          <p:cNvPr id="13" name="Text 11"/>
+          <p:cNvSpPr txBox="1"/>
+          <p:nvPr/>
+        </p:nvSpPr>
+        <p:spPr>
+          <a:xfrm>
+            <a:off x="6217920" y="1645920"/>
+            <a:ext cx="2286000" cy="640080"/>
+          </a:xfrm>
+          <a:prstGeom prst="rect">
+            <a:avLst/>
+          </a:prstGeom>
+          <a:noFill/>
+          <a:ln/>
+        </p:spPr>
+        <p:txBody>
+          <a:bodyPr wrap="square" lIns="0" tIns="0" rIns="0" bIns="0" rtlCol="0" anchor="t"/>
+          <a:lstStyle/>
+          <a:p>
+            <a:pPr indent="0" marL="0">
+              <a:buNone/>
+            </a:pPr>
+            <a:r>
+              <a:rPr lang="en-US" sz="1600" b="1" dirty="0">
+                <a:solidFill>
+                  <a:srgbClr val="24414A"/>
+                </a:solidFill>
+                <a:latin typeface="Arial" pitchFamily="34" charset="0"/>
+                <a:ea typeface="Arial" pitchFamily="34" charset="-122"/>
+                <a:cs typeface="Arial" pitchFamily="34" charset="-120"/>
+              </a:rPr>
+              <a:t>Sanierung ist kein Kündigungsgrund</a:t>
+            </a:r>
+            <a:endParaRPr lang="en-US" sz="1600" dirty="0"/>
+          </a:p>
+        </p:txBody>
+      </p:sp>
+      <p:sp>
+        <p:nvSpPr>
+          <p:cNvPr id="14" name="Text 12"/>
+          <p:cNvSpPr txBox="1"/>
+          <p:nvPr/>
+        </p:nvSpPr>
+        <p:spPr>
+          <a:xfrm>
+            <a:off x="6217920" y="2304288"/>
+            <a:ext cx="2286000" cy="1188720"/>
+          </a:xfrm>
+          <a:prstGeom prst="rect">
+            <a:avLst/>
+          </a:prstGeom>
+          <a:noFill/>
+          <a:ln/>
+        </p:spPr>
+        <p:txBody>
+          <a:bodyPr wrap="square" lIns="0" tIns="0" rIns="0" bIns="0" rtlCol="0" anchor="t"/>
+          <a:lstStyle/>
+          <a:p>
+            <a:pPr indent="0" marL="0">
+              <a:buNone/>
+            </a:pPr>
+            <a:r>
+              <a:rPr lang="en-US" sz="1000" dirty="0">
                 <a:solidFill>
                   <a:srgbClr val="1C2326"/>
                 </a:solidFill>
@@ -7059,22 +7844,22 @@
                 <a:ea typeface="Arial" pitchFamily="34" charset="-122"/>
                 <a:cs typeface="Arial" pitchFamily="34" charset="-120"/>
               </a:rPr>
-              <a:t>Genossenschaft, Pensionskasse, Stadt. Entscheidet, zahlt, trägt das Reputationsrisiko.</a:t>
-            </a:r>
-            <a:endParaRPr lang="en-US" sz="900" dirty="0"/>
-          </a:p>
-        </p:txBody>
-      </p:sp>
-      <p:sp>
-        <p:nvSpPr>
-          <p:cNvPr id="7" name="Shape 5"/>
+              <a:t>Mitglieder sind Mitbesitzer. Ohne Statutengrundlage kann die Genossenschaft wegen einer Sanierung nicht kündigen. Darum: Rochade oder befristete Zwischenvermietung.</a:t>
+            </a:r>
+            <a:endParaRPr lang="en-US" sz="1000" dirty="0"/>
+          </a:p>
+        </p:txBody>
+      </p:sp>
+      <p:sp>
+        <p:nvSpPr>
+          <p:cNvPr id="15" name="Shape 13"/>
           <p:cNvSpPr/>
           <p:nvPr/>
         </p:nvSpPr>
         <p:spPr>
           <a:xfrm>
-            <a:off x="457200" y="1883664"/>
-            <a:ext cx="4023360" cy="530352"/>
+            <a:off x="457200" y="3703320"/>
+            <a:ext cx="1988820" cy="914400"/>
           </a:xfrm>
           <a:prstGeom prst="rect">
             <a:avLst/>
@@ -7092,24 +7877,24 @@
       </p:sp>
       <p:sp>
         <p:nvSpPr>
-          <p:cNvPr id="8" name="Shape 6"/>
+          <p:cNvPr id="16" name="Shape 14"/>
           <p:cNvSpPr/>
           <p:nvPr/>
         </p:nvSpPr>
         <p:spPr>
           <a:xfrm>
-            <a:off x="457200" y="1883664"/>
-            <a:ext cx="64008" cy="530352"/>
+            <a:off x="594360" y="3831336"/>
+            <a:ext cx="128016" cy="128016"/>
           </a:xfrm>
           <a:prstGeom prst="rect">
             <a:avLst/>
           </a:prstGeom>
           <a:solidFill>
-            <a:srgbClr val="24414A"/>
+            <a:srgbClr val="276B43"/>
           </a:solidFill>
           <a:ln w="12700">
             <a:solidFill>
-              <a:srgbClr val="24414A"/>
+              <a:srgbClr val="276B43"/>
             </a:solidFill>
             <a:prstDash val="solid"/>
           </a:ln>
@@ -7117,14 +7902,14 @@
       </p:sp>
       <p:sp>
         <p:nvSpPr>
-          <p:cNvPr id="9" name="Text 7"/>
-          <p:cNvSpPr txBox="1"/>
-          <p:nvPr/>
-        </p:nvSpPr>
-        <p:spPr>
-          <a:xfrm>
-            <a:off x="658368" y="1883664"/>
-            <a:ext cx="1234440" cy="530352"/>
+          <p:cNvPr id="17" name="Text 15"/>
+          <p:cNvSpPr txBox="1"/>
+          <p:nvPr/>
+        </p:nvSpPr>
+        <p:spPr>
+          <a:xfrm>
+            <a:off x="786384" y="3767328"/>
+            <a:ext cx="1554480" cy="256032"/>
           </a:xfrm>
           <a:prstGeom prst="rect">
             <a:avLst/>
@@ -7148,7 +7933,7 @@
                 <a:ea typeface="Arial" pitchFamily="34" charset="-122"/>
                 <a:cs typeface="Arial" pitchFamily="34" charset="-120"/>
               </a:rPr>
-              <a:t>Bewirtschaftung</a:t>
+              <a:t>Zürich</a:t>
             </a:r>
             <a:endParaRPr lang="en-US" sz="1100" dirty="0"/>
           </a:p>
@@ -7156,30 +7941,30 @@
       </p:sp>
       <p:sp>
         <p:nvSpPr>
-          <p:cNvPr id="10" name="Text 8"/>
-          <p:cNvSpPr txBox="1"/>
-          <p:nvPr/>
-        </p:nvSpPr>
-        <p:spPr>
-          <a:xfrm>
-            <a:off x="1892808" y="1883664"/>
-            <a:ext cx="2496312" cy="530352"/>
-          </a:xfrm>
-          <a:prstGeom prst="rect">
-            <a:avLst/>
-          </a:prstGeom>
-          <a:noFill/>
-          <a:ln/>
-        </p:spPr>
-        <p:txBody>
-          <a:bodyPr wrap="square" lIns="0" tIns="0" rIns="0" bIns="0" rtlCol="0" anchor="ctr"/>
+          <p:cNvPr id="18" name="Text 16"/>
+          <p:cNvSpPr txBox="1"/>
+          <p:nvPr/>
+        </p:nvSpPr>
+        <p:spPr>
+          <a:xfrm>
+            <a:off x="594360" y="4041648"/>
+            <a:ext cx="1737360" cy="530352"/>
+          </a:xfrm>
+          <a:prstGeom prst="rect">
+            <a:avLst/>
+          </a:prstGeom>
+          <a:noFill/>
+          <a:ln/>
+        </p:spPr>
+        <p:txBody>
+          <a:bodyPr wrap="square" lIns="0" tIns="0" rIns="0" bIns="0" rtlCol="0" anchor="t"/>
           <a:lstStyle/>
           <a:p>
             <a:pPr indent="0" marL="0">
               <a:buNone/>
             </a:pPr>
             <a:r>
-              <a:rPr lang="en-US" sz="900" dirty="0">
+              <a:rPr lang="en-US" sz="850" dirty="0">
                 <a:solidFill>
                   <a:srgbClr val="1C2326"/>
                 </a:solidFill>
@@ -7187,22 +7972,22 @@
                 <a:ea typeface="Arial" pitchFamily="34" charset="-122"/>
                 <a:cs typeface="Arial" pitchFamily="34" charset="-120"/>
               </a:rPr>
-              <a:t>Zuteilung, Übergaben, Information. Heute vierfacher Aufwand.</a:t>
-            </a:r>
-            <a:endParaRPr lang="en-US" sz="900" dirty="0"/>
-          </a:p>
-        </p:txBody>
-      </p:sp>
-      <p:sp>
-        <p:nvSpPr>
-          <p:cNvPr id="11" name="Shape 9"/>
+              <a:t>Prüfpflicht neu. Der Nachweis, den ROCHADE liefert.</a:t>
+            </a:r>
+            <a:endParaRPr lang="en-US" sz="850" dirty="0"/>
+          </a:p>
+        </p:txBody>
+      </p:sp>
+      <p:sp>
+        <p:nvSpPr>
+          <p:cNvPr id="19" name="Shape 17"/>
           <p:cNvSpPr/>
           <p:nvPr/>
         </p:nvSpPr>
         <p:spPr>
           <a:xfrm>
-            <a:off x="457200" y="2487168"/>
-            <a:ext cx="4023360" cy="530352"/>
+            <a:off x="2537460" y="3703320"/>
+            <a:ext cx="1988820" cy="914400"/>
           </a:xfrm>
           <a:prstGeom prst="rect">
             <a:avLst/>
@@ -7220,24 +8005,24 @@
       </p:sp>
       <p:sp>
         <p:nvSpPr>
-          <p:cNvPr id="12" name="Shape 10"/>
+          <p:cNvPr id="20" name="Shape 18"/>
           <p:cNvSpPr/>
           <p:nvPr/>
         </p:nvSpPr>
         <p:spPr>
           <a:xfrm>
-            <a:off x="457200" y="2487168"/>
-            <a:ext cx="64008" cy="530352"/>
+            <a:off x="2674620" y="3831336"/>
+            <a:ext cx="128016" cy="128016"/>
           </a:xfrm>
           <a:prstGeom prst="rect">
             <a:avLst/>
           </a:prstGeom>
           <a:solidFill>
-            <a:srgbClr val="24414A"/>
+            <a:srgbClr val="F26A1B"/>
           </a:solidFill>
           <a:ln w="12700">
             <a:solidFill>
-              <a:srgbClr val="24414A"/>
+              <a:srgbClr val="F26A1B"/>
             </a:solidFill>
             <a:prstDash val="solid"/>
           </a:ln>
@@ -7245,14 +8030,14 @@
       </p:sp>
       <p:sp>
         <p:nvSpPr>
-          <p:cNvPr id="13" name="Text 11"/>
-          <p:cNvSpPr txBox="1"/>
-          <p:nvPr/>
-        </p:nvSpPr>
-        <p:spPr>
-          <a:xfrm>
-            <a:off x="658368" y="2487168"/>
-            <a:ext cx="1234440" cy="530352"/>
+          <p:cNvPr id="21" name="Text 19"/>
+          <p:cNvSpPr txBox="1"/>
+          <p:nvPr/>
+        </p:nvSpPr>
+        <p:spPr>
+          <a:xfrm>
+            <a:off x="2866644" y="3767328"/>
+            <a:ext cx="1554480" cy="256032"/>
           </a:xfrm>
           <a:prstGeom prst="rect">
             <a:avLst/>
@@ -7276,7 +8061,7 @@
                 <a:ea typeface="Arial" pitchFamily="34" charset="-122"/>
                 <a:cs typeface="Arial" pitchFamily="34" charset="-120"/>
               </a:rPr>
-              <a:t>Bauleitung</a:t>
+              <a:t>Luzern</a:t>
             </a:r>
             <a:endParaRPr lang="en-US" sz="1100" dirty="0"/>
           </a:p>
@@ -7284,30 +8069,30 @@
       </p:sp>
       <p:sp>
         <p:nvSpPr>
-          <p:cNvPr id="14" name="Text 12"/>
-          <p:cNvSpPr txBox="1"/>
-          <p:nvPr/>
-        </p:nvSpPr>
-        <p:spPr>
-          <a:xfrm>
-            <a:off x="1892808" y="2487168"/>
-            <a:ext cx="2496312" cy="530352"/>
-          </a:xfrm>
-          <a:prstGeom prst="rect">
-            <a:avLst/>
-          </a:prstGeom>
-          <a:noFill/>
-          <a:ln/>
-        </p:spPr>
-        <p:txBody>
-          <a:bodyPr wrap="square" lIns="0" tIns="0" rIns="0" bIns="0" rtlCol="0" anchor="ctr"/>
+          <p:cNvPr id="22" name="Text 20"/>
+          <p:cNvSpPr txBox="1"/>
+          <p:nvPr/>
+        </p:nvSpPr>
+        <p:spPr>
+          <a:xfrm>
+            <a:off x="2674620" y="4041648"/>
+            <a:ext cx="1737360" cy="530352"/>
+          </a:xfrm>
+          <a:prstGeom prst="rect">
+            <a:avLst/>
+          </a:prstGeom>
+          <a:noFill/>
+          <a:ln/>
+        </p:spPr>
+        <p:txBody>
+          <a:bodyPr wrap="square" lIns="0" tIns="0" rIns="0" bIns="0" rtlCol="0" anchor="t"/>
           <a:lstStyle/>
           <a:p>
             <a:pPr indent="0" marL="0">
               <a:buNone/>
             </a:pPr>
             <a:r>
-              <a:rPr lang="en-US" sz="900" dirty="0">
+              <a:rPr lang="en-US" sz="850" dirty="0">
                 <a:solidFill>
                   <a:srgbClr val="1C2326"/>
                 </a:solidFill>
@@ -7315,22 +8100,22 @@
                 <a:ea typeface="Arial" pitchFamily="34" charset="-122"/>
                 <a:cs typeface="Arial" pitchFamily="34" charset="-120"/>
               </a:rPr>
-              <a:t>Braucht leere Etappen zum Termin. Verzug kostet.</a:t>
-            </a:r>
-            <a:endParaRPr lang="en-US" sz="900" dirty="0"/>
-          </a:p>
-        </p:txBody>
-      </p:sp>
-      <p:sp>
-        <p:nvSpPr>
-          <p:cNvPr id="15" name="Shape 13"/>
+              <a:t>Wohnraum-Gesetz umkämpft: Stadt Nein 24:23, Initiative läuft.</a:t>
+            </a:r>
+            <a:endParaRPr lang="en-US" sz="850" dirty="0"/>
+          </a:p>
+        </p:txBody>
+      </p:sp>
+      <p:sp>
+        <p:nvSpPr>
+          <p:cNvPr id="23" name="Shape 21"/>
           <p:cNvSpPr/>
           <p:nvPr/>
         </p:nvSpPr>
         <p:spPr>
           <a:xfrm>
-            <a:off x="457200" y="3090672"/>
-            <a:ext cx="4023360" cy="530352"/>
+            <a:off x="4617720" y="3703320"/>
+            <a:ext cx="1988820" cy="914400"/>
           </a:xfrm>
           <a:prstGeom prst="rect">
             <a:avLst/>
@@ -7348,14 +8133,14 @@
       </p:sp>
       <p:sp>
         <p:nvSpPr>
-          <p:cNvPr id="16" name="Shape 14"/>
+          <p:cNvPr id="24" name="Shape 22"/>
           <p:cNvSpPr/>
           <p:nvPr/>
         </p:nvSpPr>
         <p:spPr>
           <a:xfrm>
-            <a:off x="457200" y="3090672"/>
-            <a:ext cx="64008" cy="530352"/>
+            <a:off x="4754880" y="3831336"/>
+            <a:ext cx="128016" cy="128016"/>
           </a:xfrm>
           <a:prstGeom prst="rect">
             <a:avLst/>
@@ -7373,14 +8158,14 @@
       </p:sp>
       <p:sp>
         <p:nvSpPr>
-          <p:cNvPr id="17" name="Text 15"/>
-          <p:cNvSpPr txBox="1"/>
-          <p:nvPr/>
-        </p:nvSpPr>
-        <p:spPr>
-          <a:xfrm>
-            <a:off x="658368" y="3090672"/>
-            <a:ext cx="1234440" cy="530352"/>
+          <p:cNvPr id="25" name="Text 23"/>
+          <p:cNvSpPr txBox="1"/>
+          <p:nvPr/>
+        </p:nvSpPr>
+        <p:spPr>
+          <a:xfrm>
+            <a:off x="4946904" y="3767328"/>
+            <a:ext cx="1554480" cy="256032"/>
           </a:xfrm>
           <a:prstGeom prst="rect">
             <a:avLst/>
@@ -7404,7 +8189,7 @@
                 <a:ea typeface="Arial" pitchFamily="34" charset="-122"/>
                 <a:cs typeface="Arial" pitchFamily="34" charset="-120"/>
               </a:rPr>
-              <a:t>Mietende</a:t>
+              <a:t>Zug</a:t>
             </a:r>
             <a:endParaRPr lang="en-US" sz="1100" dirty="0"/>
           </a:p>
@@ -7412,30 +8197,30 @@
       </p:sp>
       <p:sp>
         <p:nvSpPr>
-          <p:cNvPr id="18" name="Text 16"/>
-          <p:cNvSpPr txBox="1"/>
-          <p:nvPr/>
-        </p:nvSpPr>
-        <p:spPr>
-          <a:xfrm>
-            <a:off x="1892808" y="3090672"/>
-            <a:ext cx="2496312" cy="530352"/>
-          </a:xfrm>
-          <a:prstGeom prst="rect">
-            <a:avLst/>
-          </a:prstGeom>
-          <a:noFill/>
-          <a:ln/>
-        </p:spPr>
-        <p:txBody>
-          <a:bodyPr wrap="square" lIns="0" tIns="0" rIns="0" bIns="0" rtlCol="0" anchor="ctr"/>
+          <p:cNvPr id="26" name="Text 24"/>
+          <p:cNvSpPr txBox="1"/>
+          <p:nvPr/>
+        </p:nvSpPr>
+        <p:spPr>
+          <a:xfrm>
+            <a:off x="4754880" y="4041648"/>
+            <a:ext cx="1737360" cy="530352"/>
+          </a:xfrm>
+          <a:prstGeom prst="rect">
+            <a:avLst/>
+          </a:prstGeom>
+          <a:noFill/>
+          <a:ln/>
+        </p:spPr>
+        <p:txBody>
+          <a:bodyPr wrap="square" lIns="0" tIns="0" rIns="0" bIns="0" rtlCol="0" anchor="t"/>
           <a:lstStyle/>
           <a:p>
             <a:pPr indent="0" marL="0">
               <a:buNone/>
             </a:pPr>
             <a:r>
-              <a:rPr lang="en-US" sz="900" dirty="0">
+              <a:rPr lang="en-US" sz="850" dirty="0">
                 <a:solidFill>
                   <a:srgbClr val="1C2326"/>
                 </a:solidFill>
@@ -7443,22 +8228,22 @@
                 <a:ea typeface="Arial" pitchFamily="34" charset="-122"/>
                 <a:cs typeface="Arial" pitchFamily="34" charset="-120"/>
               </a:rPr>
-              <a:t>Ziehen freiwillig um, brauchen Klarheit. Mieterverband berät.</a:t>
-            </a:r>
-            <a:endParaRPr lang="en-US" sz="900" dirty="0"/>
-          </a:p>
-        </p:txBody>
-      </p:sp>
-      <p:sp>
-        <p:nvSpPr>
-          <p:cNvPr id="19" name="Shape 17"/>
+              <a:t>Kein Gesetz. Herti: Veto, 68 Wohnungen werden bewohnt saniert.</a:t>
+            </a:r>
+            <a:endParaRPr lang="en-US" sz="850" dirty="0"/>
+          </a:p>
+        </p:txBody>
+      </p:sp>
+      <p:sp>
+        <p:nvSpPr>
+          <p:cNvPr id="27" name="Shape 25"/>
           <p:cNvSpPr/>
           <p:nvPr/>
         </p:nvSpPr>
         <p:spPr>
           <a:xfrm>
-            <a:off x="457200" y="3694176"/>
-            <a:ext cx="4023360" cy="530352"/>
+            <a:off x="6697980" y="3703320"/>
+            <a:ext cx="1988820" cy="914400"/>
           </a:xfrm>
           <a:prstGeom prst="rect">
             <a:avLst/>
@@ -7476,24 +8261,24 @@
       </p:sp>
       <p:sp>
         <p:nvSpPr>
-          <p:cNvPr id="20" name="Shape 18"/>
+          <p:cNvPr id="28" name="Shape 26"/>
           <p:cNvSpPr/>
           <p:nvPr/>
         </p:nvSpPr>
         <p:spPr>
           <a:xfrm>
-            <a:off x="457200" y="3694176"/>
-            <a:ext cx="64008" cy="530352"/>
+            <a:off x="6835140" y="3831336"/>
+            <a:ext cx="128016" cy="128016"/>
           </a:xfrm>
           <a:prstGeom prst="rect">
             <a:avLst/>
           </a:prstGeom>
           <a:solidFill>
-            <a:srgbClr val="24414A"/>
+            <a:srgbClr val="8A8178"/>
           </a:solidFill>
           <a:ln w="12700">
             <a:solidFill>
-              <a:srgbClr val="24414A"/>
+              <a:srgbClr val="8A8178"/>
             </a:solidFill>
             <a:prstDash val="solid"/>
           </a:ln>
@@ -7501,14 +8286,14 @@
       </p:sp>
       <p:sp>
         <p:nvSpPr>
-          <p:cNvPr id="21" name="Text 19"/>
-          <p:cNvSpPr txBox="1"/>
-          <p:nvPr/>
-        </p:nvSpPr>
-        <p:spPr>
-          <a:xfrm>
-            <a:off x="658368" y="3694176"/>
-            <a:ext cx="1234440" cy="530352"/>
+          <p:cNvPr id="29" name="Text 27"/>
+          <p:cNvSpPr txBox="1"/>
+          <p:nvPr/>
+        </p:nvSpPr>
+        <p:spPr>
+          <a:xfrm>
+            <a:off x="7027164" y="3767328"/>
+            <a:ext cx="1554480" cy="256032"/>
           </a:xfrm>
           <a:prstGeom prst="rect">
             <a:avLst/>
@@ -7532,7 +8317,7 @@
                 <a:ea typeface="Arial" pitchFamily="34" charset="-122"/>
                 <a:cs typeface="Arial" pitchFamily="34" charset="-120"/>
               </a:rPr>
-              <a:t>Gemeinde</a:t>
+              <a:t>Schwyz</a:t>
             </a:r>
             <a:endParaRPr lang="en-US" sz="1100" dirty="0"/>
           </a:p>
@@ -7540,30 +8325,30 @@
       </p:sp>
       <p:sp>
         <p:nvSpPr>
-          <p:cNvPr id="22" name="Text 20"/>
-          <p:cNvSpPr txBox="1"/>
-          <p:nvPr/>
-        </p:nvSpPr>
-        <p:spPr>
-          <a:xfrm>
-            <a:off x="1892808" y="3694176"/>
-            <a:ext cx="2496312" cy="530352"/>
-          </a:xfrm>
-          <a:prstGeom prst="rect">
-            <a:avLst/>
-          </a:prstGeom>
-          <a:noFill/>
-          <a:ln/>
-        </p:spPr>
-        <p:txBody>
-          <a:bodyPr wrap="square" lIns="0" tIns="0" rIns="0" bIns="0" rtlCol="0" anchor="ctr"/>
+          <p:cNvPr id="30" name="Text 28"/>
+          <p:cNvSpPr txBox="1"/>
+          <p:nvPr/>
+        </p:nvSpPr>
+        <p:spPr>
+          <a:xfrm>
+            <a:off x="6835140" y="4041648"/>
+            <a:ext cx="1737360" cy="530352"/>
+          </a:xfrm>
+          <a:prstGeom prst="rect">
+            <a:avLst/>
+          </a:prstGeom>
+          <a:noFill/>
+          <a:ln/>
+        </p:spPr>
+        <p:txBody>
+          <a:bodyPr wrap="square" lIns="0" tIns="0" rIns="0" bIns="0" rtlCol="0" anchor="t"/>
           <a:lstStyle/>
           <a:p>
             <a:pPr indent="0" marL="0">
               <a:buNone/>
             </a:pPr>
             <a:r>
-              <a:rPr lang="en-US" sz="900" dirty="0">
+              <a:rPr lang="en-US" sz="850" dirty="0">
                 <a:solidFill>
                   <a:srgbClr val="1C2326"/>
                 </a:solidFill>
@@ -7571,641 +8356,9 @@
                 <a:ea typeface="Arial" pitchFamily="34" charset="-122"/>
                 <a:cs typeface="Arial" pitchFamily="34" charset="-120"/>
               </a:rPr>
-              <a:t>Erteilt die Baubewilligung. Zürich prüft neu den Nachweis.</a:t>
-            </a:r>
-            <a:endParaRPr lang="en-US" sz="900" dirty="0"/>
-          </a:p>
-        </p:txBody>
-      </p:sp>
-      <p:sp>
-        <p:nvSpPr>
-          <p:cNvPr id="23" name="Shape 21"/>
-          <p:cNvSpPr/>
-          <p:nvPr/>
-        </p:nvSpPr>
-        <p:spPr>
-          <a:xfrm>
-            <a:off x="4663440" y="1280160"/>
-            <a:ext cx="4023360" cy="3291840"/>
-          </a:xfrm>
-          <a:prstGeom prst="rect">
-            <a:avLst/>
-          </a:prstGeom>
-          <a:solidFill>
-            <a:srgbClr val="24414A"/>
-          </a:solidFill>
-          <a:ln w="12700">
-            <a:solidFill>
-              <a:srgbClr val="24414A"/>
-            </a:solidFill>
-            <a:prstDash val="solid"/>
-          </a:ln>
-        </p:spPr>
-      </p:sp>
-      <p:sp>
-        <p:nvSpPr>
-          <p:cNvPr id="24" name="Text 22"/>
-          <p:cNvSpPr txBox="1"/>
-          <p:nvPr/>
-        </p:nvSpPr>
-        <p:spPr>
-          <a:xfrm>
-            <a:off x="4892040" y="1371600"/>
-            <a:ext cx="3566160" cy="274320"/>
-          </a:xfrm>
-          <a:prstGeom prst="rect">
-            <a:avLst/>
-          </a:prstGeom>
-          <a:noFill/>
-          <a:ln/>
-        </p:spPr>
-        <p:txBody>
-          <a:bodyPr wrap="square" lIns="0" tIns="0" rIns="0" bIns="0" rtlCol="0" anchor="ctr"/>
-          <a:lstStyle/>
-          <a:p>
-            <a:pPr indent="0" marL="0">
-              <a:buNone/>
-            </a:pPr>
-            <a:r>
-              <a:rPr lang="en-US" sz="1100" b="1" dirty="0">
-                <a:solidFill>
-                  <a:srgbClr val="B5C9CE"/>
-                </a:solidFill>
-                <a:latin typeface="Arial" pitchFamily="34" charset="0"/>
-                <a:ea typeface="Arial" pitchFamily="34" charset="-122"/>
-                <a:cs typeface="Arial" pitchFamily="34" charset="-120"/>
-              </a:rPr>
-              <a:t>So hält die Rochade</a:t>
-            </a:r>
-            <a:endParaRPr lang="en-US" sz="1100" dirty="0"/>
-          </a:p>
-        </p:txBody>
-      </p:sp>
-      <p:sp>
-        <p:nvSpPr>
-          <p:cNvPr id="25" name="Shape 23"/>
-          <p:cNvSpPr/>
-          <p:nvPr/>
-        </p:nvSpPr>
-        <p:spPr>
-          <a:xfrm>
-            <a:off x="4892040" y="1755648"/>
-            <a:ext cx="310896" cy="310896"/>
-          </a:xfrm>
-          <a:prstGeom prst="rect">
-            <a:avLst/>
-          </a:prstGeom>
-          <a:solidFill>
-            <a:srgbClr val="F26A1B"/>
-          </a:solidFill>
-          <a:ln w="12700">
-            <a:solidFill>
-              <a:srgbClr val="F26A1B"/>
-            </a:solidFill>
-            <a:prstDash val="solid"/>
-          </a:ln>
-        </p:spPr>
-      </p:sp>
-      <p:sp>
-        <p:nvSpPr>
-          <p:cNvPr id="26" name="Text 24"/>
-          <p:cNvSpPr txBox="1"/>
-          <p:nvPr/>
-        </p:nvSpPr>
-        <p:spPr>
-          <a:xfrm>
-            <a:off x="4892040" y="1755648"/>
-            <a:ext cx="310896" cy="310896"/>
-          </a:xfrm>
-          <a:prstGeom prst="rect">
-            <a:avLst/>
-          </a:prstGeom>
-          <a:noFill/>
-          <a:ln/>
-        </p:spPr>
-        <p:txBody>
-          <a:bodyPr wrap="square" lIns="0" tIns="0" rIns="0" bIns="0" rtlCol="0" anchor="ctr"/>
-          <a:lstStyle/>
-          <a:p>
-            <a:pPr algn="ctr" indent="0" marL="0">
-              <a:buNone/>
-            </a:pPr>
-            <a:r>
-              <a:rPr lang="en-US" sz="1100" b="1" dirty="0">
-                <a:solidFill>
-                  <a:srgbClr val="FFFFFF"/>
-                </a:solidFill>
-                <a:latin typeface="Arial" pitchFamily="34" charset="0"/>
-                <a:ea typeface="Arial" pitchFamily="34" charset="-122"/>
-                <a:cs typeface="Arial" pitchFamily="34" charset="-120"/>
-              </a:rPr>
-              <a:t>1</a:t>
-            </a:r>
-            <a:endParaRPr lang="en-US" sz="1100" dirty="0"/>
-          </a:p>
-        </p:txBody>
-      </p:sp>
-      <p:sp>
-        <p:nvSpPr>
-          <p:cNvPr id="27" name="Text 25"/>
-          <p:cNvSpPr txBox="1"/>
-          <p:nvPr/>
-        </p:nvSpPr>
-        <p:spPr>
-          <a:xfrm>
-            <a:off x="5321808" y="1719072"/>
-            <a:ext cx="3200400" cy="274320"/>
-          </a:xfrm>
-          <a:prstGeom prst="rect">
-            <a:avLst/>
-          </a:prstGeom>
-          <a:noFill/>
-          <a:ln/>
-        </p:spPr>
-        <p:txBody>
-          <a:bodyPr wrap="square" lIns="0" tIns="0" rIns="0" bIns="0" rtlCol="0" anchor="ctr"/>
-          <a:lstStyle/>
-          <a:p>
-            <a:pPr indent="0" marL="0">
-              <a:buNone/>
-            </a:pPr>
-            <a:r>
-              <a:rPr lang="en-US" sz="1200" b="1" dirty="0">
-                <a:solidFill>
-                  <a:srgbClr val="FFFFFF"/>
-                </a:solidFill>
-                <a:latin typeface="Arial" pitchFamily="34" charset="0"/>
-                <a:ea typeface="Arial" pitchFamily="34" charset="-122"/>
-                <a:cs typeface="Arial" pitchFamily="34" charset="-120"/>
-              </a:rPr>
-              <a:t>Der Mietvertrag bleibt.</a:t>
-            </a:r>
-            <a:endParaRPr lang="en-US" sz="1200" dirty="0"/>
-          </a:p>
-        </p:txBody>
-      </p:sp>
-      <p:sp>
-        <p:nvSpPr>
-          <p:cNvPr id="28" name="Text 26"/>
-          <p:cNvSpPr txBox="1"/>
-          <p:nvPr/>
-        </p:nvSpPr>
-        <p:spPr>
-          <a:xfrm>
-            <a:off x="5321808" y="1993392"/>
-            <a:ext cx="3200400" cy="384048"/>
-          </a:xfrm>
-          <a:prstGeom prst="rect">
-            <a:avLst/>
-          </a:prstGeom>
-          <a:noFill/>
-          <a:ln/>
-        </p:spPr>
-        <p:txBody>
-          <a:bodyPr wrap="square" lIns="0" tIns="0" rIns="0" bIns="0" rtlCol="0" anchor="t"/>
-          <a:lstStyle/>
-          <a:p>
-            <a:pPr indent="0" marL="0">
-              <a:buNone/>
-            </a:pPr>
-            <a:r>
-              <a:rPr lang="en-US" sz="900" dirty="0">
-                <a:solidFill>
-                  <a:srgbClr val="D4E1E5"/>
-                </a:solidFill>
-                <a:latin typeface="Arial" pitchFamily="34" charset="0"/>
-                <a:ea typeface="Arial" pitchFamily="34" charset="-122"/>
-                <a:cs typeface="Arial" pitchFamily="34" charset="-120"/>
-              </a:rPr>
-              <a:t>Keine Kündigung, keine Anfechtung, keine Erstreckung.</a:t>
-            </a:r>
-            <a:endParaRPr lang="en-US" sz="900" dirty="0"/>
-          </a:p>
-        </p:txBody>
-      </p:sp>
-      <p:sp>
-        <p:nvSpPr>
-          <p:cNvPr id="29" name="Shape 27"/>
-          <p:cNvSpPr/>
-          <p:nvPr/>
-        </p:nvSpPr>
-        <p:spPr>
-          <a:xfrm>
-            <a:off x="4892040" y="2450592"/>
-            <a:ext cx="310896" cy="310896"/>
-          </a:xfrm>
-          <a:prstGeom prst="rect">
-            <a:avLst/>
-          </a:prstGeom>
-          <a:solidFill>
-            <a:srgbClr val="F26A1B"/>
-          </a:solidFill>
-          <a:ln w="12700">
-            <a:solidFill>
-              <a:srgbClr val="F26A1B"/>
-            </a:solidFill>
-            <a:prstDash val="solid"/>
-          </a:ln>
-        </p:spPr>
-      </p:sp>
-      <p:sp>
-        <p:nvSpPr>
-          <p:cNvPr id="30" name="Text 28"/>
-          <p:cNvSpPr txBox="1"/>
-          <p:nvPr/>
-        </p:nvSpPr>
-        <p:spPr>
-          <a:xfrm>
-            <a:off x="4892040" y="2450592"/>
-            <a:ext cx="310896" cy="310896"/>
-          </a:xfrm>
-          <a:prstGeom prst="rect">
-            <a:avLst/>
-          </a:prstGeom>
-          <a:noFill/>
-          <a:ln/>
-        </p:spPr>
-        <p:txBody>
-          <a:bodyPr wrap="square" lIns="0" tIns="0" rIns="0" bIns="0" rtlCol="0" anchor="ctr"/>
-          <a:lstStyle/>
-          <a:p>
-            <a:pPr algn="ctr" indent="0" marL="0">
-              <a:buNone/>
-            </a:pPr>
-            <a:r>
-              <a:rPr lang="en-US" sz="1100" b="1" dirty="0">
-                <a:solidFill>
-                  <a:srgbClr val="FFFFFF"/>
-                </a:solidFill>
-                <a:latin typeface="Arial" pitchFamily="34" charset="0"/>
-                <a:ea typeface="Arial" pitchFamily="34" charset="-122"/>
-                <a:cs typeface="Arial" pitchFamily="34" charset="-120"/>
-              </a:rPr>
-              <a:t>2</a:t>
-            </a:r>
-            <a:endParaRPr lang="en-US" sz="1100" dirty="0"/>
-          </a:p>
-        </p:txBody>
-      </p:sp>
-      <p:sp>
-        <p:nvSpPr>
-          <p:cNvPr id="31" name="Text 29"/>
-          <p:cNvSpPr txBox="1"/>
-          <p:nvPr/>
-        </p:nvSpPr>
-        <p:spPr>
-          <a:xfrm>
-            <a:off x="5321808" y="2414016"/>
-            <a:ext cx="3200400" cy="274320"/>
-          </a:xfrm>
-          <a:prstGeom prst="rect">
-            <a:avLst/>
-          </a:prstGeom>
-          <a:noFill/>
-          <a:ln/>
-        </p:spPr>
-        <p:txBody>
-          <a:bodyPr wrap="square" lIns="0" tIns="0" rIns="0" bIns="0" rtlCol="0" anchor="ctr"/>
-          <a:lstStyle/>
-          <a:p>
-            <a:pPr indent="0" marL="0">
-              <a:buNone/>
-            </a:pPr>
-            <a:r>
-              <a:rPr lang="en-US" sz="1200" b="1" dirty="0">
-                <a:solidFill>
-                  <a:srgbClr val="FFFFFF"/>
-                </a:solidFill>
-                <a:latin typeface="Arial" pitchFamily="34" charset="0"/>
-                <a:ea typeface="Arial" pitchFamily="34" charset="-122"/>
-                <a:cs typeface="Arial" pitchFamily="34" charset="-120"/>
-              </a:rPr>
-              <a:t>Rochade-Vereinbarung.</a:t>
-            </a:r>
-            <a:endParaRPr lang="en-US" sz="1200" dirty="0"/>
-          </a:p>
-        </p:txBody>
-      </p:sp>
-      <p:sp>
-        <p:nvSpPr>
-          <p:cNvPr id="32" name="Text 30"/>
-          <p:cNvSpPr txBox="1"/>
-          <p:nvPr/>
-        </p:nvSpPr>
-        <p:spPr>
-          <a:xfrm>
-            <a:off x="5321808" y="2688336"/>
-            <a:ext cx="3200400" cy="384048"/>
-          </a:xfrm>
-          <a:prstGeom prst="rect">
-            <a:avLst/>
-          </a:prstGeom>
-          <a:noFill/>
-          <a:ln/>
-        </p:spPr>
-        <p:txBody>
-          <a:bodyPr wrap="square" lIns="0" tIns="0" rIns="0" bIns="0" rtlCol="0" anchor="t"/>
-          <a:lstStyle/>
-          <a:p>
-            <a:pPr indent="0" marL="0">
-              <a:buNone/>
-            </a:pPr>
-            <a:r>
-              <a:rPr lang="en-US" sz="900" dirty="0">
-                <a:solidFill>
-                  <a:srgbClr val="D4E1E5"/>
-                </a:solidFill>
-                <a:latin typeface="Arial" pitchFamily="34" charset="0"/>
-                <a:ea typeface="Arial" pitchFamily="34" charset="-122"/>
-                <a:cs typeface="Arial" pitchFamily="34" charset="-120"/>
-              </a:rPr>
-              <a:t>Ausweichwohnung befristet (OR 255), Termine, Umzugskosten, Rückkehr schriftlich.</a:t>
-            </a:r>
-            <a:endParaRPr lang="en-US" sz="900" dirty="0"/>
-          </a:p>
-        </p:txBody>
-      </p:sp>
-      <p:sp>
-        <p:nvSpPr>
-          <p:cNvPr id="33" name="Shape 31"/>
-          <p:cNvSpPr/>
-          <p:nvPr/>
-        </p:nvSpPr>
-        <p:spPr>
-          <a:xfrm>
-            <a:off x="4892040" y="3145536"/>
-            <a:ext cx="310896" cy="310896"/>
-          </a:xfrm>
-          <a:prstGeom prst="rect">
-            <a:avLst/>
-          </a:prstGeom>
-          <a:solidFill>
-            <a:srgbClr val="F26A1B"/>
-          </a:solidFill>
-          <a:ln w="12700">
-            <a:solidFill>
-              <a:srgbClr val="F26A1B"/>
-            </a:solidFill>
-            <a:prstDash val="solid"/>
-          </a:ln>
-        </p:spPr>
-      </p:sp>
-      <p:sp>
-        <p:nvSpPr>
-          <p:cNvPr id="34" name="Text 32"/>
-          <p:cNvSpPr txBox="1"/>
-          <p:nvPr/>
-        </p:nvSpPr>
-        <p:spPr>
-          <a:xfrm>
-            <a:off x="4892040" y="3145536"/>
-            <a:ext cx="310896" cy="310896"/>
-          </a:xfrm>
-          <a:prstGeom prst="rect">
-            <a:avLst/>
-          </a:prstGeom>
-          <a:noFill/>
-          <a:ln/>
-        </p:spPr>
-        <p:txBody>
-          <a:bodyPr wrap="square" lIns="0" tIns="0" rIns="0" bIns="0" rtlCol="0" anchor="ctr"/>
-          <a:lstStyle/>
-          <a:p>
-            <a:pPr algn="ctr" indent="0" marL="0">
-              <a:buNone/>
-            </a:pPr>
-            <a:r>
-              <a:rPr lang="en-US" sz="1100" b="1" dirty="0">
-                <a:solidFill>
-                  <a:srgbClr val="FFFFFF"/>
-                </a:solidFill>
-                <a:latin typeface="Arial" pitchFamily="34" charset="0"/>
-                <a:ea typeface="Arial" pitchFamily="34" charset="-122"/>
-                <a:cs typeface="Arial" pitchFamily="34" charset="-120"/>
-              </a:rPr>
-              <a:t>3</a:t>
-            </a:r>
-            <a:endParaRPr lang="en-US" sz="1100" dirty="0"/>
-          </a:p>
-        </p:txBody>
-      </p:sp>
-      <p:sp>
-        <p:nvSpPr>
-          <p:cNvPr id="35" name="Text 33"/>
-          <p:cNvSpPr txBox="1"/>
-          <p:nvPr/>
-        </p:nvSpPr>
-        <p:spPr>
-          <a:xfrm>
-            <a:off x="5321808" y="3108960"/>
-            <a:ext cx="3200400" cy="274320"/>
-          </a:xfrm>
-          <a:prstGeom prst="rect">
-            <a:avLst/>
-          </a:prstGeom>
-          <a:noFill/>
-          <a:ln/>
-        </p:spPr>
-        <p:txBody>
-          <a:bodyPr wrap="square" lIns="0" tIns="0" rIns="0" bIns="0" rtlCol="0" anchor="ctr"/>
-          <a:lstStyle/>
-          <a:p>
-            <a:pPr indent="0" marL="0">
-              <a:buNone/>
-            </a:pPr>
-            <a:r>
-              <a:rPr lang="en-US" sz="1200" b="1" dirty="0">
-                <a:solidFill>
-                  <a:srgbClr val="FFFFFF"/>
-                </a:solidFill>
-                <a:latin typeface="Arial" pitchFamily="34" charset="0"/>
-                <a:ea typeface="Arial" pitchFamily="34" charset="-122"/>
-                <a:cs typeface="Arial" pitchFamily="34" charset="-120"/>
-              </a:rPr>
-              <a:t>Gleichwertiges Ersatzangebot.</a:t>
-            </a:r>
-            <a:endParaRPr lang="en-US" sz="1200" dirty="0"/>
-          </a:p>
-        </p:txBody>
-      </p:sp>
-      <p:sp>
-        <p:nvSpPr>
-          <p:cNvPr id="36" name="Text 34"/>
-          <p:cNvSpPr txBox="1"/>
-          <p:nvPr/>
-        </p:nvSpPr>
-        <p:spPr>
-          <a:xfrm>
-            <a:off x="5321808" y="3383280"/>
-            <a:ext cx="3200400" cy="384048"/>
-          </a:xfrm>
-          <a:prstGeom prst="rect">
-            <a:avLst/>
-          </a:prstGeom>
-          <a:noFill/>
-          <a:ln/>
-        </p:spPr>
-        <p:txBody>
-          <a:bodyPr wrap="square" lIns="0" tIns="0" rIns="0" bIns="0" rtlCol="0" anchor="t"/>
-          <a:lstStyle/>
-          <a:p>
-            <a:pPr indent="0" marL="0">
-              <a:buNone/>
-            </a:pPr>
-            <a:r>
-              <a:rPr lang="en-US" sz="900" dirty="0">
-                <a:solidFill>
-                  <a:srgbClr val="D4E1E5"/>
-                </a:solidFill>
-                <a:latin typeface="Arial" pitchFamily="34" charset="0"/>
-                <a:ea typeface="Arial" pitchFamily="34" charset="-122"/>
-                <a:cs typeface="Arial" pitchFamily="34" charset="-120"/>
-              </a:rPr>
-              <a:t>Mängelrechte entfallen weitgehend (OR 259c, Obergericht Zürich 2025).</a:t>
-            </a:r>
-            <a:endParaRPr lang="en-US" sz="900" dirty="0"/>
-          </a:p>
-        </p:txBody>
-      </p:sp>
-      <p:sp>
-        <p:nvSpPr>
-          <p:cNvPr id="37" name="Shape 35"/>
-          <p:cNvSpPr/>
-          <p:nvPr/>
-        </p:nvSpPr>
-        <p:spPr>
-          <a:xfrm>
-            <a:off x="4892040" y="3840480"/>
-            <a:ext cx="310896" cy="310896"/>
-          </a:xfrm>
-          <a:prstGeom prst="rect">
-            <a:avLst/>
-          </a:prstGeom>
-          <a:solidFill>
-            <a:srgbClr val="F26A1B"/>
-          </a:solidFill>
-          <a:ln w="12700">
-            <a:solidFill>
-              <a:srgbClr val="F26A1B"/>
-            </a:solidFill>
-            <a:prstDash val="solid"/>
-          </a:ln>
-        </p:spPr>
-      </p:sp>
-      <p:sp>
-        <p:nvSpPr>
-          <p:cNvPr id="38" name="Text 36"/>
-          <p:cNvSpPr txBox="1"/>
-          <p:nvPr/>
-        </p:nvSpPr>
-        <p:spPr>
-          <a:xfrm>
-            <a:off x="4892040" y="3840480"/>
-            <a:ext cx="310896" cy="310896"/>
-          </a:xfrm>
-          <a:prstGeom prst="rect">
-            <a:avLst/>
-          </a:prstGeom>
-          <a:noFill/>
-          <a:ln/>
-        </p:spPr>
-        <p:txBody>
-          <a:bodyPr wrap="square" lIns="0" tIns="0" rIns="0" bIns="0" rtlCol="0" anchor="ctr"/>
-          <a:lstStyle/>
-          <a:p>
-            <a:pPr algn="ctr" indent="0" marL="0">
-              <a:buNone/>
-            </a:pPr>
-            <a:r>
-              <a:rPr lang="en-US" sz="1100" b="1" dirty="0">
-                <a:solidFill>
-                  <a:srgbClr val="FFFFFF"/>
-                </a:solidFill>
-                <a:latin typeface="Arial" pitchFamily="34" charset="0"/>
-                <a:ea typeface="Arial" pitchFamily="34" charset="-122"/>
-                <a:cs typeface="Arial" pitchFamily="34" charset="-120"/>
-              </a:rPr>
-              <a:t>4</a:t>
-            </a:r>
-            <a:endParaRPr lang="en-US" sz="1100" dirty="0"/>
-          </a:p>
-        </p:txBody>
-      </p:sp>
-      <p:sp>
-        <p:nvSpPr>
-          <p:cNvPr id="39" name="Text 37"/>
-          <p:cNvSpPr txBox="1"/>
-          <p:nvPr/>
-        </p:nvSpPr>
-        <p:spPr>
-          <a:xfrm>
-            <a:off x="5321808" y="3803904"/>
-            <a:ext cx="3200400" cy="274320"/>
-          </a:xfrm>
-          <a:prstGeom prst="rect">
-            <a:avLst/>
-          </a:prstGeom>
-          <a:noFill/>
-          <a:ln/>
-        </p:spPr>
-        <p:txBody>
-          <a:bodyPr wrap="square" lIns="0" tIns="0" rIns="0" bIns="0" rtlCol="0" anchor="ctr"/>
-          <a:lstStyle/>
-          <a:p>
-            <a:pPr indent="0" marL="0">
-              <a:buNone/>
-            </a:pPr>
-            <a:r>
-              <a:rPr lang="en-US" sz="1200" b="1" dirty="0">
-                <a:solidFill>
-                  <a:srgbClr val="FFFFFF"/>
-                </a:solidFill>
-                <a:latin typeface="Arial" pitchFamily="34" charset="0"/>
-                <a:ea typeface="Arial" pitchFamily="34" charset="-122"/>
-                <a:cs typeface="Arial" pitchFamily="34" charset="-120"/>
-              </a:rPr>
-              <a:t>Miete danach.</a:t>
-            </a:r>
-            <a:endParaRPr lang="en-US" sz="1200" dirty="0"/>
-          </a:p>
-        </p:txBody>
-      </p:sp>
-      <p:sp>
-        <p:nvSpPr>
-          <p:cNvPr id="40" name="Text 38"/>
-          <p:cNvSpPr txBox="1"/>
-          <p:nvPr/>
-        </p:nvSpPr>
-        <p:spPr>
-          <a:xfrm>
-            <a:off x="5321808" y="4078224"/>
-            <a:ext cx="3200400" cy="384048"/>
-          </a:xfrm>
-          <a:prstGeom prst="rect">
-            <a:avLst/>
-          </a:prstGeom>
-          <a:noFill/>
-          <a:ln/>
-        </p:spPr>
-        <p:txBody>
-          <a:bodyPr wrap="square" lIns="0" tIns="0" rIns="0" bIns="0" rtlCol="0" anchor="t"/>
-          <a:lstStyle/>
-          <a:p>
-            <a:pPr indent="0" marL="0">
-              <a:buNone/>
-            </a:pPr>
-            <a:r>
-              <a:rPr lang="en-US" sz="900" dirty="0">
-                <a:solidFill>
-                  <a:srgbClr val="D4E1E5"/>
-                </a:solidFill>
-                <a:latin typeface="Arial" pitchFamily="34" charset="0"/>
-                <a:ea typeface="Arial" pitchFamily="34" charset="-122"/>
-                <a:cs typeface="Arial" pitchFamily="34" charset="-120"/>
-              </a:rPr>
-              <a:t>Nur der wertvermehrende Anteil wird überwälzt, 50 bis 70 % bei umfassender Überholung (VMWG 14).</a:t>
-            </a:r>
-            <a:endParaRPr lang="en-US" sz="900" dirty="0"/>
+              <a:t>Nur Bundesrecht. Mieten +10,5 % in einem Jahr.</a:t>
+            </a:r>
+            <a:endParaRPr lang="en-US" sz="850" dirty="0"/>
           </a:p>
         </p:txBody>
       </p:sp>

</xml_diff>